<commit_message>
style: apply dark theme to all 5 training slide decks
Restyle all pptx files from blue (#1E40AF) to dark theme:
- Slide background: #1E40AF / inherited -> #1C1C1C
- Header bar (full-width Rectangle at top): #1E40AF -> #252525
- Callout boxes: #EFF6FF -> #2F2F2F
- Accent text (#93C5FD): -> #DA7756 (orange)
- Subtitle text (#BFDBFE): -> #B8A99A (warm gray)
- Body text on light bg (#1E293B): -> #EEEEEE

Co-Authored-By: Claude Sonnet 4.6 <noreply@anthropic.com>
</commit_message>
<xml_diff>
--- a/00-01_han-ai/training-materials/course01_AI活用知識編.pptx
+++ b/00-01_han-ai/training-materials/course01_AI活用知識編.pptx
@@ -3110,7 +3110,7 @@
     <p:bg>
       <p:bgPr>
         <a:solidFill>
-          <a:srgbClr val="1E40AF"/>
+          <a:srgbClr val="1C1C1C"/>
         </a:solidFill>
         <a:effectLst/>
       </p:bgPr>
@@ -3191,7 +3191,7 @@
             <a:r>
               <a:rPr sz="1300" b="0" i="0">
                 <a:solidFill>
-                  <a:srgbClr val="93C5FD"/>
+                  <a:srgbClr val="DA7756"/>
                 </a:solidFill>
               </a:rPr>
               <a:t>ざつね屋</a:t>
@@ -3225,7 +3225,7 @@
             <a:r>
               <a:rPr sz="1800" b="0" i="0">
                 <a:solidFill>
-                  <a:srgbClr val="BFDBFE"/>
+                  <a:srgbClr val="B8A99A"/>
                 </a:solidFill>
               </a:rPr>
               <a:t>コース ①</a:t>
@@ -3293,7 +3293,7 @@
             <a:r>
               <a:rPr sz="1600" b="0" i="0">
                 <a:solidFill>
-                  <a:srgbClr val="BFDBFE"/>
+                  <a:srgbClr val="B8A99A"/>
                 </a:solidFill>
               </a:rPr>
               <a:t>「何から始めればいいかわからない」を解消する 90分</a:t>
@@ -3327,7 +3327,7 @@
             <a:r>
               <a:rPr sz="1300" b="0" i="0">
                 <a:solidFill>
-                  <a:srgbClr val="93C5FD"/>
+                  <a:srgbClr val="DA7756"/>
                 </a:solidFill>
               </a:rPr>
               <a:t>所要時間：90分　｜　成果物：自社 AI活用マップ</a:t>
@@ -3346,6 +3346,14 @@
 <file path=ppt/slides/slide10.xml><?xml version="1.0" encoding="utf-8"?>
 <p:sld xmlns:a="http://schemas.openxmlformats.org/drawingml/2006/main" xmlns:p="http://schemas.openxmlformats.org/presentationml/2006/main" xmlns:r="http://schemas.openxmlformats.org/officeDocument/2006/relationships">
   <p:cSld>
+    <p:bg>
+      <p:bgPr>
+        <a:solidFill>
+          <a:srgbClr val="1C1C1C"/>
+        </a:solidFill>
+        <a:effectLst/>
+      </p:bgPr>
+    </p:bg>
     <p:spTree>
       <p:nvGrpSpPr>
         <p:cNvPr id="1" name=""/>
@@ -3368,7 +3376,7 @@
             <a:avLst/>
           </a:prstGeom>
           <a:solidFill>
-            <a:srgbClr val="1E40AF"/>
+            <a:srgbClr val="252525"/>
           </a:solidFill>
           <a:ln>
             <a:noFill/>
@@ -3472,7 +3480,7 @@
                   </a:txBody>
                   <a:tcPr>
                     <a:solidFill>
-                      <a:srgbClr val="1E40AF"/>
+                      <a:srgbClr val="1C1C1C"/>
                     </a:solidFill>
                   </a:tcPr>
                 </a:tc>
@@ -3494,7 +3502,7 @@
                   </a:txBody>
                   <a:tcPr>
                     <a:solidFill>
-                      <a:srgbClr val="1E40AF"/>
+                      <a:srgbClr val="1C1C1C"/>
                     </a:solidFill>
                   </a:tcPr>
                 </a:tc>
@@ -3516,7 +3524,7 @@
                   </a:txBody>
                   <a:tcPr>
                     <a:solidFill>
-                      <a:srgbClr val="1E40AF"/>
+                      <a:srgbClr val="1C1C1C"/>
                     </a:solidFill>
                   </a:tcPr>
                 </a:tc>
@@ -3531,7 +3539,7 @@
                       <a:r>
                         <a:rPr sz="1100">
                           <a:solidFill>
-                            <a:srgbClr val="1E293B"/>
+                            <a:srgbClr val="EEEEEE"/>
                           </a:solidFill>
                         </a:rPr>
                         <a:t>社内外コミュニケーション</a:t>
@@ -3549,7 +3557,7 @@
                       <a:r>
                         <a:rPr sz="1100">
                           <a:solidFill>
-                            <a:srgbClr val="1E293B"/>
+                            <a:srgbClr val="EEEEEE"/>
                           </a:solidFill>
                         </a:rPr>
                         <a:t>メール文案・議事録・報告書・マニュアル・顧客対応文</a:t>
@@ -3567,7 +3575,7 @@
                       <a:r>
                         <a:rPr sz="1100">
                           <a:solidFill>
-                            <a:srgbClr val="1E293B"/>
+                            <a:srgbClr val="EEEEEE"/>
                           </a:solidFill>
                         </a:rPr>
                         <a:t>ChatGPT / Gemini / Claude</a:t>
@@ -3587,7 +3595,7 @@
                       <a:r>
                         <a:rPr sz="1100">
                           <a:solidFill>
-                            <a:srgbClr val="1E293B"/>
+                            <a:srgbClr val="EEEEEE"/>
                           </a:solidFill>
                         </a:rPr>
                         <a:t>広報・情報発信</a:t>
@@ -3609,7 +3617,7 @@
                       <a:r>
                         <a:rPr sz="1100">
                           <a:solidFill>
-                            <a:srgbClr val="1E293B"/>
+                            <a:srgbClr val="EEEEEE"/>
                           </a:solidFill>
                         </a:rPr>
                         <a:t>SNS投稿文・チラシ文案・HPテキスト・プレスリリース</a:t>
@@ -3631,7 +3639,7 @@
                       <a:r>
                         <a:rPr sz="1100">
                           <a:solidFill>
-                            <a:srgbClr val="1E293B"/>
+                            <a:srgbClr val="EEEEEE"/>
                           </a:solidFill>
                         </a:rPr>
                         <a:t>ChatGPT / Gemini / Claude</a:t>
@@ -3655,7 +3663,7 @@
                       <a:r>
                         <a:rPr sz="1100">
                           <a:solidFill>
-                            <a:srgbClr val="1E293B"/>
+                            <a:srgbClr val="EEEEEE"/>
                           </a:solidFill>
                         </a:rPr>
                         <a:t>採用</a:t>
@@ -3673,7 +3681,7 @@
                       <a:r>
                         <a:rPr sz="1100">
                           <a:solidFill>
-                            <a:srgbClr val="1E293B"/>
+                            <a:srgbClr val="EEEEEE"/>
                           </a:solidFill>
                         </a:rPr>
                         <a:t>求人票・会社紹介文・面接質問リスト・内定通知文</a:t>
@@ -3691,7 +3699,7 @@
                       <a:r>
                         <a:rPr sz="1100">
                           <a:solidFill>
-                            <a:srgbClr val="1E293B"/>
+                            <a:srgbClr val="EEEEEE"/>
                           </a:solidFill>
                         </a:rPr>
                         <a:t>ChatGPT / Gemini / Claude</a:t>
@@ -3711,7 +3719,7 @@
                       <a:r>
                         <a:rPr sz="1100">
                           <a:solidFill>
-                            <a:srgbClr val="1E293B"/>
+                            <a:srgbClr val="EEEEEE"/>
                           </a:solidFill>
                         </a:rPr>
                         <a:t>営業・提案</a:t>
@@ -3733,7 +3741,7 @@
                       <a:r>
                         <a:rPr sz="1100">
                           <a:solidFill>
-                            <a:srgbClr val="1E293B"/>
+                            <a:srgbClr val="EEEEEE"/>
                           </a:solidFill>
                         </a:rPr>
                         <a:t>提案書たたき台・トークスクリプト・お礼メール</a:t>
@@ -3755,7 +3763,7 @@
                       <a:r>
                         <a:rPr sz="1100">
                           <a:solidFill>
-                            <a:srgbClr val="1E293B"/>
+                            <a:srgbClr val="EEEEEE"/>
                           </a:solidFill>
                         </a:rPr>
                         <a:t>ChatGPT / Gemini / Claude</a:t>
@@ -3779,7 +3787,7 @@
                       <a:r>
                         <a:rPr sz="1100">
                           <a:solidFill>
-                            <a:srgbClr val="1E293B"/>
+                            <a:srgbClr val="EEEEEE"/>
                           </a:solidFill>
                         </a:rPr>
                         <a:t>情報収集・調査</a:t>
@@ -3797,7 +3805,7 @@
                       <a:r>
                         <a:rPr sz="1100">
                           <a:solidFill>
-                            <a:srgbClr val="1E293B"/>
+                            <a:srgbClr val="EEEEEE"/>
                           </a:solidFill>
                         </a:rPr>
                         <a:t>競合調査まとめ・業界トレンド整理・議事録要約</a:t>
@@ -3815,7 +3823,7 @@
                       <a:r>
                         <a:rPr sz="1100">
                           <a:solidFill>
-                            <a:srgbClr val="1E293B"/>
+                            <a:srgbClr val="EEEEEE"/>
                           </a:solidFill>
                         </a:rPr>
                         <a:t>Gemini / ChatGPT / Claude</a:t>
@@ -3835,7 +3843,7 @@
                       <a:r>
                         <a:rPr sz="1100">
                           <a:solidFill>
-                            <a:srgbClr val="1E293B"/>
+                            <a:srgbClr val="EEEEEE"/>
                           </a:solidFill>
                         </a:rPr>
                         <a:t>画像制作</a:t>
@@ -3857,7 +3865,7 @@
                       <a:r>
                         <a:rPr sz="1100">
                           <a:solidFill>
-                            <a:srgbClr val="1E293B"/>
+                            <a:srgbClr val="EEEEEE"/>
                           </a:solidFill>
                         </a:rPr>
                         <a:t>SNS画像・バナー・チラシ・商品イメージ</a:t>
@@ -3879,7 +3887,7 @@
                       <a:r>
                         <a:rPr sz="1100">
                           <a:solidFill>
-                            <a:srgbClr val="1E293B"/>
+                            <a:srgbClr val="EEEEEE"/>
                           </a:solidFill>
                         </a:rPr>
                         <a:t>Canva / ChatGPT / Firefly</a:t>
@@ -3903,7 +3911,7 @@
                       <a:r>
                         <a:rPr sz="1100">
                           <a:solidFill>
-                            <a:srgbClr val="1E293B"/>
+                            <a:srgbClr val="EEEEEE"/>
                           </a:solidFill>
                         </a:rPr>
                         <a:t>動画・映像</a:t>
@@ -3921,7 +3929,7 @@
                       <a:r>
                         <a:rPr sz="1100">
                           <a:solidFill>
-                            <a:srgbClr val="1E293B"/>
+                            <a:srgbClr val="EEEEEE"/>
                           </a:solidFill>
                         </a:rPr>
                         <a:t>SNSショート動画・採用動画・会社紹介動画</a:t>
@@ -3939,7 +3947,7 @@
                       <a:r>
                         <a:rPr sz="1100">
                           <a:solidFill>
-                            <a:srgbClr val="1E293B"/>
+                            <a:srgbClr val="EEEEEE"/>
                           </a:solidFill>
                         </a:rPr>
                         <a:t>CapCut / Canva</a:t>
@@ -3959,7 +3967,7 @@
                       <a:r>
                         <a:rPr sz="1100">
                           <a:solidFill>
-                            <a:srgbClr val="1E293B"/>
+                            <a:srgbClr val="EEEEEE"/>
                           </a:solidFill>
                         </a:rPr>
                         <a:t>業務自動化</a:t>
@@ -3981,7 +3989,7 @@
                       <a:r>
                         <a:rPr sz="1100">
                           <a:solidFill>
-                            <a:srgbClr val="1E293B"/>
+                            <a:srgbClr val="EEEEEE"/>
                           </a:solidFill>
                         </a:rPr>
                         <a:t>CSV整理・ファイル処理・定型作業のスクリプト化</a:t>
@@ -4003,7 +4011,7 @@
                       <a:r>
                         <a:rPr sz="1100">
                           <a:solidFill>
-                            <a:srgbClr val="1E293B"/>
+                            <a:srgbClr val="EEEEEE"/>
                           </a:solidFill>
                         </a:rPr>
                         <a:t>Claude Code</a:t>
@@ -4035,7 +4043,7 @@
     <p:bg>
       <p:bgPr>
         <a:solidFill>
-          <a:srgbClr val="1E40AF"/>
+          <a:srgbClr val="1C1C1C"/>
         </a:solidFill>
         <a:effectLst/>
       </p:bgPr>
@@ -4184,7 +4192,7 @@
             <a:r>
               <a:rPr sz="1400" b="0" i="0">
                 <a:solidFill>
-                  <a:srgbClr val="93C5FD"/>
+                  <a:srgbClr val="DA7756"/>
                 </a:solidFill>
               </a:rPr>
               <a:t>⏱ 10分</a:t>
@@ -4218,7 +4226,7 @@
             <a:r>
               <a:rPr sz="1500" b="0" i="0">
                 <a:solidFill>
-                  <a:srgbClr val="BFDBFE"/>
+                  <a:srgbClr val="B8A99A"/>
                 </a:solidFill>
               </a:rPr>
               <a:t>AIをどの方向に使うかを地図で整理する</a:t>
@@ -4237,6 +4245,14 @@
 <file path=ppt/slides/slide12.xml><?xml version="1.0" encoding="utf-8"?>
 <p:sld xmlns:a="http://schemas.openxmlformats.org/drawingml/2006/main" xmlns:p="http://schemas.openxmlformats.org/presentationml/2006/main" xmlns:r="http://schemas.openxmlformats.org/officeDocument/2006/relationships">
   <p:cSld>
+    <p:bg>
+      <p:bgPr>
+        <a:solidFill>
+          <a:srgbClr val="1C1C1C"/>
+        </a:solidFill>
+        <a:effectLst/>
+      </p:bgPr>
+    </p:bg>
     <p:spTree>
       <p:nvGrpSpPr>
         <p:cNvPr id="1" name=""/>
@@ -4259,7 +4275,7 @@
             <a:avLst/>
           </a:prstGeom>
           <a:solidFill>
-            <a:srgbClr val="1E40AF"/>
+            <a:srgbClr val="252525"/>
           </a:solidFill>
           <a:ln>
             <a:noFill/>
@@ -4422,7 +4438,7 @@
             <a:avLst/>
           </a:prstGeom>
           <a:solidFill>
-            <a:srgbClr val="1E40AF"/>
+            <a:srgbClr val="1C1C1C"/>
           </a:solidFill>
           <a:ln>
             <a:noFill/>
@@ -4476,7 +4492,7 @@
             <a:r>
               <a:rPr sz="1300" b="1" i="0">
                 <a:solidFill>
-                  <a:srgbClr val="1E40AF"/>
+                  <a:srgbClr val="1C1C1C"/>
                 </a:solidFill>
               </a:rPr>
               <a:t>【文書・テキスト】
@@ -4737,6 +4753,14 @@
 <file path=ppt/slides/slide13.xml><?xml version="1.0" encoding="utf-8"?>
 <p:sld xmlns:a="http://schemas.openxmlformats.org/drawingml/2006/main" xmlns:p="http://schemas.openxmlformats.org/presentationml/2006/main" xmlns:r="http://schemas.openxmlformats.org/officeDocument/2006/relationships">
   <p:cSld>
+    <p:bg>
+      <p:bgPr>
+        <a:solidFill>
+          <a:srgbClr val="1C1C1C"/>
+        </a:solidFill>
+        <a:effectLst/>
+      </p:bgPr>
+    </p:bg>
     <p:spTree>
       <p:nvGrpSpPr>
         <p:cNvPr id="1" name=""/>
@@ -4759,7 +4783,7 @@
             <a:avLst/>
           </a:prstGeom>
           <a:solidFill>
-            <a:srgbClr val="1E40AF"/>
+            <a:srgbClr val="252525"/>
           </a:solidFill>
           <a:ln>
             <a:noFill/>
@@ -4864,7 +4888,7 @@
                   </a:txBody>
                   <a:tcPr>
                     <a:solidFill>
-                      <a:srgbClr val="1E40AF"/>
+                      <a:srgbClr val="1C1C1C"/>
                     </a:solidFill>
                   </a:tcPr>
                 </a:tc>
@@ -4886,7 +4910,7 @@
                   </a:txBody>
                   <a:tcPr>
                     <a:solidFill>
-                      <a:srgbClr val="1E40AF"/>
+                      <a:srgbClr val="1C1C1C"/>
                     </a:solidFill>
                   </a:tcPr>
                 </a:tc>
@@ -4908,7 +4932,7 @@
                   </a:txBody>
                   <a:tcPr>
                     <a:solidFill>
-                      <a:srgbClr val="1E40AF"/>
+                      <a:srgbClr val="1C1C1C"/>
                     </a:solidFill>
                   </a:tcPr>
                 </a:tc>
@@ -4930,7 +4954,7 @@
                   </a:txBody>
                   <a:tcPr>
                     <a:solidFill>
-                      <a:srgbClr val="1E40AF"/>
+                      <a:srgbClr val="1C1C1C"/>
                     </a:solidFill>
                   </a:tcPr>
                 </a:tc>
@@ -4945,7 +4969,7 @@
                       <a:r>
                         <a:rPr sz="1100">
                           <a:solidFill>
-                            <a:srgbClr val="1E293B"/>
+                            <a:srgbClr val="EEEEEE"/>
                           </a:solidFill>
                         </a:rPr>
                         <a:t>文書・テキスト</a:t>
@@ -4963,7 +4987,7 @@
                       <a:r>
                         <a:rPr sz="1100">
                           <a:solidFill>
-                            <a:srgbClr val="1E293B"/>
+                            <a:srgbClr val="EEEEEE"/>
                           </a:solidFill>
                         </a:rPr>
                         <a:t>全スタッフ</a:t>
@@ -4981,7 +5005,7 @@
                       <a:r>
                         <a:rPr sz="1100">
                           <a:solidFill>
-                            <a:srgbClr val="1E293B"/>
+                            <a:srgbClr val="EEEEEE"/>
                           </a:solidFill>
                         </a:rPr>
                         <a:t>メール・報告書・広報文</a:t>
@@ -4999,7 +5023,7 @@
                       <a:r>
                         <a:rPr sz="1100">
                           <a:solidFill>
-                            <a:srgbClr val="1E293B"/>
+                            <a:srgbClr val="EEEEEE"/>
                           </a:solidFill>
                         </a:rPr>
                         <a:t>無料で可</a:t>
@@ -5019,7 +5043,7 @@
                       <a:r>
                         <a:rPr sz="1100">
                           <a:solidFill>
-                            <a:srgbClr val="1E293B"/>
+                            <a:srgbClr val="EEEEEE"/>
                           </a:solidFill>
                         </a:rPr>
                         <a:t>画像・ビジュアル</a:t>
@@ -5041,7 +5065,7 @@
                       <a:r>
                         <a:rPr sz="1100">
                           <a:solidFill>
-                            <a:srgbClr val="1E293B"/>
+                            <a:srgbClr val="EEEEEE"/>
                           </a:solidFill>
                         </a:rPr>
                         <a:t>広報・営業・SNS担当</a:t>
@@ -5063,7 +5087,7 @@
                       <a:r>
                         <a:rPr sz="1100">
                           <a:solidFill>
-                            <a:srgbClr val="1E293B"/>
+                            <a:srgbClr val="EEEEEE"/>
                           </a:solidFill>
                         </a:rPr>
                         <a:t>SNS画像・チラシ・バナー</a:t>
@@ -5085,7 +5109,7 @@
                       <a:r>
                         <a:rPr sz="1100">
                           <a:solidFill>
-                            <a:srgbClr val="1E293B"/>
+                            <a:srgbClr val="EEEEEE"/>
                           </a:solidFill>
                         </a:rPr>
                         <a:t>無料で可</a:t>
@@ -5109,7 +5133,7 @@
                       <a:r>
                         <a:rPr sz="1100">
                           <a:solidFill>
-                            <a:srgbClr val="1E293B"/>
+                            <a:srgbClr val="EEEEEE"/>
                           </a:solidFill>
                         </a:rPr>
                         <a:t>動画・映像</a:t>
@@ -5127,7 +5151,7 @@
                       <a:r>
                         <a:rPr sz="1100">
                           <a:solidFill>
-                            <a:srgbClr val="1E293B"/>
+                            <a:srgbClr val="EEEEEE"/>
                           </a:solidFill>
                         </a:rPr>
                         <a:t>広報・採用・SNS担当</a:t>
@@ -5145,7 +5169,7 @@
                       <a:r>
                         <a:rPr sz="1100">
                           <a:solidFill>
-                            <a:srgbClr val="1E293B"/>
+                            <a:srgbClr val="EEEEEE"/>
                           </a:solidFill>
                         </a:rPr>
                         <a:t>SNS動画・採用動画</a:t>
@@ -5163,7 +5187,7 @@
                       <a:r>
                         <a:rPr sz="1100">
                           <a:solidFill>
-                            <a:srgbClr val="1E293B"/>
+                            <a:srgbClr val="EEEEEE"/>
                           </a:solidFill>
                         </a:rPr>
                         <a:t>無料で可</a:t>
@@ -5183,7 +5207,7 @@
                       <a:r>
                         <a:rPr sz="1100">
                           <a:solidFill>
-                            <a:srgbClr val="1E293B"/>
+                            <a:srgbClr val="EEEEEE"/>
                           </a:solidFill>
                         </a:rPr>
                         <a:t>自動化・開発</a:t>
@@ -5205,7 +5229,7 @@
                       <a:r>
                         <a:rPr sz="1100">
                           <a:solidFill>
-                            <a:srgbClr val="1E293B"/>
+                            <a:srgbClr val="EEEEEE"/>
                           </a:solidFill>
                         </a:rPr>
                         <a:t>経営者・業務改善担当</a:t>
@@ -5227,7 +5251,7 @@
                       <a:r>
                         <a:rPr sz="1100">
                           <a:solidFill>
-                            <a:srgbClr val="1E293B"/>
+                            <a:srgbClr val="EEEEEE"/>
                           </a:solidFill>
                         </a:rPr>
                         <a:t>繰り返し作業の自動化</a:t>
@@ -5249,7 +5273,7 @@
                       <a:r>
                         <a:rPr sz="1100">
                           <a:solidFill>
-                            <a:srgbClr val="1E293B"/>
+                            <a:srgbClr val="EEEEEE"/>
                           </a:solidFill>
                         </a:rPr>
                         <a:t>APIキー必要</a:t>
@@ -5312,6 +5336,14 @@
 <file path=ppt/slides/slide14.xml><?xml version="1.0" encoding="utf-8"?>
 <p:sld xmlns:a="http://schemas.openxmlformats.org/drawingml/2006/main" xmlns:p="http://schemas.openxmlformats.org/presentationml/2006/main" xmlns:r="http://schemas.openxmlformats.org/officeDocument/2006/relationships">
   <p:cSld>
+    <p:bg>
+      <p:bgPr>
+        <a:solidFill>
+          <a:srgbClr val="1C1C1C"/>
+        </a:solidFill>
+        <a:effectLst/>
+      </p:bgPr>
+    </p:bg>
     <p:spTree>
       <p:nvGrpSpPr>
         <p:cNvPr id="1" name=""/>
@@ -5334,7 +5366,7 @@
             <a:avLst/>
           </a:prstGeom>
           <a:solidFill>
-            <a:srgbClr val="1E40AF"/>
+            <a:srgbClr val="252525"/>
           </a:solidFill>
           <a:ln>
             <a:noFill/>
@@ -5440,7 +5472,7 @@
                   </a:txBody>
                   <a:tcPr>
                     <a:solidFill>
-                      <a:srgbClr val="1E40AF"/>
+                      <a:srgbClr val="1C1C1C"/>
                     </a:solidFill>
                   </a:tcPr>
                 </a:tc>
@@ -5462,7 +5494,7 @@
                   </a:txBody>
                   <a:tcPr>
                     <a:solidFill>
-                      <a:srgbClr val="1E40AF"/>
+                      <a:srgbClr val="1C1C1C"/>
                     </a:solidFill>
                   </a:tcPr>
                 </a:tc>
@@ -5484,7 +5516,7 @@
                   </a:txBody>
                   <a:tcPr>
                     <a:solidFill>
-                      <a:srgbClr val="1E40AF"/>
+                      <a:srgbClr val="1C1C1C"/>
                     </a:solidFill>
                   </a:tcPr>
                 </a:tc>
@@ -5506,7 +5538,7 @@
                   </a:txBody>
                   <a:tcPr>
                     <a:solidFill>
-                      <a:srgbClr val="1E40AF"/>
+                      <a:srgbClr val="1C1C1C"/>
                     </a:solidFill>
                   </a:tcPr>
                 </a:tc>
@@ -5528,7 +5560,7 @@
                   </a:txBody>
                   <a:tcPr>
                     <a:solidFill>
-                      <a:srgbClr val="1E40AF"/>
+                      <a:srgbClr val="1C1C1C"/>
                     </a:solidFill>
                   </a:tcPr>
                 </a:tc>
@@ -5543,7 +5575,7 @@
                       <a:r>
                         <a:rPr sz="1100">
                           <a:solidFill>
-                            <a:srgbClr val="1E293B"/>
+                            <a:srgbClr val="EEEEEE"/>
                           </a:solidFill>
                         </a:rPr>
                         <a:t>ChatGPT</a:t>
@@ -5561,7 +5593,7 @@
                       <a:r>
                         <a:rPr sz="1100">
                           <a:solidFill>
-                            <a:srgbClr val="1E293B"/>
+                            <a:srgbClr val="EEEEEE"/>
                           </a:solidFill>
                         </a:rPr>
                         <a:t>★☆☆</a:t>
@@ -5579,7 +5611,7 @@
                       <a:r>
                         <a:rPr sz="1100">
                           <a:solidFill>
-                            <a:srgbClr val="1E293B"/>
+                            <a:srgbClr val="EEEEEE"/>
                           </a:solidFill>
                         </a:rPr>
                         <a:t>★☆☆</a:t>
@@ -5597,7 +5629,7 @@
                       <a:r>
                         <a:rPr sz="1100">
                           <a:solidFill>
-                            <a:srgbClr val="1E293B"/>
+                            <a:srgbClr val="EEEEEE"/>
                           </a:solidFill>
                         </a:rPr>
                         <a:t>★☆☆</a:t>
@@ -5615,7 +5647,7 @@
                       <a:r>
                         <a:rPr sz="1100">
                           <a:solidFill>
-                            <a:srgbClr val="1E293B"/>
+                            <a:srgbClr val="EEEEEE"/>
                           </a:solidFill>
                         </a:rPr>
                         <a:t>無料あり／Plus 約3,000円/月</a:t>
@@ -5635,7 +5667,7 @@
                       <a:r>
                         <a:rPr sz="1100">
                           <a:solidFill>
-                            <a:srgbClr val="1E293B"/>
+                            <a:srgbClr val="EEEEEE"/>
                           </a:solidFill>
                         </a:rPr>
                         <a:t>Gemini</a:t>
@@ -5657,7 +5689,7 @@
                       <a:r>
                         <a:rPr sz="1100">
                           <a:solidFill>
-                            <a:srgbClr val="1E293B"/>
+                            <a:srgbClr val="EEEEEE"/>
                           </a:solidFill>
                         </a:rPr>
                         <a:t>★☆☆</a:t>
@@ -5679,7 +5711,7 @@
                       <a:r>
                         <a:rPr sz="1100">
                           <a:solidFill>
-                            <a:srgbClr val="1E293B"/>
+                            <a:srgbClr val="EEEEEE"/>
                           </a:solidFill>
                         </a:rPr>
                         <a:t>★☆☆</a:t>
@@ -5701,7 +5733,7 @@
                       <a:r>
                         <a:rPr sz="1100">
                           <a:solidFill>
-                            <a:srgbClr val="1E293B"/>
+                            <a:srgbClr val="EEEEEE"/>
                           </a:solidFill>
                         </a:rPr>
                         <a:t>★☆☆</a:t>
@@ -5723,7 +5755,7 @@
                       <a:r>
                         <a:rPr sz="1100">
                           <a:solidFill>
-                            <a:srgbClr val="1E293B"/>
+                            <a:srgbClr val="EEEEEE"/>
                           </a:solidFill>
                         </a:rPr>
                         <a:t>無料あり／Advanced 2,900円/月</a:t>
@@ -5747,7 +5779,7 @@
                       <a:r>
                         <a:rPr sz="1100">
                           <a:solidFill>
-                            <a:srgbClr val="1E293B"/>
+                            <a:srgbClr val="EEEEEE"/>
                           </a:solidFill>
                         </a:rPr>
                         <a:t>Microsoft Copilot</a:t>
@@ -5765,7 +5797,7 @@
                       <a:r>
                         <a:rPr sz="1100">
                           <a:solidFill>
-                            <a:srgbClr val="1E293B"/>
+                            <a:srgbClr val="EEEEEE"/>
                           </a:solidFill>
                         </a:rPr>
                         <a:t>★★☆</a:t>
@@ -5783,7 +5815,7 @@
                       <a:r>
                         <a:rPr sz="1100">
                           <a:solidFill>
-                            <a:srgbClr val="1E293B"/>
+                            <a:srgbClr val="EEEEEE"/>
                           </a:solidFill>
                         </a:rPr>
                         <a:t>★☆☆</a:t>
@@ -5801,7 +5833,7 @@
                       <a:r>
                         <a:rPr sz="1100">
                           <a:solidFill>
-                            <a:srgbClr val="1E293B"/>
+                            <a:srgbClr val="EEEEEE"/>
                           </a:solidFill>
                         </a:rPr>
                         <a:t>★☆☆</a:t>
@@ -5819,7 +5851,7 @@
                       <a:r>
                         <a:rPr sz="1100">
                           <a:solidFill>
-                            <a:srgbClr val="1E293B"/>
+                            <a:srgbClr val="EEEEEE"/>
                           </a:solidFill>
                         </a:rPr>
                         <a:t>M365契約前提／Copilot 約4,500円/ユーザー/月</a:t>
@@ -5839,7 +5871,7 @@
                       <a:r>
                         <a:rPr sz="1100">
                           <a:solidFill>
-                            <a:srgbClr val="1E293B"/>
+                            <a:srgbClr val="EEEEEE"/>
                           </a:solidFill>
                         </a:rPr>
                         <a:t>Claude</a:t>
@@ -5861,7 +5893,7 @@
                       <a:r>
                         <a:rPr sz="1100">
                           <a:solidFill>
-                            <a:srgbClr val="1E293B"/>
+                            <a:srgbClr val="EEEEEE"/>
                           </a:solidFill>
                         </a:rPr>
                         <a:t>★☆☆</a:t>
@@ -5883,7 +5915,7 @@
                       <a:r>
                         <a:rPr sz="1100">
                           <a:solidFill>
-                            <a:srgbClr val="1E293B"/>
+                            <a:srgbClr val="EEEEEE"/>
                           </a:solidFill>
                         </a:rPr>
                         <a:t>★☆☆</a:t>
@@ -5905,7 +5937,7 @@
                       <a:r>
                         <a:rPr sz="1100">
                           <a:solidFill>
-                            <a:srgbClr val="1E293B"/>
+                            <a:srgbClr val="EEEEEE"/>
                           </a:solidFill>
                         </a:rPr>
                         <a:t>★☆☆</a:t>
@@ -5927,7 +5959,7 @@
                       <a:r>
                         <a:rPr sz="1100">
                           <a:solidFill>
-                            <a:srgbClr val="1E293B"/>
+                            <a:srgbClr val="EEEEEE"/>
                           </a:solidFill>
                         </a:rPr>
                         <a:t>無料あり／Pro 約3,000円/月</a:t>
@@ -6009,6 +6041,14 @@
 <file path=ppt/slides/slide15.xml><?xml version="1.0" encoding="utf-8"?>
 <p:sld xmlns:a="http://schemas.openxmlformats.org/drawingml/2006/main" xmlns:p="http://schemas.openxmlformats.org/presentationml/2006/main" xmlns:r="http://schemas.openxmlformats.org/officeDocument/2006/relationships">
   <p:cSld>
+    <p:bg>
+      <p:bgPr>
+        <a:solidFill>
+          <a:srgbClr val="1C1C1C"/>
+        </a:solidFill>
+        <a:effectLst/>
+      </p:bgPr>
+    </p:bg>
     <p:spTree>
       <p:nvGrpSpPr>
         <p:cNvPr id="1" name=""/>
@@ -6031,7 +6071,7 @@
             <a:avLst/>
           </a:prstGeom>
           <a:solidFill>
-            <a:srgbClr val="1E40AF"/>
+            <a:srgbClr val="252525"/>
           </a:solidFill>
           <a:ln>
             <a:noFill/>
@@ -6137,7 +6177,7 @@
                   </a:txBody>
                   <a:tcPr>
                     <a:solidFill>
-                      <a:srgbClr val="1E40AF"/>
+                      <a:srgbClr val="1C1C1C"/>
                     </a:solidFill>
                   </a:tcPr>
                 </a:tc>
@@ -6159,7 +6199,7 @@
                   </a:txBody>
                   <a:tcPr>
                     <a:solidFill>
-                      <a:srgbClr val="1E40AF"/>
+                      <a:srgbClr val="1C1C1C"/>
                     </a:solidFill>
                   </a:tcPr>
                 </a:tc>
@@ -6181,7 +6221,7 @@
                   </a:txBody>
                   <a:tcPr>
                     <a:solidFill>
-                      <a:srgbClr val="1E40AF"/>
+                      <a:srgbClr val="1C1C1C"/>
                     </a:solidFill>
                   </a:tcPr>
                 </a:tc>
@@ -6203,7 +6243,7 @@
                   </a:txBody>
                   <a:tcPr>
                     <a:solidFill>
-                      <a:srgbClr val="1E40AF"/>
+                      <a:srgbClr val="1C1C1C"/>
                     </a:solidFill>
                   </a:tcPr>
                 </a:tc>
@@ -6225,7 +6265,7 @@
                   </a:txBody>
                   <a:tcPr>
                     <a:solidFill>
-                      <a:srgbClr val="1E40AF"/>
+                      <a:srgbClr val="1C1C1C"/>
                     </a:solidFill>
                   </a:tcPr>
                 </a:tc>
@@ -6240,7 +6280,7 @@
                       <a:r>
                         <a:rPr sz="1100">
                           <a:solidFill>
-                            <a:srgbClr val="1E293B"/>
+                            <a:srgbClr val="EEEEEE"/>
                           </a:solidFill>
                         </a:rPr>
                         <a:t>Canva（AI機能）</a:t>
@@ -6258,7 +6298,7 @@
                       <a:r>
                         <a:rPr sz="1100">
                           <a:solidFill>
-                            <a:srgbClr val="1E293B"/>
+                            <a:srgbClr val="EEEEEE"/>
                           </a:solidFill>
                         </a:rPr>
                         <a:t>画像</a:t>
@@ -6276,7 +6316,7 @@
                       <a:r>
                         <a:rPr sz="1100">
                           <a:solidFill>
-                            <a:srgbClr val="1E293B"/>
+                            <a:srgbClr val="EEEEEE"/>
                           </a:solidFill>
                         </a:rPr>
                         <a:t>★☆☆</a:t>
@@ -6294,7 +6334,7 @@
                       <a:r>
                         <a:rPr sz="1100">
                           <a:solidFill>
-                            <a:srgbClr val="1E293B"/>
+                            <a:srgbClr val="EEEEEE"/>
                           </a:solidFill>
                         </a:rPr>
                         <a:t>★☆☆</a:t>
@@ -6312,7 +6352,7 @@
                       <a:r>
                         <a:rPr sz="1100">
                           <a:solidFill>
-                            <a:srgbClr val="1E293B"/>
+                            <a:srgbClr val="EEEEEE"/>
                           </a:solidFill>
                         </a:rPr>
                         <a:t>無料あり／Pro 1,500円/月</a:t>
@@ -6332,7 +6372,7 @@
                       <a:r>
                         <a:rPr sz="1100">
                           <a:solidFill>
-                            <a:srgbClr val="1E293B"/>
+                            <a:srgbClr val="EEEEEE"/>
                           </a:solidFill>
                         </a:rPr>
                         <a:t>Bing Image Creator</a:t>
@@ -6354,7 +6394,7 @@
                       <a:r>
                         <a:rPr sz="1100">
                           <a:solidFill>
-                            <a:srgbClr val="1E293B"/>
+                            <a:srgbClr val="EEEEEE"/>
                           </a:solidFill>
                         </a:rPr>
                         <a:t>画像</a:t>
@@ -6376,7 +6416,7 @@
                       <a:r>
                         <a:rPr sz="1100">
                           <a:solidFill>
-                            <a:srgbClr val="1E293B"/>
+                            <a:srgbClr val="EEEEEE"/>
                           </a:solidFill>
                         </a:rPr>
                         <a:t>★☆☆</a:t>
@@ -6398,7 +6438,7 @@
                       <a:r>
                         <a:rPr sz="1100">
                           <a:solidFill>
-                            <a:srgbClr val="1E293B"/>
+                            <a:srgbClr val="EEEEEE"/>
                           </a:solidFill>
                         </a:rPr>
                         <a:t>★☆☆</a:t>
@@ -6420,7 +6460,7 @@
                       <a:r>
                         <a:rPr sz="1100">
                           <a:solidFill>
-                            <a:srgbClr val="1E293B"/>
+                            <a:srgbClr val="EEEEEE"/>
                           </a:solidFill>
                         </a:rPr>
                         <a:t>完全無料</a:t>
@@ -6444,7 +6484,7 @@
                       <a:r>
                         <a:rPr sz="1100">
                           <a:solidFill>
-                            <a:srgbClr val="1E293B"/>
+                            <a:srgbClr val="EEEEEE"/>
                           </a:solidFill>
                         </a:rPr>
                         <a:t>Adobe Firefly</a:t>
@@ -6462,7 +6502,7 @@
                       <a:r>
                         <a:rPr sz="1100">
                           <a:solidFill>
-                            <a:srgbClr val="1E293B"/>
+                            <a:srgbClr val="EEEEEE"/>
                           </a:solidFill>
                         </a:rPr>
                         <a:t>画像</a:t>
@@ -6480,7 +6520,7 @@
                       <a:r>
                         <a:rPr sz="1100">
                           <a:solidFill>
-                            <a:srgbClr val="1E293B"/>
+                            <a:srgbClr val="EEEEEE"/>
                           </a:solidFill>
                         </a:rPr>
                         <a:t>★☆☆</a:t>
@@ -6498,7 +6538,7 @@
                       <a:r>
                         <a:rPr sz="1100">
                           <a:solidFill>
-                            <a:srgbClr val="1E293B"/>
+                            <a:srgbClr val="EEEEEE"/>
                           </a:solidFill>
                         </a:rPr>
                         <a:t>★★☆</a:t>
@@ -6516,7 +6556,7 @@
                       <a:r>
                         <a:rPr sz="1100">
                           <a:solidFill>
-                            <a:srgbClr val="1E293B"/>
+                            <a:srgbClr val="EEEEEE"/>
                           </a:solidFill>
                         </a:rPr>
                         <a:t>無料あり（25クレジット/月）／CC 6,480円/月〜</a:t>
@@ -6536,7 +6576,7 @@
                       <a:r>
                         <a:rPr sz="1100">
                           <a:solidFill>
-                            <a:srgbClr val="1E293B"/>
+                            <a:srgbClr val="EEEEEE"/>
                           </a:solidFill>
                         </a:rPr>
                         <a:t>CapCut（AI機能）</a:t>
@@ -6558,7 +6598,7 @@
                       <a:r>
                         <a:rPr sz="1100">
                           <a:solidFill>
-                            <a:srgbClr val="1E293B"/>
+                            <a:srgbClr val="EEEEEE"/>
                           </a:solidFill>
                         </a:rPr>
                         <a:t>動画</a:t>
@@ -6580,7 +6620,7 @@
                       <a:r>
                         <a:rPr sz="1100">
                           <a:solidFill>
-                            <a:srgbClr val="1E293B"/>
+                            <a:srgbClr val="EEEEEE"/>
                           </a:solidFill>
                         </a:rPr>
                         <a:t>★★☆</a:t>
@@ -6602,7 +6642,7 @@
                       <a:r>
                         <a:rPr sz="1100">
                           <a:solidFill>
-                            <a:srgbClr val="1E293B"/>
+                            <a:srgbClr val="EEEEEE"/>
                           </a:solidFill>
                         </a:rPr>
                         <a:t>★★☆</a:t>
@@ -6624,7 +6664,7 @@
                       <a:r>
                         <a:rPr sz="1100">
                           <a:solidFill>
-                            <a:srgbClr val="1E293B"/>
+                            <a:srgbClr val="EEEEEE"/>
                           </a:solidFill>
                         </a:rPr>
                         <a:t>無料あり／Pro 約1,200円/月</a:t>
@@ -6648,7 +6688,7 @@
                       <a:r>
                         <a:rPr sz="1100">
                           <a:solidFill>
-                            <a:srgbClr val="1E293B"/>
+                            <a:srgbClr val="EEEEEE"/>
                           </a:solidFill>
                         </a:rPr>
                         <a:t>Canva（動画）</a:t>
@@ -6666,7 +6706,7 @@
                       <a:r>
                         <a:rPr sz="1100">
                           <a:solidFill>
-                            <a:srgbClr val="1E293B"/>
+                            <a:srgbClr val="EEEEEE"/>
                           </a:solidFill>
                         </a:rPr>
                         <a:t>動画</a:t>
@@ -6684,7 +6724,7 @@
                       <a:r>
                         <a:rPr sz="1100">
                           <a:solidFill>
-                            <a:srgbClr val="1E293B"/>
+                            <a:srgbClr val="EEEEEE"/>
                           </a:solidFill>
                         </a:rPr>
                         <a:t>★☆☆</a:t>
@@ -6702,7 +6742,7 @@
                       <a:r>
                         <a:rPr sz="1100">
                           <a:solidFill>
-                            <a:srgbClr val="1E293B"/>
+                            <a:srgbClr val="EEEEEE"/>
                           </a:solidFill>
                         </a:rPr>
                         <a:t>★☆☆</a:t>
@@ -6720,7 +6760,7 @@
                       <a:r>
                         <a:rPr sz="1100">
                           <a:solidFill>
-                            <a:srgbClr val="1E293B"/>
+                            <a:srgbClr val="EEEEEE"/>
                           </a:solidFill>
                         </a:rPr>
                         <a:t>無料あり／Pro 1,500円/月</a:t>
@@ -6740,7 +6780,7 @@
                       <a:r>
                         <a:rPr sz="1100">
                           <a:solidFill>
-                            <a:srgbClr val="1E293B"/>
+                            <a:srgbClr val="EEEEEE"/>
                           </a:solidFill>
                         </a:rPr>
                         <a:t>Claude Code</a:t>
@@ -6762,7 +6802,7 @@
                       <a:r>
                         <a:rPr sz="1100">
                           <a:solidFill>
-                            <a:srgbClr val="1E293B"/>
+                            <a:srgbClr val="EEEEEE"/>
                           </a:solidFill>
                         </a:rPr>
                         <a:t>自動化</a:t>
@@ -6784,7 +6824,7 @@
                       <a:r>
                         <a:rPr sz="1100">
                           <a:solidFill>
-                            <a:srgbClr val="1E293B"/>
+                            <a:srgbClr val="EEEEEE"/>
                           </a:solidFill>
                         </a:rPr>
                         <a:t>★★★</a:t>
@@ -6806,7 +6846,7 @@
                       <a:r>
                         <a:rPr sz="1100">
                           <a:solidFill>
-                            <a:srgbClr val="1E293B"/>
+                            <a:srgbClr val="EEEEEE"/>
                           </a:solidFill>
                         </a:rPr>
                         <a:t>★★★</a:t>
@@ -6828,7 +6868,7 @@
                       <a:r>
                         <a:rPr sz="1100">
                           <a:solidFill>
-                            <a:srgbClr val="1E293B"/>
+                            <a:srgbClr val="EEEEEE"/>
                           </a:solidFill>
                         </a:rPr>
                         <a:t>APIキー従量課金（軽い使い方で月数百円〜）</a:t>
@@ -6860,7 +6900,7 @@
     <p:bg>
       <p:bgPr>
         <a:solidFill>
-          <a:srgbClr val="1E40AF"/>
+          <a:srgbClr val="1C1C1C"/>
         </a:solidFill>
         <a:effectLst/>
       </p:bgPr>
@@ -7009,7 +7049,7 @@
             <a:r>
               <a:rPr sz="1400" b="0" i="0">
                 <a:solidFill>
-                  <a:srgbClr val="93C5FD"/>
+                  <a:srgbClr val="DA7756"/>
                 </a:solidFill>
               </a:rPr>
               <a:t>⏱ 10分 ＋ 休憩5分</a:t>
@@ -7043,7 +7083,7 @@
             <a:r>
               <a:rPr sz="1500" b="0" i="0">
                 <a:solidFill>
-                  <a:srgbClr val="BFDBFE"/>
+                  <a:srgbClr val="B8A99A"/>
                 </a:solidFill>
               </a:rPr>
               <a:t>安心して使えるルールを確認しましょう</a:t>
@@ -7062,6 +7102,14 @@
 <file path=ppt/slides/slide17.xml><?xml version="1.0" encoding="utf-8"?>
 <p:sld xmlns:a="http://schemas.openxmlformats.org/drawingml/2006/main" xmlns:p="http://schemas.openxmlformats.org/presentationml/2006/main" xmlns:r="http://schemas.openxmlformats.org/officeDocument/2006/relationships">
   <p:cSld>
+    <p:bg>
+      <p:bgPr>
+        <a:solidFill>
+          <a:srgbClr val="1C1C1C"/>
+        </a:solidFill>
+        <a:effectLst/>
+      </p:bgPr>
+    </p:bg>
     <p:spTree>
       <p:nvGrpSpPr>
         <p:cNvPr id="1" name=""/>
@@ -7084,7 +7132,7 @@
             <a:avLst/>
           </a:prstGeom>
           <a:solidFill>
-            <a:srgbClr val="1E40AF"/>
+            <a:srgbClr val="252525"/>
           </a:solidFill>
           <a:ln>
             <a:noFill/>
@@ -7187,7 +7235,7 @@
                   </a:txBody>
                   <a:tcPr>
                     <a:solidFill>
-                      <a:srgbClr val="1E40AF"/>
+                      <a:srgbClr val="1C1C1C"/>
                     </a:solidFill>
                   </a:tcPr>
                 </a:tc>
@@ -7209,7 +7257,7 @@
                   </a:txBody>
                   <a:tcPr>
                     <a:solidFill>
-                      <a:srgbClr val="1E40AF"/>
+                      <a:srgbClr val="1C1C1C"/>
                     </a:solidFill>
                   </a:tcPr>
                 </a:tc>
@@ -7224,7 +7272,7 @@
                       <a:r>
                         <a:rPr sz="1100">
                           <a:solidFill>
-                            <a:srgbClr val="1E293B"/>
+                            <a:srgbClr val="EEEEEE"/>
                           </a:solidFill>
                         </a:rPr>
                         <a:t>個人情報</a:t>
@@ -7242,7 +7290,7 @@
                       <a:r>
                         <a:rPr sz="1100">
                           <a:solidFill>
-                            <a:srgbClr val="1E293B"/>
+                            <a:srgbClr val="EEEEEE"/>
                           </a:solidFill>
                         </a:rPr>
                         <a:t>顧客名・住所・電話番号・メールアドレス</a:t>
@@ -7262,7 +7310,7 @@
                       <a:r>
                         <a:rPr sz="1100">
                           <a:solidFill>
-                            <a:srgbClr val="1E293B"/>
+                            <a:srgbClr val="EEEEEE"/>
                           </a:solidFill>
                         </a:rPr>
                         <a:t>機密情報</a:t>
@@ -7284,7 +7332,7 @@
                       <a:r>
                         <a:rPr sz="1100">
                           <a:solidFill>
-                            <a:srgbClr val="1E293B"/>
+                            <a:srgbClr val="EEEEEE"/>
                           </a:solidFill>
                         </a:rPr>
                         <a:t>未発表の事業計画・契約内容・取引先との交渉内容</a:t>
@@ -7308,7 +7356,7 @@
                       <a:r>
                         <a:rPr sz="1100">
                           <a:solidFill>
-                            <a:srgbClr val="1E293B"/>
+                            <a:srgbClr val="EEEEEE"/>
                           </a:solidFill>
                         </a:rPr>
                         <a:t>社内情報</a:t>
@@ -7326,7 +7374,7 @@
                       <a:r>
                         <a:rPr sz="1100">
                           <a:solidFill>
-                            <a:srgbClr val="1E293B"/>
+                            <a:srgbClr val="EEEEEE"/>
                           </a:solidFill>
                         </a:rPr>
                         <a:t>従業員の給与・人事評価・内部トラブル</a:t>
@@ -7428,6 +7476,14 @@
 <file path=ppt/slides/slide18.xml><?xml version="1.0" encoding="utf-8"?>
 <p:sld xmlns:a="http://schemas.openxmlformats.org/drawingml/2006/main" xmlns:p="http://schemas.openxmlformats.org/presentationml/2006/main" xmlns:r="http://schemas.openxmlformats.org/officeDocument/2006/relationships">
   <p:cSld>
+    <p:bg>
+      <p:bgPr>
+        <a:solidFill>
+          <a:srgbClr val="1C1C1C"/>
+        </a:solidFill>
+        <a:effectLst/>
+      </p:bgPr>
+    </p:bg>
     <p:spTree>
       <p:nvGrpSpPr>
         <p:cNvPr id="1" name=""/>
@@ -7450,7 +7506,7 @@
             <a:avLst/>
           </a:prstGeom>
           <a:solidFill>
-            <a:srgbClr val="1E40AF"/>
+            <a:srgbClr val="252525"/>
           </a:solidFill>
           <a:ln>
             <a:noFill/>
@@ -7554,7 +7610,7 @@
                   </a:txBody>
                   <a:tcPr>
                     <a:solidFill>
-                      <a:srgbClr val="1E40AF"/>
+                      <a:srgbClr val="1C1C1C"/>
                     </a:solidFill>
                   </a:tcPr>
                 </a:tc>
@@ -7576,7 +7632,7 @@
                   </a:txBody>
                   <a:tcPr>
                     <a:solidFill>
-                      <a:srgbClr val="1E40AF"/>
+                      <a:srgbClr val="1C1C1C"/>
                     </a:solidFill>
                   </a:tcPr>
                 </a:tc>
@@ -7598,7 +7654,7 @@
                   </a:txBody>
                   <a:tcPr>
                     <a:solidFill>
-                      <a:srgbClr val="1E40AF"/>
+                      <a:srgbClr val="1C1C1C"/>
                     </a:solidFill>
                   </a:tcPr>
                 </a:tc>
@@ -7613,7 +7669,7 @@
                       <a:r>
                         <a:rPr sz="1100">
                           <a:solidFill>
-                            <a:srgbClr val="1E293B"/>
+                            <a:srgbClr val="EEEEEE"/>
                           </a:solidFill>
                         </a:rPr>
                         <a:t>ChatGPT</a:t>
@@ -7631,7 +7687,7 @@
                       <a:r>
                         <a:rPr sz="1100">
                           <a:solidFill>
-                            <a:srgbClr val="1E293B"/>
+                            <a:srgbClr val="EEEEEE"/>
                           </a:solidFill>
                         </a:rPr>
                         <a:t>デフォルトON</a:t>
@@ -7649,7 +7705,7 @@
                       <a:r>
                         <a:rPr sz="1100">
                           <a:solidFill>
-                            <a:srgbClr val="1E293B"/>
+                            <a:srgbClr val="EEEEEE"/>
                           </a:solidFill>
                         </a:rPr>
                         <a:t>設定でOFFにできる</a:t>
@@ -7669,7 +7725,7 @@
                       <a:r>
                         <a:rPr sz="1100">
                           <a:solidFill>
-                            <a:srgbClr val="1E293B"/>
+                            <a:srgbClr val="EEEEEE"/>
                           </a:solidFill>
                         </a:rPr>
                         <a:t>Gemini</a:t>
@@ -7691,7 +7747,7 @@
                       <a:r>
                         <a:rPr sz="1100">
                           <a:solidFill>
-                            <a:srgbClr val="1E293B"/>
+                            <a:srgbClr val="EEEEEE"/>
                           </a:solidFill>
                         </a:rPr>
                         <a:t>デフォルトON</a:t>
@@ -7713,7 +7769,7 @@
                       <a:r>
                         <a:rPr sz="1100">
                           <a:solidFill>
-                            <a:srgbClr val="1E293B"/>
+                            <a:srgbClr val="EEEEEE"/>
                           </a:solidFill>
                         </a:rPr>
                         <a:t>設定でOFFにできる</a:t>
@@ -7737,7 +7793,7 @@
                       <a:r>
                         <a:rPr sz="1100">
                           <a:solidFill>
-                            <a:srgbClr val="1E293B"/>
+                            <a:srgbClr val="EEEEEE"/>
                           </a:solidFill>
                         </a:rPr>
                         <a:t>Claude</a:t>
@@ -7755,7 +7811,7 @@
                       <a:r>
                         <a:rPr sz="1100">
                           <a:solidFill>
-                            <a:srgbClr val="1E293B"/>
+                            <a:srgbClr val="EEEEEE"/>
                           </a:solidFill>
                         </a:rPr>
                         <a:t>デフォルトOFF</a:t>
@@ -7773,7 +7829,7 @@
                       <a:r>
                         <a:rPr sz="1100">
                           <a:solidFill>
-                            <a:srgbClr val="1E293B"/>
+                            <a:srgbClr val="EEEEEE"/>
                           </a:solidFill>
                         </a:rPr>
                         <a:t>商用利用は学習に使わない</a:t>
@@ -7793,7 +7849,7 @@
                       <a:r>
                         <a:rPr sz="1100">
                           <a:solidFill>
-                            <a:srgbClr val="1E293B"/>
+                            <a:srgbClr val="EEEEEE"/>
                           </a:solidFill>
                         </a:rPr>
                         <a:t>Microsoft Copilot</a:t>
@@ -7815,7 +7871,7 @@
                       <a:r>
                         <a:rPr sz="1100">
                           <a:solidFill>
-                            <a:srgbClr val="1E293B"/>
+                            <a:srgbClr val="EEEEEE"/>
                           </a:solidFill>
                         </a:rPr>
                         <a:t>OFF</a:t>
@@ -7837,7 +7893,7 @@
                       <a:r>
                         <a:rPr sz="1100">
                           <a:solidFill>
-                            <a:srgbClr val="1E293B"/>
+                            <a:srgbClr val="EEEEEE"/>
                           </a:solidFill>
                         </a:rPr>
                         <a:t>M365契約内は学習利用なし</a:t>
@@ -7861,7 +7917,7 @@
                       <a:r>
                         <a:rPr sz="1100">
                           <a:solidFill>
-                            <a:srgbClr val="1E293B"/>
+                            <a:srgbClr val="EEEEEE"/>
                           </a:solidFill>
                         </a:rPr>
                         <a:t>Claude Code</a:t>
@@ -7879,7 +7935,7 @@
                       <a:r>
                         <a:rPr sz="1100">
                           <a:solidFill>
-                            <a:srgbClr val="1E293B"/>
+                            <a:srgbClr val="EEEEEE"/>
                           </a:solidFill>
                         </a:rPr>
                         <a:t>OFF</a:t>
@@ -7897,7 +7953,7 @@
                       <a:r>
                         <a:rPr sz="1100">
                           <a:solidFill>
-                            <a:srgbClr val="1E293B"/>
+                            <a:srgbClr val="EEEEEE"/>
                           </a:solidFill>
                         </a:rPr>
                         <a:t>API経由のため学習利用なし・社内情報を扱う業務自動化に向いている</a:t>
@@ -7926,7 +7982,7 @@
             <a:avLst/>
           </a:prstGeom>
           <a:solidFill>
-            <a:srgbClr val="EFF6FF"/>
+            <a:srgbClr val="2F2F2F"/>
           </a:solidFill>
           <a:ln>
             <a:noFill/>
@@ -7980,7 +8036,7 @@
             <a:r>
               <a:rPr sz="1400" b="1" i="0">
                 <a:solidFill>
-                  <a:srgbClr val="1E40AF"/>
+                  <a:srgbClr val="1C1C1C"/>
                 </a:solidFill>
               </a:rPr>
               <a:t>💡 社内の機密情報を扱う業務には、学習OFFのツールを選ぶのが安心です</a:t>
@@ -7999,6 +8055,14 @@
 <file path=ppt/slides/slide19.xml><?xml version="1.0" encoding="utf-8"?>
 <p:sld xmlns:a="http://schemas.openxmlformats.org/drawingml/2006/main" xmlns:p="http://schemas.openxmlformats.org/presentationml/2006/main" xmlns:r="http://schemas.openxmlformats.org/officeDocument/2006/relationships">
   <p:cSld>
+    <p:bg>
+      <p:bgPr>
+        <a:solidFill>
+          <a:srgbClr val="1C1C1C"/>
+        </a:solidFill>
+        <a:effectLst/>
+      </p:bgPr>
+    </p:bg>
     <p:spTree>
       <p:nvGrpSpPr>
         <p:cNvPr id="1" name=""/>
@@ -8021,7 +8085,7 @@
             <a:avLst/>
           </a:prstGeom>
           <a:solidFill>
-            <a:srgbClr val="1E40AF"/>
+            <a:srgbClr val="252525"/>
           </a:solidFill>
           <a:ln>
             <a:noFill/>
@@ -8109,7 +8173,7 @@
             <a:r>
               <a:rPr sz="1400" b="1" i="0">
                 <a:solidFill>
-                  <a:srgbClr val="1E40AF"/>
+                  <a:srgbClr val="1C1C1C"/>
                 </a:solidFill>
               </a:rPr>
               <a:t>社内ルール（最低限）</a:t>
@@ -8142,7 +8206,7 @@
             <a:r>
               <a:rPr sz="1400">
                 <a:solidFill>
-                  <a:srgbClr val="1E293B"/>
+                  <a:srgbClr val="EEEEEE"/>
                 </a:solidFill>
               </a:rPr>
               <a:t>① 使ってよいツールを決める</a:t>
@@ -8150,6 +8214,9 @@
           </a:p>
           <a:p>
             <a:r>
+              <a:rPr>
+                <a:solidFill/>
+              </a:rPr>
               <a:t/>
             </a:r>
           </a:p>
@@ -8157,7 +8224,7 @@
             <a:r>
               <a:rPr sz="1400">
                 <a:solidFill>
-                  <a:srgbClr val="1E293B"/>
+                  <a:srgbClr val="EEEEEE"/>
                 </a:solidFill>
               </a:rPr>
               <a:t>② 入力禁止情報のリストを共有する</a:t>
@@ -8165,6 +8232,9 @@
           </a:p>
           <a:p>
             <a:r>
+              <a:rPr>
+                <a:solidFill/>
+              </a:rPr>
               <a:t/>
             </a:r>
           </a:p>
@@ -8172,7 +8242,7 @@
             <a:r>
               <a:rPr sz="1400">
                 <a:solidFill>
-                  <a:srgbClr val="1E293B"/>
+                  <a:srgbClr val="EEEEEE"/>
                 </a:solidFill>
               </a:rPr>
               <a:t>③ AIの出力は必ず確認してから使う</a:t>
@@ -8282,7 +8352,7 @@
             <a:r>
               <a:rPr sz="1300" b="1">
                 <a:solidFill>
-                  <a:srgbClr val="1E293B"/>
+                  <a:srgbClr val="EEEEEE"/>
                 </a:solidFill>
               </a:rPr>
               <a:t>ファクトチェック必須</a:t>
@@ -8300,6 +8370,9 @@
           </a:p>
           <a:p>
             <a:r>
+              <a:rPr>
+                <a:solidFill/>
+              </a:rPr>
               <a:t/>
             </a:r>
           </a:p>
@@ -8307,7 +8380,7 @@
             <a:r>
               <a:rPr sz="1300" b="1">
                 <a:solidFill>
-                  <a:srgbClr val="1E293B"/>
+                  <a:srgbClr val="EEEEEE"/>
                 </a:solidFill>
               </a:rPr>
               <a:t>著作権の確認</a:t>
@@ -8325,6 +8398,9 @@
           </a:p>
           <a:p>
             <a:r>
+              <a:rPr>
+                <a:solidFill/>
+              </a:rPr>
               <a:t/>
             </a:r>
           </a:p>
@@ -8332,7 +8408,7 @@
             <a:r>
               <a:rPr sz="1300" b="1">
                 <a:solidFill>
-                  <a:srgbClr val="1E293B"/>
+                  <a:srgbClr val="EEEEEE"/>
                 </a:solidFill>
               </a:rPr>
               <a:t>最終判断は人間が行う</a:t>
@@ -8361,6 +8437,14 @@
 <file path=ppt/slides/slide2.xml><?xml version="1.0" encoding="utf-8"?>
 <p:sld xmlns:a="http://schemas.openxmlformats.org/drawingml/2006/main" xmlns:p="http://schemas.openxmlformats.org/presentationml/2006/main" xmlns:r="http://schemas.openxmlformats.org/officeDocument/2006/relationships">
   <p:cSld>
+    <p:bg>
+      <p:bgPr>
+        <a:solidFill>
+          <a:srgbClr val="1C1C1C"/>
+        </a:solidFill>
+        <a:effectLst/>
+      </p:bgPr>
+    </p:bg>
     <p:spTree>
       <p:nvGrpSpPr>
         <p:cNvPr id="1" name=""/>
@@ -8383,7 +8467,7 @@
             <a:avLst/>
           </a:prstGeom>
           <a:solidFill>
-            <a:srgbClr val="1E40AF"/>
+            <a:srgbClr val="252525"/>
           </a:solidFill>
           <a:ln>
             <a:noFill/>
@@ -8487,7 +8571,7 @@
                   </a:txBody>
                   <a:tcPr>
                     <a:solidFill>
-                      <a:srgbClr val="1E40AF"/>
+                      <a:srgbClr val="1C1C1C"/>
                     </a:solidFill>
                   </a:tcPr>
                 </a:tc>
@@ -8509,7 +8593,7 @@
                   </a:txBody>
                   <a:tcPr>
                     <a:solidFill>
-                      <a:srgbClr val="1E40AF"/>
+                      <a:srgbClr val="1C1C1C"/>
                     </a:solidFill>
                   </a:tcPr>
                 </a:tc>
@@ -8531,7 +8615,7 @@
                   </a:txBody>
                   <a:tcPr>
                     <a:solidFill>
-                      <a:srgbClr val="1E40AF"/>
+                      <a:srgbClr val="1C1C1C"/>
                     </a:solidFill>
                   </a:tcPr>
                 </a:tc>
@@ -8546,7 +8630,7 @@
                       <a:r>
                         <a:rPr sz="1100">
                           <a:solidFill>
-                            <a:srgbClr val="1E293B"/>
+                            <a:srgbClr val="EEEEEE"/>
                           </a:solidFill>
                         </a:rPr>
                         <a:t>1</a:t>
@@ -8564,7 +8648,7 @@
                       <a:r>
                         <a:rPr sz="1100">
                           <a:solidFill>
-                            <a:srgbClr val="1E293B"/>
+                            <a:srgbClr val="EEEEEE"/>
                           </a:solidFill>
                         </a:rPr>
                         <a:t>AIの種類</a:t>
@@ -8582,7 +8666,7 @@
                       <a:r>
                         <a:rPr sz="1100">
                           <a:solidFill>
-                            <a:srgbClr val="1E293B"/>
+                            <a:srgbClr val="EEEEEE"/>
                           </a:solidFill>
                         </a:rPr>
                         <a:t>5分</a:t>
@@ -8602,7 +8686,7 @@
                       <a:r>
                         <a:rPr sz="1100">
                           <a:solidFill>
-                            <a:srgbClr val="1E293B"/>
+                            <a:srgbClr val="EEEEEE"/>
                           </a:solidFill>
                         </a:rPr>
                         <a:t>2</a:t>
@@ -8624,7 +8708,7 @@
                       <a:r>
                         <a:rPr sz="1100">
                           <a:solidFill>
-                            <a:srgbClr val="1E293B"/>
+                            <a:srgbClr val="EEEEEE"/>
                           </a:solidFill>
                         </a:rPr>
                         <a:t>できること / できないこと</a:t>
@@ -8646,7 +8730,7 @@
                       <a:r>
                         <a:rPr sz="1100">
                           <a:solidFill>
-                            <a:srgbClr val="1E293B"/>
+                            <a:srgbClr val="EEEEEE"/>
                           </a:solidFill>
                         </a:rPr>
                         <a:t>5分</a:t>
@@ -8670,7 +8754,7 @@
                       <a:r>
                         <a:rPr sz="1100">
                           <a:solidFill>
-                            <a:srgbClr val="1E293B"/>
+                            <a:srgbClr val="EEEEEE"/>
                           </a:solidFill>
                         </a:rPr>
                         <a:t>3</a:t>
@@ -8688,7 +8772,7 @@
                       <a:r>
                         <a:rPr sz="1100">
                           <a:solidFill>
-                            <a:srgbClr val="1E293B"/>
+                            <a:srgbClr val="EEEEEE"/>
                           </a:solidFill>
                         </a:rPr>
                         <a:t>業務別活用シーン</a:t>
@@ -8706,7 +8790,7 @@
                       <a:r>
                         <a:rPr sz="1100">
                           <a:solidFill>
-                            <a:srgbClr val="1E293B"/>
+                            <a:srgbClr val="EEEEEE"/>
                           </a:solidFill>
                         </a:rPr>
                         <a:t>10分</a:t>
@@ -8726,7 +8810,7 @@
                       <a:r>
                         <a:rPr sz="1100">
                           <a:solidFill>
-                            <a:srgbClr val="1E293B"/>
+                            <a:srgbClr val="EEEEEE"/>
                           </a:solidFill>
                         </a:rPr>
                         <a:t>4</a:t>
@@ -8748,7 +8832,7 @@
                       <a:r>
                         <a:rPr sz="1100">
                           <a:solidFill>
-                            <a:srgbClr val="1E293B"/>
+                            <a:srgbClr val="EEEEEE"/>
                           </a:solidFill>
                         </a:rPr>
                         <a:t>4軸 AI活用マップ ＋ ツール別表（持ち帰り）</a:t>
@@ -8770,7 +8854,7 @@
                       <a:r>
                         <a:rPr sz="1100">
                           <a:solidFill>
-                            <a:srgbClr val="1E293B"/>
+                            <a:srgbClr val="EEEEEE"/>
                           </a:solidFill>
                         </a:rPr>
                         <a:t>10分</a:t>
@@ -8794,7 +8878,7 @@
                       <a:r>
                         <a:rPr sz="1100">
                           <a:solidFill>
-                            <a:srgbClr val="1E293B"/>
+                            <a:srgbClr val="EEEEEE"/>
                           </a:solidFill>
                         </a:rPr>
                         <a:t>5</a:t>
@@ -8812,7 +8896,7 @@
                       <a:r>
                         <a:rPr sz="1100">
                           <a:solidFill>
-                            <a:srgbClr val="1E293B"/>
+                            <a:srgbClr val="EEEEEE"/>
                           </a:solidFill>
                         </a:rPr>
                         <a:t>セキュリティと社内ルール</a:t>
@@ -8830,7 +8914,7 @@
                       <a:r>
                         <a:rPr sz="1100">
                           <a:solidFill>
-                            <a:srgbClr val="1E293B"/>
+                            <a:srgbClr val="EEEEEE"/>
                           </a:solidFill>
                         </a:rPr>
                         <a:t>10分 ＋ 休憩5分</a:t>
@@ -8850,7 +8934,7 @@
                       <a:r>
                         <a:rPr sz="1100">
                           <a:solidFill>
-                            <a:srgbClr val="1E293B"/>
+                            <a:srgbClr val="EEEEEE"/>
                           </a:solidFill>
                         </a:rPr>
                         <a:t>6</a:t>
@@ -8872,7 +8956,7 @@
                       <a:r>
                         <a:rPr sz="1100">
                           <a:solidFill>
-                            <a:srgbClr val="1E293B"/>
+                            <a:srgbClr val="EEEEEE"/>
                           </a:solidFill>
                         </a:rPr>
                         <a:t>プロンプトの基本</a:t>
@@ -8894,7 +8978,7 @@
                       <a:r>
                         <a:rPr sz="1100">
                           <a:solidFill>
-                            <a:srgbClr val="1E293B"/>
+                            <a:srgbClr val="EEEEEE"/>
                           </a:solidFill>
                         </a:rPr>
                         <a:t>10分</a:t>
@@ -8918,7 +9002,7 @@
                       <a:r>
                         <a:rPr sz="1100">
                           <a:solidFill>
-                            <a:srgbClr val="1E293B"/>
+                            <a:srgbClr val="EEEEEE"/>
                           </a:solidFill>
                         </a:rPr>
                         <a:t>7</a:t>
@@ -8936,7 +9020,7 @@
                       <a:r>
                         <a:rPr sz="1100">
                           <a:solidFill>
-                            <a:srgbClr val="1E293B"/>
+                            <a:srgbClr val="EEEEEE"/>
                           </a:solidFill>
                         </a:rPr>
                         <a:t>実践</a:t>
@@ -8954,7 +9038,7 @@
                       <a:r>
                         <a:rPr sz="1100">
                           <a:solidFill>
-                            <a:srgbClr val="1E293B"/>
+                            <a:srgbClr val="EEEEEE"/>
                           </a:solidFill>
                         </a:rPr>
                         <a:t>30分</a:t>
@@ -8974,7 +9058,7 @@
                       <a:r>
                         <a:rPr sz="1100">
                           <a:solidFill>
-                            <a:srgbClr val="1E293B"/>
+                            <a:srgbClr val="EEEEEE"/>
                           </a:solidFill>
                         </a:rPr>
                         <a:t>8</a:t>
@@ -8996,7 +9080,7 @@
                       <a:r>
                         <a:rPr sz="1100">
                           <a:solidFill>
-                            <a:srgbClr val="1E293B"/>
+                            <a:srgbClr val="EEEEEE"/>
                           </a:solidFill>
                         </a:rPr>
                         <a:t>まとめ</a:t>
@@ -9018,7 +9102,7 @@
                       <a:r>
                         <a:rPr sz="1100">
                           <a:solidFill>
-                            <a:srgbClr val="1E293B"/>
+                            <a:srgbClr val="EEEEEE"/>
                           </a:solidFill>
                         </a:rPr>
                         <a:t>5分</a:t>
@@ -9050,7 +9134,7 @@
     <p:bg>
       <p:bgPr>
         <a:solidFill>
-          <a:srgbClr val="1E40AF"/>
+          <a:srgbClr val="1C1C1C"/>
         </a:solidFill>
         <a:effectLst/>
       </p:bgPr>
@@ -9199,7 +9283,7 @@
             <a:r>
               <a:rPr sz="1400" b="0" i="0">
                 <a:solidFill>
-                  <a:srgbClr val="93C5FD"/>
+                  <a:srgbClr val="DA7756"/>
                 </a:solidFill>
               </a:rPr>
               <a:t>⏱ 10分</a:t>
@@ -9233,7 +9317,7 @@
             <a:r>
               <a:rPr sz="1500" b="0" i="0">
                 <a:solidFill>
-                  <a:srgbClr val="BFDBFE"/>
+                  <a:srgbClr val="B8A99A"/>
                 </a:solidFill>
               </a:rPr>
               <a:t>指示の質がそのまま出力の質になります</a:t>
@@ -9252,6 +9336,14 @@
 <file path=ppt/slides/slide21.xml><?xml version="1.0" encoding="utf-8"?>
 <p:sld xmlns:a="http://schemas.openxmlformats.org/drawingml/2006/main" xmlns:p="http://schemas.openxmlformats.org/presentationml/2006/main" xmlns:r="http://schemas.openxmlformats.org/officeDocument/2006/relationships">
   <p:cSld>
+    <p:bg>
+      <p:bgPr>
+        <a:solidFill>
+          <a:srgbClr val="1C1C1C"/>
+        </a:solidFill>
+        <a:effectLst/>
+      </p:bgPr>
+    </p:bg>
     <p:spTree>
       <p:nvGrpSpPr>
         <p:cNvPr id="1" name=""/>
@@ -9274,7 +9366,7 @@
             <a:avLst/>
           </a:prstGeom>
           <a:solidFill>
-            <a:srgbClr val="1E40AF"/>
+            <a:srgbClr val="252525"/>
           </a:solidFill>
           <a:ln>
             <a:noFill/>
@@ -9378,7 +9470,7 @@
                   </a:txBody>
                   <a:tcPr>
                     <a:solidFill>
-                      <a:srgbClr val="1E40AF"/>
+                      <a:srgbClr val="1C1C1C"/>
                     </a:solidFill>
                   </a:tcPr>
                 </a:tc>
@@ -9400,7 +9492,7 @@
                   </a:txBody>
                   <a:tcPr>
                     <a:solidFill>
-                      <a:srgbClr val="1E40AF"/>
+                      <a:srgbClr val="1C1C1C"/>
                     </a:solidFill>
                   </a:tcPr>
                 </a:tc>
@@ -9422,7 +9514,7 @@
                   </a:txBody>
                   <a:tcPr>
                     <a:solidFill>
-                      <a:srgbClr val="1E40AF"/>
+                      <a:srgbClr val="1C1C1C"/>
                     </a:solidFill>
                   </a:tcPr>
                 </a:tc>
@@ -9437,7 +9529,7 @@
                       <a:r>
                         <a:rPr sz="1100">
                           <a:solidFill>
-                            <a:srgbClr val="1E293B"/>
+                            <a:srgbClr val="EEEEEE"/>
                           </a:solidFill>
                         </a:rPr>
                         <a:t>役割</a:t>
@@ -9455,7 +9547,7 @@
                       <a:r>
                         <a:rPr sz="1100">
                           <a:solidFill>
-                            <a:srgbClr val="1E293B"/>
+                            <a:srgbClr val="EEEEEE"/>
                           </a:solidFill>
                         </a:rPr>
                         <a:t>AIにどの立場で考えるかを伝える</a:t>
@@ -9473,7 +9565,7 @@
                       <a:r>
                         <a:rPr sz="1100">
                           <a:solidFill>
-                            <a:srgbClr val="1E293B"/>
+                            <a:srgbClr val="EEEEEE"/>
                           </a:solidFill>
                         </a:rPr>
                         <a:t>「あなたは中小企業向けの採用担当者です」</a:t>
@@ -9493,7 +9585,7 @@
                       <a:r>
                         <a:rPr sz="1100">
                           <a:solidFill>
-                            <a:srgbClr val="1E293B"/>
+                            <a:srgbClr val="EEEEEE"/>
                           </a:solidFill>
                         </a:rPr>
                         <a:t>背景</a:t>
@@ -9515,7 +9607,7 @@
                       <a:r>
                         <a:rPr sz="1100">
                           <a:solidFill>
-                            <a:srgbClr val="1E293B"/>
+                            <a:srgbClr val="EEEEEE"/>
                           </a:solidFill>
                         </a:rPr>
                         <a:t>状況・前提を伝える</a:t>
@@ -9537,7 +9629,7 @@
                       <a:r>
                         <a:rPr sz="1100">
                           <a:solidFill>
-                            <a:srgbClr val="1E293B"/>
+                            <a:srgbClr val="EEEEEE"/>
                           </a:solidFill>
                         </a:rPr>
                         <a:t>「広島県の製造業・従業員30名」</a:t>
@@ -9561,7 +9653,7 @@
                       <a:r>
                         <a:rPr sz="1100">
                           <a:solidFill>
-                            <a:srgbClr val="1E293B"/>
+                            <a:srgbClr val="EEEEEE"/>
                           </a:solidFill>
                         </a:rPr>
                         <a:t>指示</a:t>
@@ -9579,7 +9671,7 @@
                       <a:r>
                         <a:rPr sz="1100">
                           <a:solidFill>
-                            <a:srgbClr val="1E293B"/>
+                            <a:srgbClr val="EEEEEE"/>
                           </a:solidFill>
                         </a:rPr>
                         <a:t>何をしてほしいか具体的に</a:t>
@@ -9597,7 +9689,7 @@
                       <a:r>
                         <a:rPr sz="1100">
                           <a:solidFill>
-                            <a:srgbClr val="1E293B"/>
+                            <a:srgbClr val="EEEEEE"/>
                           </a:solidFill>
                         </a:rPr>
                         <a:t>「求人票を作成してください」</a:t>
@@ -9617,7 +9709,7 @@
                       <a:r>
                         <a:rPr sz="1100">
                           <a:solidFill>
-                            <a:srgbClr val="1E293B"/>
+                            <a:srgbClr val="EEEEEE"/>
                           </a:solidFill>
                         </a:rPr>
                         <a:t>形式</a:t>
@@ -9639,7 +9731,7 @@
                       <a:r>
                         <a:rPr sz="1100">
                           <a:solidFill>
-                            <a:srgbClr val="1E293B"/>
+                            <a:srgbClr val="EEEEEE"/>
                           </a:solidFill>
                         </a:rPr>
                         <a:t>出力の形を指定する</a:t>
@@ -9661,7 +9753,7 @@
                       <a:r>
                         <a:rPr sz="1100">
                           <a:solidFill>
-                            <a:srgbClr val="1E293B"/>
+                            <a:srgbClr val="EEEEEE"/>
                           </a:solidFill>
                         </a:rPr>
                         <a:t>「箇条書きで・400字以内で」</a:t>
@@ -9694,7 +9786,7 @@
             <a:avLst/>
           </a:prstGeom>
           <a:solidFill>
-            <a:srgbClr val="EFF6FF"/>
+            <a:srgbClr val="2F2F2F"/>
           </a:solidFill>
           <a:ln>
             <a:noFill/>
@@ -9748,7 +9840,7 @@
             <a:r>
               <a:rPr sz="1400" b="1" i="0">
                 <a:solidFill>
-                  <a:srgbClr val="1E40AF"/>
+                  <a:srgbClr val="1C1C1C"/>
                 </a:solidFill>
               </a:rPr>
               <a:t>💡 4要素がすべて揃うほど、期待通りの出力が得られやすくなります</a:t>
@@ -9767,6 +9859,14 @@
 <file path=ppt/slides/slide22.xml><?xml version="1.0" encoding="utf-8"?>
 <p:sld xmlns:a="http://schemas.openxmlformats.org/drawingml/2006/main" xmlns:p="http://schemas.openxmlformats.org/presentationml/2006/main" xmlns:r="http://schemas.openxmlformats.org/officeDocument/2006/relationships">
   <p:cSld>
+    <p:bg>
+      <p:bgPr>
+        <a:solidFill>
+          <a:srgbClr val="1C1C1C"/>
+        </a:solidFill>
+        <a:effectLst/>
+      </p:bgPr>
+    </p:bg>
     <p:spTree>
       <p:nvGrpSpPr>
         <p:cNvPr id="1" name=""/>
@@ -9789,7 +9889,7 @@
             <a:avLst/>
           </a:prstGeom>
           <a:solidFill>
-            <a:srgbClr val="1E40AF"/>
+            <a:srgbClr val="252525"/>
           </a:solidFill>
           <a:ln>
             <a:noFill/>
@@ -10120,6 +10220,14 @@
 <file path=ppt/slides/slide23.xml><?xml version="1.0" encoding="utf-8"?>
 <p:sld xmlns:a="http://schemas.openxmlformats.org/drawingml/2006/main" xmlns:p="http://schemas.openxmlformats.org/presentationml/2006/main" xmlns:r="http://schemas.openxmlformats.org/officeDocument/2006/relationships">
   <p:cSld>
+    <p:bg>
+      <p:bgPr>
+        <a:solidFill>
+          <a:srgbClr val="1C1C1C"/>
+        </a:solidFill>
+        <a:effectLst/>
+      </p:bgPr>
+    </p:bg>
     <p:spTree>
       <p:nvGrpSpPr>
         <p:cNvPr id="1" name=""/>
@@ -10142,7 +10250,7 @@
             <a:avLst/>
           </a:prstGeom>
           <a:solidFill>
-            <a:srgbClr val="1E40AF"/>
+            <a:srgbClr val="252525"/>
           </a:solidFill>
           <a:ln>
             <a:noFill/>
@@ -10245,7 +10353,7 @@
                   </a:txBody>
                   <a:tcPr>
                     <a:solidFill>
-                      <a:srgbClr val="1E40AF"/>
+                      <a:srgbClr val="1C1C1C"/>
                     </a:solidFill>
                   </a:tcPr>
                 </a:tc>
@@ -10267,7 +10375,7 @@
                   </a:txBody>
                   <a:tcPr>
                     <a:solidFill>
-                      <a:srgbClr val="1E40AF"/>
+                      <a:srgbClr val="1C1C1C"/>
                     </a:solidFill>
                   </a:tcPr>
                 </a:tc>
@@ -10282,7 +10390,7 @@
                       <a:r>
                         <a:rPr sz="1100">
                           <a:solidFill>
-                            <a:srgbClr val="1E293B"/>
+                            <a:srgbClr val="EEEEEE"/>
                           </a:solidFill>
                         </a:rPr>
                         <a:t>わからないことを認めさせる</a:t>
@@ -10300,7 +10408,7 @@
                       <a:r>
                         <a:rPr sz="1100">
                           <a:solidFill>
-                            <a:srgbClr val="1E293B"/>
+                            <a:srgbClr val="EEEEEE"/>
                           </a:solidFill>
                         </a:rPr>
                         <a:t>「不明な点は『わかりません』と答えてください」をプロンプトに加える</a:t>
@@ -10320,7 +10428,7 @@
                       <a:r>
                         <a:rPr sz="1100">
                           <a:solidFill>
-                            <a:srgbClr val="1E293B"/>
+                            <a:srgbClr val="EEEEEE"/>
                           </a:solidFill>
                         </a:rPr>
                         <a:t>確信度を明示させる</a:t>
@@ -10342,7 +10450,7 @@
                       <a:r>
                         <a:rPr sz="1100">
                           <a:solidFill>
-                            <a:srgbClr val="1E293B"/>
+                            <a:srgbClr val="EEEEEE"/>
                           </a:solidFill>
                         </a:rPr>
                         <a:t>「確信が持てない情報には【要確認】とつけてください」と指示する</a:t>
@@ -10366,7 +10474,7 @@
                       <a:r>
                         <a:rPr sz="1100">
                           <a:solidFill>
-                            <a:srgbClr val="1E293B"/>
+                            <a:srgbClr val="EEEEEE"/>
                           </a:solidFill>
                         </a:rPr>
                         <a:t>推測を排除する</a:t>
@@ -10384,7 +10492,7 @@
                       <a:r>
                         <a:rPr sz="1100">
                           <a:solidFill>
-                            <a:srgbClr val="1E293B"/>
+                            <a:srgbClr val="EEEEEE"/>
                           </a:solidFill>
                         </a:rPr>
                         <a:t>「推測や不確かな情報は含めないでください」と指示する</a:t>
@@ -10404,7 +10512,7 @@
                       <a:r>
                         <a:rPr sz="1100">
                           <a:solidFill>
-                            <a:srgbClr val="1E293B"/>
+                            <a:srgbClr val="EEEEEE"/>
                           </a:solidFill>
                         </a:rPr>
                         <a:t>情報はこちらが提供する</a:t>
@@ -10426,7 +10534,7 @@
                       <a:r>
                         <a:rPr sz="1100">
                           <a:solidFill>
-                            <a:srgbClr val="1E293B"/>
+                            <a:srgbClr val="EEEEEE"/>
                           </a:solidFill>
                         </a:rPr>
                         <a:t>「以下の情報をもとに整理してください」と事実を渡してから指示する</a:t>
@@ -10459,7 +10567,7 @@
             <a:avLst/>
           </a:prstGeom>
           <a:solidFill>
-            <a:srgbClr val="EFF6FF"/>
+            <a:srgbClr val="2F2F2F"/>
           </a:solidFill>
           <a:ln>
             <a:noFill/>
@@ -10513,7 +10621,7 @@
             <a:r>
               <a:rPr sz="1400" b="1" i="0">
                 <a:solidFill>
-                  <a:srgbClr val="1E40AF"/>
+                  <a:srgbClr val="1C1C1C"/>
                 </a:solidFill>
               </a:rPr>
               <a:t>💡 ハルシネーションはAIの限界ではなく、指示の出し方で大幅に減らせます</a:t>
@@ -10535,7 +10643,7 @@
     <p:bg>
       <p:bgPr>
         <a:solidFill>
-          <a:srgbClr val="1E40AF"/>
+          <a:srgbClr val="1C1C1C"/>
         </a:solidFill>
         <a:effectLst/>
       </p:bgPr>
@@ -10684,7 +10792,7 @@
             <a:r>
               <a:rPr sz="1400" b="0" i="0">
                 <a:solidFill>
-                  <a:srgbClr val="93C5FD"/>
+                  <a:srgbClr val="DA7756"/>
                 </a:solidFill>
               </a:rPr>
               <a:t>⏱ 30分</a:t>
@@ -10718,7 +10826,7 @@
             <a:r>
               <a:rPr sz="1500" b="0" i="0">
                 <a:solidFill>
-                  <a:srgbClr val="BFDBFE"/>
+                  <a:srgbClr val="B8A99A"/>
                 </a:solidFill>
               </a:rPr>
               <a:t>体験して「できる」を感じて帰りましょう</a:t>
@@ -10737,6 +10845,14 @@
 <file path=ppt/slides/slide25.xml><?xml version="1.0" encoding="utf-8"?>
 <p:sld xmlns:a="http://schemas.openxmlformats.org/drawingml/2006/main" xmlns:p="http://schemas.openxmlformats.org/presentationml/2006/main" xmlns:r="http://schemas.openxmlformats.org/officeDocument/2006/relationships">
   <p:cSld>
+    <p:bg>
+      <p:bgPr>
+        <a:solidFill>
+          <a:srgbClr val="1C1C1C"/>
+        </a:solidFill>
+        <a:effectLst/>
+      </p:bgPr>
+    </p:bg>
     <p:spTree>
       <p:nvGrpSpPr>
         <p:cNvPr id="1" name=""/>
@@ -10759,7 +10875,7 @@
             <a:avLst/>
           </a:prstGeom>
           <a:solidFill>
-            <a:srgbClr val="1E40AF"/>
+            <a:srgbClr val="252525"/>
           </a:solidFill>
           <a:ln>
             <a:noFill/>
@@ -10863,7 +10979,7 @@
                   </a:txBody>
                   <a:tcPr>
                     <a:solidFill>
-                      <a:srgbClr val="1E40AF"/>
+                      <a:srgbClr val="1C1C1C"/>
                     </a:solidFill>
                   </a:tcPr>
                 </a:tc>
@@ -10885,7 +11001,7 @@
                   </a:txBody>
                   <a:tcPr>
                     <a:solidFill>
-                      <a:srgbClr val="1E40AF"/>
+                      <a:srgbClr val="1C1C1C"/>
                     </a:solidFill>
                   </a:tcPr>
                 </a:tc>
@@ -10907,7 +11023,7 @@
                   </a:txBody>
                   <a:tcPr>
                     <a:solidFill>
-                      <a:srgbClr val="1E40AF"/>
+                      <a:srgbClr val="1C1C1C"/>
                     </a:solidFill>
                   </a:tcPr>
                 </a:tc>
@@ -10922,7 +11038,7 @@
                       <a:r>
                         <a:rPr sz="1100">
                           <a:solidFill>
-                            <a:srgbClr val="1E293B"/>
+                            <a:srgbClr val="EEEEEE"/>
                           </a:solidFill>
                         </a:rPr>
                         <a:t>1</a:t>
@@ -10940,7 +11056,7 @@
                       <a:r>
                         <a:rPr sz="1100">
                           <a:solidFill>
-                            <a:srgbClr val="1E293B"/>
+                            <a:srgbClr val="EEEEEE"/>
                           </a:solidFill>
                         </a:rPr>
                         <a:t>お題を選ぶ（社内向けお知らせ ／ SNS投稿文 ／ 求人票のたたき台）</a:t>
@@ -10958,7 +11074,7 @@
                       <a:r>
                         <a:rPr sz="1100">
                           <a:solidFill>
-                            <a:srgbClr val="1E293B"/>
+                            <a:srgbClr val="EEEEEE"/>
                           </a:solidFill>
                         </a:rPr>
                         <a:t>2分</a:t>
@@ -10978,7 +11094,7 @@
                       <a:r>
                         <a:rPr sz="1100">
                           <a:solidFill>
-                            <a:srgbClr val="1E293B"/>
+                            <a:srgbClr val="EEEEEE"/>
                           </a:solidFill>
                         </a:rPr>
                         <a:t>2</a:t>
@@ -11000,7 +11116,7 @@
                       <a:r>
                         <a:rPr sz="1100">
                           <a:solidFill>
-                            <a:srgbClr val="1E293B"/>
+                            <a:srgbClr val="EEEEEE"/>
                           </a:solidFill>
                         </a:rPr>
                         <a:t>4要素を使ってプロンプトを自分で書く</a:t>
@@ -11022,7 +11138,7 @@
                       <a:r>
                         <a:rPr sz="1100">
                           <a:solidFill>
-                            <a:srgbClr val="1E293B"/>
+                            <a:srgbClr val="EEEEEE"/>
                           </a:solidFill>
                         </a:rPr>
                         <a:t>5分</a:t>
@@ -11046,7 +11162,7 @@
                       <a:r>
                         <a:rPr sz="1100">
                           <a:solidFill>
-                            <a:srgbClr val="1E293B"/>
+                            <a:srgbClr val="EEEEEE"/>
                           </a:solidFill>
                         </a:rPr>
                         <a:t>3</a:t>
@@ -11064,7 +11180,7 @@
                       <a:r>
                         <a:rPr sz="1100">
                           <a:solidFill>
-                            <a:srgbClr val="1E293B"/>
+                            <a:srgbClr val="EEEEEE"/>
                           </a:solidFill>
                         </a:rPr>
                         <a:t>AIに投げて結果を見る</a:t>
@@ -11082,7 +11198,7 @@
                       <a:r>
                         <a:rPr sz="1100">
                           <a:solidFill>
-                            <a:srgbClr val="1E293B"/>
+                            <a:srgbClr val="EEEEEE"/>
                           </a:solidFill>
                         </a:rPr>
                         <a:t>3分</a:t>
@@ -11102,7 +11218,7 @@
                       <a:r>
                         <a:rPr sz="1100">
                           <a:solidFill>
-                            <a:srgbClr val="1E293B"/>
+                            <a:srgbClr val="EEEEEE"/>
                           </a:solidFill>
                         </a:rPr>
                         <a:t>4</a:t>
@@ -11124,7 +11240,7 @@
                       <a:r>
                         <a:rPr sz="1100">
                           <a:solidFill>
-                            <a:srgbClr val="1E293B"/>
+                            <a:srgbClr val="EEEEEE"/>
                           </a:solidFill>
                         </a:rPr>
                         <a:t>修正指示を出してみる（「もっと短く」「やわらかく」等）</a:t>
@@ -11146,7 +11262,7 @@
                       <a:r>
                         <a:rPr sz="1100">
                           <a:solidFill>
-                            <a:srgbClr val="1E293B"/>
+                            <a:srgbClr val="EEEEEE"/>
                           </a:solidFill>
                         </a:rPr>
                         <a:t>5分</a:t>
@@ -11170,7 +11286,7 @@
                       <a:r>
                         <a:rPr sz="1100">
                           <a:solidFill>
-                            <a:srgbClr val="1E293B"/>
+                            <a:srgbClr val="EEEEEE"/>
                           </a:solidFill>
                         </a:rPr>
                         <a:t>5</a:t>
@@ -11188,7 +11304,7 @@
                       <a:r>
                         <a:rPr sz="1100">
                           <a:solidFill>
-                            <a:srgbClr val="1E293B"/>
+                            <a:srgbClr val="EEEEEE"/>
                           </a:solidFill>
                         </a:rPr>
                         <a:t>全体シェア（1〜2人が披露）</a:t>
@@ -11206,7 +11322,7 @@
                       <a:r>
                         <a:rPr sz="1100">
                           <a:solidFill>
-                            <a:srgbClr val="1E293B"/>
+                            <a:srgbClr val="EEEEEE"/>
                           </a:solidFill>
                         </a:rPr>
                         <a:t>5分</a:t>
@@ -11226,7 +11342,7 @@
                       <a:r>
                         <a:rPr sz="1100">
                           <a:solidFill>
-                            <a:srgbClr val="1E293B"/>
+                            <a:srgbClr val="EEEEEE"/>
                           </a:solidFill>
                         </a:rPr>
                         <a:t>6</a:t>
@@ -11248,7 +11364,7 @@
                       <a:r>
                         <a:rPr sz="1100">
                           <a:solidFill>
-                            <a:srgbClr val="1E293B"/>
+                            <a:srgbClr val="EEEEEE"/>
                           </a:solidFill>
                         </a:rPr>
                         <a:t>意見交換（受講者同士でフィードバック）</a:t>
@@ -11270,7 +11386,7 @@
                       <a:r>
                         <a:rPr sz="1100">
                           <a:solidFill>
-                            <a:srgbClr val="1E293B"/>
+                            <a:srgbClr val="EEEEEE"/>
                           </a:solidFill>
                         </a:rPr>
                         <a:t>5分</a:t>
@@ -11294,7 +11410,7 @@
                       <a:r>
                         <a:rPr sz="1100">
                           <a:solidFill>
-                            <a:srgbClr val="1E293B"/>
+                            <a:srgbClr val="EEEEEE"/>
                           </a:solidFill>
                         </a:rPr>
                         <a:t/>
@@ -11312,7 +11428,7 @@
                       <a:r>
                         <a:rPr sz="1100">
                           <a:solidFill>
-                            <a:srgbClr val="1E293B"/>
+                            <a:srgbClr val="EEEEEE"/>
                           </a:solidFill>
                         </a:rPr>
                         <a:t>⭐ バッファ・Q&amp;A</a:t>
@@ -11330,7 +11446,7 @@
                       <a:r>
                         <a:rPr sz="1100">
                           <a:solidFill>
-                            <a:srgbClr val="1E293B"/>
+                            <a:srgbClr val="EEEEEE"/>
                           </a:solidFill>
                         </a:rPr>
                         <a:t>5分</a:t>
@@ -11358,7 +11474,7 @@
     <p:bg>
       <p:bgPr>
         <a:solidFill>
-          <a:srgbClr val="1E40AF"/>
+          <a:srgbClr val="1C1C1C"/>
         </a:solidFill>
         <a:effectLst/>
       </p:bgPr>
@@ -11507,7 +11623,7 @@
             <a:r>
               <a:rPr sz="1400" b="0" i="0">
                 <a:solidFill>
-                  <a:srgbClr val="93C5FD"/>
+                  <a:srgbClr val="DA7756"/>
                 </a:solidFill>
               </a:rPr>
               <a:t>⏱ 5分</a:t>
@@ -11541,7 +11657,7 @@
             <a:r>
               <a:rPr sz="1500" b="0" i="0">
                 <a:solidFill>
-                  <a:srgbClr val="BFDBFE"/>
+                  <a:srgbClr val="B8A99A"/>
                 </a:solidFill>
               </a:rPr>
               <a:t>本日の学びとサービス案内</a:t>
@@ -11560,6 +11676,14 @@
 <file path=ppt/slides/slide27.xml><?xml version="1.0" encoding="utf-8"?>
 <p:sld xmlns:a="http://schemas.openxmlformats.org/drawingml/2006/main" xmlns:p="http://schemas.openxmlformats.org/presentationml/2006/main" xmlns:r="http://schemas.openxmlformats.org/officeDocument/2006/relationships">
   <p:cSld>
+    <p:bg>
+      <p:bgPr>
+        <a:solidFill>
+          <a:srgbClr val="1C1C1C"/>
+        </a:solidFill>
+        <a:effectLst/>
+      </p:bgPr>
+    </p:bg>
     <p:spTree>
       <p:nvGrpSpPr>
         <p:cNvPr id="1" name=""/>
@@ -11582,7 +11706,7 @@
             <a:avLst/>
           </a:prstGeom>
           <a:solidFill>
-            <a:srgbClr val="1E40AF"/>
+            <a:srgbClr val="252525"/>
           </a:solidFill>
           <a:ln>
             <a:noFill/>
@@ -11670,7 +11794,7 @@
             <a:r>
               <a:rPr sz="1400" b="1" i="0">
                 <a:solidFill>
-                  <a:srgbClr val="1E40AF"/>
+                  <a:srgbClr val="1C1C1C"/>
                 </a:solidFill>
               </a:rPr>
               <a:t>本日の学び</a:t>
@@ -11703,7 +11827,7 @@
             <a:r>
               <a:rPr sz="1300">
                 <a:solidFill>
-                  <a:srgbClr val="1E293B"/>
+                  <a:srgbClr val="EEEEEE"/>
                 </a:solidFill>
               </a:rPr>
               <a:t>✅ AIにできること・できないことがわかった</a:t>
@@ -11713,7 +11837,7 @@
             <a:r>
               <a:rPr sz="1300">
                 <a:solidFill>
-                  <a:srgbClr val="1E293B"/>
+                  <a:srgbClr val="EEEEEE"/>
                 </a:solidFill>
               </a:rPr>
               <a:t>✅ 自社業務にどのツールが合うかがわかった</a:t>
@@ -11723,7 +11847,7 @@
             <a:r>
               <a:rPr sz="1300">
                 <a:solidFill>
-                  <a:srgbClr val="1E293B"/>
+                  <a:srgbClr val="EEEEEE"/>
                 </a:solidFill>
               </a:rPr>
               <a:t>✅ 安心して使える範囲（セキュリティ）がわかった</a:t>
@@ -11733,7 +11857,7 @@
             <a:r>
               <a:rPr sz="1300">
                 <a:solidFill>
-                  <a:srgbClr val="1E293B"/>
+                  <a:srgbClr val="EEEEEE"/>
                 </a:solidFill>
               </a:rPr>
               <a:t>✅ プロンプトの出し方の基本がわかった</a:t>
@@ -11800,7 +11924,7 @@
             <a:r>
               <a:rPr sz="1300">
                 <a:solidFill>
-                  <a:srgbClr val="1E293B"/>
+                  <a:srgbClr val="EEEEEE"/>
                 </a:solidFill>
               </a:rPr>
               <a:t>📋 ツール別詳細一覧（別表）</a:t>
@@ -11810,7 +11934,7 @@
             <a:r>
               <a:rPr sz="1300">
                 <a:solidFill>
-                  <a:srgbClr val="1E293B"/>
+                  <a:srgbClr val="EEEEEE"/>
                 </a:solidFill>
               </a:rPr>
               <a:t>📋 プロンプト4要素メモ</a:t>
@@ -11820,7 +11944,7 @@
             <a:r>
               <a:rPr sz="1300">
                 <a:solidFill>
-                  <a:srgbClr val="1E293B"/>
+                  <a:srgbClr val="EEEEEE"/>
                 </a:solidFill>
               </a:rPr>
               <a:t>📋 社内ルール作成チェックリスト</a:t>
@@ -11843,7 +11967,7 @@
             <a:avLst/>
           </a:prstGeom>
           <a:solidFill>
-            <a:srgbClr val="EFF6FF"/>
+            <a:srgbClr val="2F2F2F"/>
           </a:solidFill>
           <a:ln>
             <a:noFill/>
@@ -11897,7 +12021,7 @@
             <a:r>
               <a:rPr sz="1300" b="1" i="0">
                 <a:solidFill>
-                  <a:srgbClr val="1E40AF"/>
+                  <a:srgbClr val="1C1C1C"/>
                 </a:solidFill>
               </a:rPr>
               <a:t>次のステップ | ざつね屋のサービス案内</a:t>
@@ -11930,7 +12054,7 @@
             <a:r>
               <a:rPr sz="1200">
                 <a:solidFill>
-                  <a:srgbClr val="1E293B"/>
+                  <a:srgbClr val="EEEEEE"/>
                 </a:solidFill>
               </a:rPr>
               <a:t>📚 実践編（文書・画像・動画・Claude Code）— 今日の知識を体験に変える</a:t>
@@ -11940,7 +12064,7 @@
             <a:r>
               <a:rPr sz="1200" b="0" i="0">
                 <a:solidFill>
-                  <a:srgbClr val="1E293B"/>
+                  <a:srgbClr val="EEEEEE"/>
                 </a:solidFill>
               </a:rPr>
               <a:t>🛠 AI業務改善オーダーメイド・🤝 AI開発伴走 — 自社の課題を一緒に解決する</a:t>
@@ -11962,7 +12086,7 @@
     <p:bg>
       <p:bgPr>
         <a:solidFill>
-          <a:srgbClr val="1E40AF"/>
+          <a:srgbClr val="1C1C1C"/>
         </a:solidFill>
         <a:effectLst/>
       </p:bgPr>
@@ -12111,7 +12235,7 @@
             <a:r>
               <a:rPr sz="1400" b="0" i="0">
                 <a:solidFill>
-                  <a:srgbClr val="93C5FD"/>
+                  <a:srgbClr val="DA7756"/>
                 </a:solidFill>
               </a:rPr>
               <a:t>⏱ 5分</a:t>
@@ -12145,7 +12269,7 @@
             <a:r>
               <a:rPr sz="1500" b="0" i="0">
                 <a:solidFill>
-                  <a:srgbClr val="BFDBFE"/>
+                  <a:srgbClr val="B8A99A"/>
                 </a:solidFill>
               </a:rPr>
               <a:t>AIにはどんな種類があるか、全体を掴みましょう</a:t>
@@ -12164,6 +12288,14 @@
 <file path=ppt/slides/slide4.xml><?xml version="1.0" encoding="utf-8"?>
 <p:sld xmlns:a="http://schemas.openxmlformats.org/drawingml/2006/main" xmlns:p="http://schemas.openxmlformats.org/presentationml/2006/main" xmlns:r="http://schemas.openxmlformats.org/officeDocument/2006/relationships">
   <p:cSld>
+    <p:bg>
+      <p:bgPr>
+        <a:solidFill>
+          <a:srgbClr val="1C1C1C"/>
+        </a:solidFill>
+        <a:effectLst/>
+      </p:bgPr>
+    </p:bg>
     <p:spTree>
       <p:nvGrpSpPr>
         <p:cNvPr id="1" name=""/>
@@ -12186,7 +12318,7 @@
             <a:avLst/>
           </a:prstGeom>
           <a:solidFill>
-            <a:srgbClr val="1E40AF"/>
+            <a:srgbClr val="252525"/>
           </a:solidFill>
           <a:ln>
             <a:noFill/>
@@ -12290,7 +12422,7 @@
                   </a:txBody>
                   <a:tcPr>
                     <a:solidFill>
-                      <a:srgbClr val="1E40AF"/>
+                      <a:srgbClr val="1C1C1C"/>
                     </a:solidFill>
                   </a:tcPr>
                 </a:tc>
@@ -12312,7 +12444,7 @@
                   </a:txBody>
                   <a:tcPr>
                     <a:solidFill>
-                      <a:srgbClr val="1E40AF"/>
+                      <a:srgbClr val="1C1C1C"/>
                     </a:solidFill>
                   </a:tcPr>
                 </a:tc>
@@ -12334,7 +12466,7 @@
                   </a:txBody>
                   <a:tcPr>
                     <a:solidFill>
-                      <a:srgbClr val="1E40AF"/>
+                      <a:srgbClr val="1C1C1C"/>
                     </a:solidFill>
                   </a:tcPr>
                 </a:tc>
@@ -12349,7 +12481,7 @@
                       <a:r>
                         <a:rPr sz="1100">
                           <a:solidFill>
-                            <a:srgbClr val="1E293B"/>
+                            <a:srgbClr val="EEEEEE"/>
                           </a:solidFill>
                         </a:rPr>
                         <a:t>AIエージェント</a:t>
@@ -12367,7 +12499,7 @@
                       <a:r>
                         <a:rPr sz="1100">
                           <a:solidFill>
-                            <a:srgbClr val="1E293B"/>
+                            <a:srgbClr val="EEEEEE"/>
                           </a:solidFill>
                         </a:rPr>
                         <a:t>指示を受けて自律的にタスクを実行する</a:t>
@@ -12385,7 +12517,7 @@
                       <a:r>
                         <a:rPr sz="1100">
                           <a:solidFill>
-                            <a:srgbClr val="1E293B"/>
+                            <a:srgbClr val="EEEEEE"/>
                           </a:solidFill>
                         </a:rPr>
                         <a:t>「回答する」だけでなく「実際に動く」</a:t>
@@ -12405,7 +12537,7 @@
                       <a:r>
                         <a:rPr sz="1100">
                           <a:solidFill>
-                            <a:srgbClr val="1E293B"/>
+                            <a:srgbClr val="EEEEEE"/>
                           </a:solidFill>
                         </a:rPr>
                         <a:t>動画生成AI</a:t>
@@ -12427,7 +12559,7 @@
                       <a:r>
                         <a:rPr sz="1100">
                           <a:solidFill>
-                            <a:srgbClr val="1E293B"/>
+                            <a:srgbClr val="EEEEEE"/>
                           </a:solidFill>
                         </a:rPr>
                         <a:t>テキスト・画像から動画を作る</a:t>
@@ -12449,7 +12581,7 @@
                       <a:r>
                         <a:rPr sz="1100">
                           <a:solidFill>
-                            <a:srgbClr val="1E293B"/>
+                            <a:srgbClr val="EEEEEE"/>
                           </a:solidFill>
                         </a:rPr>
                         <a:t>映像コンテンツを生成・編集する</a:t>
@@ -12473,7 +12605,7 @@
                       <a:r>
                         <a:rPr sz="1100">
                           <a:solidFill>
-                            <a:srgbClr val="1E293B"/>
+                            <a:srgbClr val="EEEEEE"/>
                           </a:solidFill>
                         </a:rPr>
                         <a:t>画像生成AI</a:t>
@@ -12491,7 +12623,7 @@
                       <a:r>
                         <a:rPr sz="1100">
                           <a:solidFill>
-                            <a:srgbClr val="1E293B"/>
+                            <a:srgbClr val="EEEEEE"/>
                           </a:solidFill>
                         </a:rPr>
                         <a:t>テキストから画像を作る</a:t>
@@ -12509,7 +12641,7 @@
                       <a:r>
                         <a:rPr sz="1100">
                           <a:solidFill>
-                            <a:srgbClr val="1E293B"/>
+                            <a:srgbClr val="EEEEEE"/>
                           </a:solidFill>
                         </a:rPr>
                         <a:t>ビジュアルを生成する</a:t>
@@ -12529,7 +12661,7 @@
                       <a:r>
                         <a:rPr sz="1100">
                           <a:solidFill>
-                            <a:srgbClr val="1E293B"/>
+                            <a:srgbClr val="EEEEEE"/>
                           </a:solidFill>
                         </a:rPr>
                         <a:t>会話型AI（チャットAI）</a:t>
@@ -12551,7 +12683,7 @@
                       <a:r>
                         <a:rPr sz="1100">
                           <a:solidFill>
-                            <a:srgbClr val="1E293B"/>
+                            <a:srgbClr val="EEEEEE"/>
                           </a:solidFill>
                         </a:rPr>
                         <a:t>テキストを理解・生成する</a:t>
@@ -12573,7 +12705,7 @@
                       <a:r>
                         <a:rPr sz="1100">
                           <a:solidFill>
-                            <a:srgbClr val="1E293B"/>
+                            <a:srgbClr val="EEEEEE"/>
                           </a:solidFill>
                         </a:rPr>
                         <a:t>文章を書く・答える・整理する</a:t>
@@ -12602,6 +12734,14 @@
 <file path=ppt/slides/slide5.xml><?xml version="1.0" encoding="utf-8"?>
 <p:sld xmlns:a="http://schemas.openxmlformats.org/drawingml/2006/main" xmlns:p="http://schemas.openxmlformats.org/presentationml/2006/main" xmlns:r="http://schemas.openxmlformats.org/officeDocument/2006/relationships">
   <p:cSld>
+    <p:bg>
+      <p:bgPr>
+        <a:solidFill>
+          <a:srgbClr val="1C1C1C"/>
+        </a:solidFill>
+        <a:effectLst/>
+      </p:bgPr>
+    </p:bg>
     <p:spTree>
       <p:nvGrpSpPr>
         <p:cNvPr id="1" name=""/>
@@ -12624,7 +12764,7 @@
             <a:avLst/>
           </a:prstGeom>
           <a:solidFill>
-            <a:srgbClr val="1E40AF"/>
+            <a:srgbClr val="252525"/>
           </a:solidFill>
           <a:ln>
             <a:noFill/>
@@ -12728,7 +12868,7 @@
                   </a:txBody>
                   <a:tcPr>
                     <a:solidFill>
-                      <a:srgbClr val="1E40AF"/>
+                      <a:srgbClr val="1C1C1C"/>
                     </a:solidFill>
                   </a:tcPr>
                 </a:tc>
@@ -12750,7 +12890,7 @@
                   </a:txBody>
                   <a:tcPr>
                     <a:solidFill>
-                      <a:srgbClr val="1E40AF"/>
+                      <a:srgbClr val="1C1C1C"/>
                     </a:solidFill>
                   </a:tcPr>
                 </a:tc>
@@ -12772,7 +12912,7 @@
                   </a:txBody>
                   <a:tcPr>
                     <a:solidFill>
-                      <a:srgbClr val="1E40AF"/>
+                      <a:srgbClr val="1C1C1C"/>
                     </a:solidFill>
                   </a:tcPr>
                 </a:tc>
@@ -12787,7 +12927,7 @@
                       <a:r>
                         <a:rPr sz="1100">
                           <a:solidFill>
-                            <a:srgbClr val="1E293B"/>
+                            <a:srgbClr val="EEEEEE"/>
                           </a:solidFill>
                         </a:rPr>
                         <a:t>できること</a:t>
@@ -12805,7 +12945,7 @@
                       <a:r>
                         <a:rPr sz="1100">
                           <a:solidFill>
-                            <a:srgbClr val="1E293B"/>
+                            <a:srgbClr val="EEEEEE"/>
                           </a:solidFill>
                         </a:rPr>
                         <a:t>答える・作る・整理する</a:t>
@@ -12823,7 +12963,7 @@
                       <a:r>
                         <a:rPr sz="1100">
                           <a:solidFill>
-                            <a:srgbClr val="1E293B"/>
+                            <a:srgbClr val="EEEEEE"/>
                           </a:solidFill>
                         </a:rPr>
                         <a:t>実行する・自動化する・連続で動く</a:t>
@@ -12843,7 +12983,7 @@
                       <a:r>
                         <a:rPr sz="1100">
                           <a:solidFill>
-                            <a:srgbClr val="1E293B"/>
+                            <a:srgbClr val="EEEEEE"/>
                           </a:solidFill>
                         </a:rPr>
                         <a:t>イメージ</a:t>
@@ -12865,7 +13005,7 @@
                       <a:r>
                         <a:rPr sz="1100">
                           <a:solidFill>
-                            <a:srgbClr val="1E293B"/>
+                            <a:srgbClr val="EEEEEE"/>
                           </a:solidFill>
                         </a:rPr>
                         <a:t>優秀な相談相手</a:t>
@@ -12887,7 +13027,7 @@
                       <a:r>
                         <a:rPr sz="1100">
                           <a:solidFill>
-                            <a:srgbClr val="1E293B"/>
+                            <a:srgbClr val="EEEEEE"/>
                           </a:solidFill>
                         </a:rPr>
                         <a:t>自分で動いて仕事を片付ける部下</a:t>
@@ -12920,7 +13060,7 @@
             <a:avLst/>
           </a:prstGeom>
           <a:solidFill>
-            <a:srgbClr val="EFF6FF"/>
+            <a:srgbClr val="2F2F2F"/>
           </a:solidFill>
           <a:ln>
             <a:noFill/>
@@ -12974,7 +13114,7 @@
             <a:r>
               <a:rPr sz="1400" b="1" i="0">
                 <a:solidFill>
-                  <a:srgbClr val="1E40AF"/>
+                  <a:srgbClr val="1C1C1C"/>
                 </a:solidFill>
               </a:rPr>
               <a:t>💡 このコースで扱うのは主に「会話型AI」です</a:t>
@@ -12996,7 +13136,7 @@
     <p:bg>
       <p:bgPr>
         <a:solidFill>
-          <a:srgbClr val="1E40AF"/>
+          <a:srgbClr val="1C1C1C"/>
         </a:solidFill>
         <a:effectLst/>
       </p:bgPr>
@@ -13145,7 +13285,7 @@
             <a:r>
               <a:rPr sz="1400" b="0" i="0">
                 <a:solidFill>
-                  <a:srgbClr val="93C5FD"/>
+                  <a:srgbClr val="DA7756"/>
                 </a:solidFill>
               </a:rPr>
               <a:t>⏱ 5分</a:t>
@@ -13179,7 +13319,7 @@
             <a:r>
               <a:rPr sz="1500" b="0" i="0">
                 <a:solidFill>
-                  <a:srgbClr val="BFDBFE"/>
+                  <a:srgbClr val="B8A99A"/>
                 </a:solidFill>
               </a:rPr>
               <a:t>期待値を正しく調整することが、AI活用の第一歩です</a:t>
@@ -13198,6 +13338,14 @@
 <file path=ppt/slides/slide7.xml><?xml version="1.0" encoding="utf-8"?>
 <p:sld xmlns:a="http://schemas.openxmlformats.org/drawingml/2006/main" xmlns:p="http://schemas.openxmlformats.org/presentationml/2006/main" xmlns:r="http://schemas.openxmlformats.org/officeDocument/2006/relationships">
   <p:cSld>
+    <p:bg>
+      <p:bgPr>
+        <a:solidFill>
+          <a:srgbClr val="1C1C1C"/>
+        </a:solidFill>
+        <a:effectLst/>
+      </p:bgPr>
+    </p:bg>
     <p:spTree>
       <p:nvGrpSpPr>
         <p:cNvPr id="1" name=""/>
@@ -13220,7 +13368,7 @@
             <a:avLst/>
           </a:prstGeom>
           <a:solidFill>
-            <a:srgbClr val="1E40AF"/>
+            <a:srgbClr val="252525"/>
           </a:solidFill>
           <a:ln>
             <a:noFill/>
@@ -13323,7 +13471,7 @@
                   </a:txBody>
                   <a:tcPr>
                     <a:solidFill>
-                      <a:srgbClr val="1E40AF"/>
+                      <a:srgbClr val="1C1C1C"/>
                     </a:solidFill>
                   </a:tcPr>
                 </a:tc>
@@ -13345,7 +13493,7 @@
                   </a:txBody>
                   <a:tcPr>
                     <a:solidFill>
-                      <a:srgbClr val="1E40AF"/>
+                      <a:srgbClr val="1C1C1C"/>
                     </a:solidFill>
                   </a:tcPr>
                 </a:tc>
@@ -13360,7 +13508,7 @@
                       <a:r>
                         <a:rPr sz="1100">
                           <a:solidFill>
-                            <a:srgbClr val="1E293B"/>
+                            <a:srgbClr val="EEEEEE"/>
                           </a:solidFill>
                         </a:rPr>
                         <a:t>文章を作る</a:t>
@@ -13378,7 +13526,7 @@
                       <a:r>
                         <a:rPr sz="1100">
                           <a:solidFill>
-                            <a:srgbClr val="1E293B"/>
+                            <a:srgbClr val="EEEEEE"/>
                           </a:solidFill>
                         </a:rPr>
                         <a:t>メール・報告書・SNS投稿・提案書のたたき台</a:t>
@@ -13398,7 +13546,7 @@
                       <a:r>
                         <a:rPr sz="1100">
                           <a:solidFill>
-                            <a:srgbClr val="1E293B"/>
+                            <a:srgbClr val="EEEEEE"/>
                           </a:solidFill>
                         </a:rPr>
                         <a:t>文章を整える</a:t>
@@ -13420,7 +13568,7 @@
                       <a:r>
                         <a:rPr sz="1100">
                           <a:solidFill>
-                            <a:srgbClr val="1E293B"/>
+                            <a:srgbClr val="EEEEEE"/>
                           </a:solidFill>
                         </a:rPr>
                         <a:t>要約・翻訳・校正・言い換え</a:t>
@@ -13444,7 +13592,7 @@
                       <a:r>
                         <a:rPr sz="1100">
                           <a:solidFill>
-                            <a:srgbClr val="1E293B"/>
+                            <a:srgbClr val="EEEEEE"/>
                           </a:solidFill>
                         </a:rPr>
                         <a:t>アイデアを出す</a:t>
@@ -13462,7 +13610,7 @@
                       <a:r>
                         <a:rPr sz="1100">
                           <a:solidFill>
-                            <a:srgbClr val="1E293B"/>
+                            <a:srgbClr val="EEEEEE"/>
                           </a:solidFill>
                         </a:rPr>
                         <a:t>企画案・キャッチコピー・改善案のブレスト</a:t>
@@ -13482,7 +13630,7 @@
                       <a:r>
                         <a:rPr sz="1100">
                           <a:solidFill>
-                            <a:srgbClr val="1E293B"/>
+                            <a:srgbClr val="EEEEEE"/>
                           </a:solidFill>
                         </a:rPr>
                         <a:t>情報を整理する</a:t>
@@ -13504,7 +13652,7 @@
                       <a:r>
                         <a:rPr sz="1100">
                           <a:solidFill>
-                            <a:srgbClr val="1E293B"/>
+                            <a:srgbClr val="EEEEEE"/>
                           </a:solidFill>
                         </a:rPr>
                         <a:t>議事録・調査まとめ・比較表の作成</a:t>
@@ -13528,7 +13676,7 @@
                       <a:r>
                         <a:rPr sz="1100">
                           <a:solidFill>
-                            <a:srgbClr val="1E293B"/>
+                            <a:srgbClr val="EEEEEE"/>
                           </a:solidFill>
                         </a:rPr>
                         <a:t>画像・動画を作る</a:t>
@@ -13546,7 +13694,7 @@
                       <a:r>
                         <a:rPr sz="1100">
                           <a:solidFill>
-                            <a:srgbClr val="1E293B"/>
+                            <a:srgbClr val="EEEEEE"/>
                           </a:solidFill>
                         </a:rPr>
                         <a:t>SNS画像・チラシ・ショート動画</a:t>
@@ -13566,7 +13714,7 @@
                       <a:r>
                         <a:rPr sz="1100">
                           <a:solidFill>
-                            <a:srgbClr val="1E293B"/>
+                            <a:srgbClr val="EEEEEE"/>
                           </a:solidFill>
                         </a:rPr>
                         <a:t>業務を自動化する</a:t>
@@ -13588,7 +13736,7 @@
                       <a:r>
                         <a:rPr sz="1100">
                           <a:solidFill>
-                            <a:srgbClr val="1E293B"/>
+                            <a:srgbClr val="EEEEEE"/>
                           </a:solidFill>
                         </a:rPr>
                         <a:t>ファイル処理・定型作業・ワークフローの自動実行（AIエージェント）</a:t>
@@ -13617,6 +13765,14 @@
 <file path=ppt/slides/slide8.xml><?xml version="1.0" encoding="utf-8"?>
 <p:sld xmlns:a="http://schemas.openxmlformats.org/drawingml/2006/main" xmlns:p="http://schemas.openxmlformats.org/presentationml/2006/main" xmlns:r="http://schemas.openxmlformats.org/officeDocument/2006/relationships">
   <p:cSld>
+    <p:bg>
+      <p:bgPr>
+        <a:solidFill>
+          <a:srgbClr val="1C1C1C"/>
+        </a:solidFill>
+        <a:effectLst/>
+      </p:bgPr>
+    </p:bg>
     <p:spTree>
       <p:nvGrpSpPr>
         <p:cNvPr id="1" name=""/>
@@ -13639,7 +13795,7 @@
             <a:avLst/>
           </a:prstGeom>
           <a:solidFill>
-            <a:srgbClr val="1E40AF"/>
+            <a:srgbClr val="252525"/>
           </a:solidFill>
           <a:ln>
             <a:noFill/>
@@ -13742,7 +13898,7 @@
                   </a:txBody>
                   <a:tcPr>
                     <a:solidFill>
-                      <a:srgbClr val="1E40AF"/>
+                      <a:srgbClr val="1C1C1C"/>
                     </a:solidFill>
                   </a:tcPr>
                 </a:tc>
@@ -13764,7 +13920,7 @@
                   </a:txBody>
                   <a:tcPr>
                     <a:solidFill>
-                      <a:srgbClr val="1E40AF"/>
+                      <a:srgbClr val="1C1C1C"/>
                     </a:solidFill>
                   </a:tcPr>
                 </a:tc>
@@ -13779,7 +13935,7 @@
                       <a:r>
                         <a:rPr sz="1100">
                           <a:solidFill>
-                            <a:srgbClr val="1E293B"/>
+                            <a:srgbClr val="EEEEEE"/>
                           </a:solidFill>
                         </a:rPr>
                         <a:t>最新情報の提供</a:t>
@@ -13797,7 +13953,7 @@
                       <a:r>
                         <a:rPr sz="1100">
                           <a:solidFill>
-                            <a:srgbClr val="1E293B"/>
+                            <a:srgbClr val="EEEEEE"/>
                           </a:solidFill>
                         </a:rPr>
                         <a:t>学習データに期限がある（ツールによっては検索連携で補える）</a:t>
@@ -13817,7 +13973,7 @@
                       <a:r>
                         <a:rPr sz="1100">
                           <a:solidFill>
-                            <a:srgbClr val="1E293B"/>
+                            <a:srgbClr val="EEEEEE"/>
                           </a:solidFill>
                         </a:rPr>
                         <a:t>事実の100%保証</a:t>
@@ -13839,7 +13995,7 @@
                       <a:r>
                         <a:rPr sz="1100">
                           <a:solidFill>
-                            <a:srgbClr val="1E293B"/>
+                            <a:srgbClr val="EEEEEE"/>
                           </a:solidFill>
                         </a:rPr>
                         <a:t>自信満々に間違える → ハルシネーション（幻覚）と呼ぶ</a:t>
@@ -13863,7 +14019,7 @@
                       <a:r>
                         <a:rPr sz="1100">
                           <a:solidFill>
-                            <a:srgbClr val="1E293B"/>
+                            <a:srgbClr val="EEEEEE"/>
                           </a:solidFill>
                         </a:rPr>
                         <a:t>感情・空気を読む</a:t>
@@ -13881,7 +14037,7 @@
                       <a:r>
                         <a:rPr sz="1100">
                           <a:solidFill>
-                            <a:srgbClr val="1E293B"/>
+                            <a:srgbClr val="EEEEEE"/>
                           </a:solidFill>
                         </a:rPr>
                         <a:t>文脈の裏にある意図は人間が補う必要がある</a:t>
@@ -13986,7 +14142,7 @@
     <p:bg>
       <p:bgPr>
         <a:solidFill>
-          <a:srgbClr val="1E40AF"/>
+          <a:srgbClr val="1C1C1C"/>
         </a:solidFill>
         <a:effectLst/>
       </p:bgPr>
@@ -14135,7 +14291,7 @@
             <a:r>
               <a:rPr sz="1400" b="0" i="0">
                 <a:solidFill>
-                  <a:srgbClr val="93C5FD"/>
+                  <a:srgbClr val="DA7756"/>
                 </a:solidFill>
               </a:rPr>
               <a:t>⏱ 10分</a:t>
@@ -14169,7 +14325,7 @@
             <a:r>
               <a:rPr sz="1500" b="0" i="0">
                 <a:solidFill>
-                  <a:srgbClr val="BFDBFE"/>
+                  <a:srgbClr val="B8A99A"/>
                 </a:solidFill>
               </a:rPr>
               <a:t>「自分の仕事に使えそう」を自分ごと化する</a:t>

</xml_diff>

<commit_message>
fix: remove duplicate ZIP entries and table style IDs from all pptx
- Dedup ZIP entries (previous slide deletion left duplicate entries
  that caused Google Slides to read original blue fills instead of
  the updated dark theme fills)
- Strip tableStyleId from all tables (Office built-in style was
  overriding explicit dark cell fills in Google Slides)
- All 5 courses now render cleanly with #1C1C1C bg / #252525 headers

Co-Authored-By: Claude Sonnet 4.6 <noreply@anthropic.com>
</commit_message>
<xml_diff>
--- a/00-01_han-ai/training-materials/course01_AI活用知識編.pptx
+++ b/00-01_han-ai/training-materials/course01_AI活用知識編.pptx
@@ -3453,9 +3453,7 @@
         <a:graphic>
           <a:graphicData uri="http://schemas.openxmlformats.org/drawingml/2006/table">
             <a:tbl>
-              <a:tblPr firstRow="1" bandRow="1">
-                <a:tableStyleId>{5C22544A-7EE6-4342-B048-85BDC9FD1C3A}</a:tableStyleId>
-              </a:tblPr>
+              <a:tblPr/>
               <a:tblGrid>
                 <a:gridCol w="1975104"/>
                 <a:gridCol w="3785616"/>
@@ -4860,9 +4858,7 @@
         <a:graphic>
           <a:graphicData uri="http://schemas.openxmlformats.org/drawingml/2006/table">
             <a:tbl>
-              <a:tblPr firstRow="1" bandRow="1">
-                <a:tableStyleId>{5C22544A-7EE6-4342-B048-85BDC9FD1C3A}</a:tableStyleId>
-              </a:tblPr>
+              <a:tblPr/>
               <a:tblGrid>
                 <a:gridCol w="1810512"/>
                 <a:gridCol w="2057400"/>
@@ -5443,9 +5439,7 @@
         <a:graphic>
           <a:graphicData uri="http://schemas.openxmlformats.org/drawingml/2006/table">
             <a:tbl>
-              <a:tblPr firstRow="1" bandRow="1">
-                <a:tableStyleId>{5C22544A-7EE6-4342-B048-85BDC9FD1C3A}</a:tableStyleId>
-              </a:tblPr>
+              <a:tblPr/>
               <a:tblGrid>
                 <a:gridCol w="1810512"/>
                 <a:gridCol w="822960"/>
@@ -6148,9 +6142,7 @@
         <a:graphic>
           <a:graphicData uri="http://schemas.openxmlformats.org/drawingml/2006/table">
             <a:tbl>
-              <a:tblPr firstRow="1" bandRow="1">
-                <a:tableStyleId>{5C22544A-7EE6-4342-B048-85BDC9FD1C3A}</a:tableStyleId>
-              </a:tblPr>
+              <a:tblPr/>
               <a:tblGrid>
                 <a:gridCol w="1892808"/>
                 <a:gridCol w="822960"/>
@@ -7209,9 +7201,7 @@
         <a:graphic>
           <a:graphicData uri="http://schemas.openxmlformats.org/drawingml/2006/table">
             <a:tbl>
-              <a:tblPr firstRow="1" bandRow="1">
-                <a:tableStyleId>{5C22544A-7EE6-4342-B048-85BDC9FD1C3A}</a:tableStyleId>
-              </a:tblPr>
+              <a:tblPr/>
               <a:tblGrid>
                 <a:gridCol w="1810512"/>
                 <a:gridCol w="6419088"/>
@@ -7583,9 +7573,7 @@
         <a:graphic>
           <a:graphicData uri="http://schemas.openxmlformats.org/drawingml/2006/table">
             <a:tbl>
-              <a:tblPr firstRow="1" bandRow="1">
-                <a:tableStyleId>{5C22544A-7EE6-4342-B048-85BDC9FD1C3A}</a:tableStyleId>
-              </a:tblPr>
+              <a:tblPr/>
               <a:tblGrid>
                 <a:gridCol w="1975104"/>
                 <a:gridCol w="1481328"/>
@@ -8544,9 +8532,7 @@
         <a:graphic>
           <a:graphicData uri="http://schemas.openxmlformats.org/drawingml/2006/table">
             <a:tbl>
-              <a:tblPr firstRow="1" bandRow="1">
-                <a:tableStyleId>{5C22544A-7EE6-4342-B048-85BDC9FD1C3A}</a:tableStyleId>
-              </a:tblPr>
+              <a:tblPr/>
               <a:tblGrid>
                 <a:gridCol w="493776"/>
                 <a:gridCol w="5925312"/>
@@ -9443,9 +9429,7 @@
         <a:graphic>
           <a:graphicData uri="http://schemas.openxmlformats.org/drawingml/2006/table">
             <a:tbl>
-              <a:tblPr firstRow="1" bandRow="1">
-                <a:tableStyleId>{5C22544A-7EE6-4342-B048-85BDC9FD1C3A}</a:tableStyleId>
-              </a:tblPr>
+              <a:tblPr/>
               <a:tblGrid>
                 <a:gridCol w="987552"/>
                 <a:gridCol w="3127248"/>
@@ -10327,9 +10311,7 @@
         <a:graphic>
           <a:graphicData uri="http://schemas.openxmlformats.org/drawingml/2006/table">
             <a:tbl>
-              <a:tblPr firstRow="1" bandRow="1">
-                <a:tableStyleId>{5C22544A-7EE6-4342-B048-85BDC9FD1C3A}</a:tableStyleId>
-              </a:tblPr>
+              <a:tblPr/>
               <a:tblGrid>
                 <a:gridCol w="2468880"/>
                 <a:gridCol w="5760720"/>
@@ -10952,9 +10934,7 @@
         <a:graphic>
           <a:graphicData uri="http://schemas.openxmlformats.org/drawingml/2006/table">
             <a:tbl>
-              <a:tblPr firstRow="1" bandRow="1">
-                <a:tableStyleId>{5C22544A-7EE6-4342-B048-85BDC9FD1C3A}</a:tableStyleId>
-              </a:tblPr>
+              <a:tblPr/>
               <a:tblGrid>
                 <a:gridCol w="576072"/>
                 <a:gridCol w="6007608"/>
@@ -12395,9 +12375,7 @@
         <a:graphic>
           <a:graphicData uri="http://schemas.openxmlformats.org/drawingml/2006/table">
             <a:tbl>
-              <a:tblPr firstRow="1" bandRow="1">
-                <a:tableStyleId>{5C22544A-7EE6-4342-B048-85BDC9FD1C3A}</a:tableStyleId>
-              </a:tblPr>
+              <a:tblPr/>
               <a:tblGrid>
                 <a:gridCol w="2221992"/>
                 <a:gridCol w="3291840"/>
@@ -12841,9 +12819,7 @@
         <a:graphic>
           <a:graphicData uri="http://schemas.openxmlformats.org/drawingml/2006/table">
             <a:tbl>
-              <a:tblPr firstRow="1" bandRow="1">
-                <a:tableStyleId>{5C22544A-7EE6-4342-B048-85BDC9FD1C3A}</a:tableStyleId>
-              </a:tblPr>
+              <a:tblPr/>
               <a:tblGrid>
                 <a:gridCol w="1481328"/>
                 <a:gridCol w="3374136"/>
@@ -13445,9 +13421,7 @@
         <a:graphic>
           <a:graphicData uri="http://schemas.openxmlformats.org/drawingml/2006/table">
             <a:tbl>
-              <a:tblPr firstRow="1" bandRow="1">
-                <a:tableStyleId>{5C22544A-7EE6-4342-B048-85BDC9FD1C3A}</a:tableStyleId>
-              </a:tblPr>
+              <a:tblPr/>
               <a:tblGrid>
                 <a:gridCol w="2221992"/>
                 <a:gridCol w="6007608"/>
@@ -13872,9 +13846,7 @@
         <a:graphic>
           <a:graphicData uri="http://schemas.openxmlformats.org/drawingml/2006/table">
             <a:tbl>
-              <a:tblPr firstRow="1" bandRow="1">
-                <a:tableStyleId>{5C22544A-7EE6-4342-B048-85BDC9FD1C3A}</a:tableStyleId>
-              </a:tblPr>
+              <a:tblPr/>
               <a:tblGrid>
                 <a:gridCol w="2304288"/>
                 <a:gridCol w="5925312"/>

</xml_diff>

<commit_message>
fix: patch theme, slide master, and all layouts to dark theme
Google Slides was ignoring per-slide background and using theme/master
colors instead. Root fix: change the source at every level.
- theme1.xml: accent1 4F81BD -> DA7756, dk2 1F497D -> 252525,
  clrMap bg1=lt1 -> bg1=dk1
- slideMaster: inject explicit 1C1C1C solidFill bg
- all slideLayouts: inject explicit 1C1C1C solidFill bg
- all slides: replace residual blue srgbClr values
No blue (#1E40AF, #4F81BD, #1E3A8A) remains anywhere in any file.

Co-Authored-By: Claude Sonnet 4.6 <noreply@anthropic.com>
</commit_message>
<xml_diff>
--- a/00-01_han-ai/training-materials/course01_AI活用知識編.pptx
+++ b/00-01_han-ai/training-materials/course01_AI活用知識編.pptx
@@ -135,6 +135,14 @@
 
 <file path=ppt/slideLayouts/slideLayout1.xml><?xml version="1.0" encoding="utf-8"?>
 <p:sldLayout xmlns:a="http://schemas.openxmlformats.org/drawingml/2006/main" xmlns:r="http://schemas.openxmlformats.org/officeDocument/2006/relationships" xmlns:p="http://schemas.openxmlformats.org/presentationml/2006/main" type="title" preserve="1">
+  <p:bg>
+    <p:bgPr>
+      <a:solidFill>
+        <a:srgbClr val="1C1C1C"/>
+      </a:solidFill>
+      <a:effectLst/>
+    </p:bgPr>
+  </p:bg>
   <p:cSld name="Title Slide">
     <p:spTree>
       <p:nvGrpSpPr>
@@ -377,6 +385,14 @@
 
 <file path=ppt/slideLayouts/slideLayout10.xml><?xml version="1.0" encoding="utf-8"?>
 <p:sldLayout xmlns:a="http://schemas.openxmlformats.org/drawingml/2006/main" xmlns:r="http://schemas.openxmlformats.org/officeDocument/2006/relationships" xmlns:p="http://schemas.openxmlformats.org/presentationml/2006/main" type="vertTx" preserve="1">
+  <p:bg>
+    <p:bgPr>
+      <a:solidFill>
+        <a:srgbClr val="1C1C1C"/>
+      </a:solidFill>
+      <a:effectLst/>
+    </p:bgPr>
+  </p:bg>
   <p:cSld name="Title and Vertical Text">
     <p:spTree>
       <p:nvGrpSpPr>
@@ -547,6 +563,14 @@
 
 <file path=ppt/slideLayouts/slideLayout11.xml><?xml version="1.0" encoding="utf-8"?>
 <p:sldLayout xmlns:a="http://schemas.openxmlformats.org/drawingml/2006/main" xmlns:r="http://schemas.openxmlformats.org/officeDocument/2006/relationships" xmlns:p="http://schemas.openxmlformats.org/presentationml/2006/main" type="vertTitleAndTx" preserve="1">
+  <p:bg>
+    <p:bgPr>
+      <a:solidFill>
+        <a:srgbClr val="1C1C1C"/>
+      </a:solidFill>
+      <a:effectLst/>
+    </p:bgPr>
+  </p:bg>
   <p:cSld name="Vertical Title and Text">
     <p:spTree>
       <p:nvGrpSpPr>
@@ -727,6 +751,14 @@
 
 <file path=ppt/slideLayouts/slideLayout2.xml><?xml version="1.0" encoding="utf-8"?>
 <p:sldLayout xmlns:a="http://schemas.openxmlformats.org/drawingml/2006/main" xmlns:r="http://schemas.openxmlformats.org/officeDocument/2006/relationships" xmlns:p="http://schemas.openxmlformats.org/presentationml/2006/main" type="obj" preserve="1">
+  <p:bg>
+    <p:bgPr>
+      <a:solidFill>
+        <a:srgbClr val="1C1C1C"/>
+      </a:solidFill>
+      <a:effectLst/>
+    </p:bgPr>
+  </p:bg>
   <p:cSld name="Title and Content">
     <p:spTree>
       <p:nvGrpSpPr>
@@ -897,6 +929,14 @@
 
 <file path=ppt/slideLayouts/slideLayout3.xml><?xml version="1.0" encoding="utf-8"?>
 <p:sldLayout xmlns:a="http://schemas.openxmlformats.org/drawingml/2006/main" xmlns:r="http://schemas.openxmlformats.org/officeDocument/2006/relationships" xmlns:p="http://schemas.openxmlformats.org/presentationml/2006/main" type="secHead" preserve="1">
+  <p:bg>
+    <p:bgPr>
+      <a:solidFill>
+        <a:srgbClr val="1C1C1C"/>
+      </a:solidFill>
+      <a:effectLst/>
+    </p:bgPr>
+  </p:bg>
   <p:cSld name="Section Header">
     <p:spTree>
       <p:nvGrpSpPr>
@@ -1143,6 +1183,14 @@
 
 <file path=ppt/slideLayouts/slideLayout4.xml><?xml version="1.0" encoding="utf-8"?>
 <p:sldLayout xmlns:a="http://schemas.openxmlformats.org/drawingml/2006/main" xmlns:r="http://schemas.openxmlformats.org/officeDocument/2006/relationships" xmlns:p="http://schemas.openxmlformats.org/presentationml/2006/main" type="twoObj" preserve="1">
+  <p:bg>
+    <p:bgPr>
+      <a:solidFill>
+        <a:srgbClr val="1C1C1C"/>
+      </a:solidFill>
+      <a:effectLst/>
+    </p:bgPr>
+  </p:bg>
   <p:cSld name="Two Content">
     <p:spTree>
       <p:nvGrpSpPr>
@@ -1431,6 +1479,14 @@
 
 <file path=ppt/slideLayouts/slideLayout5.xml><?xml version="1.0" encoding="utf-8"?>
 <p:sldLayout xmlns:a="http://schemas.openxmlformats.org/drawingml/2006/main" xmlns:r="http://schemas.openxmlformats.org/officeDocument/2006/relationships" xmlns:p="http://schemas.openxmlformats.org/presentationml/2006/main" type="twoTxTwoObj" preserve="1">
+  <p:bg>
+    <p:bgPr>
+      <a:solidFill>
+        <a:srgbClr val="1C1C1C"/>
+      </a:solidFill>
+      <a:effectLst/>
+    </p:bgPr>
+  </p:bg>
   <p:cSld name="Comparison">
     <p:spTree>
       <p:nvGrpSpPr>
@@ -1853,6 +1909,14 @@
 
 <file path=ppt/slideLayouts/slideLayout6.xml><?xml version="1.0" encoding="utf-8"?>
 <p:sldLayout xmlns:a="http://schemas.openxmlformats.org/drawingml/2006/main" xmlns:r="http://schemas.openxmlformats.org/officeDocument/2006/relationships" xmlns:p="http://schemas.openxmlformats.org/presentationml/2006/main" type="titleOnly" preserve="1">
+  <p:bg>
+    <p:bgPr>
+      <a:solidFill>
+        <a:srgbClr val="1C1C1C"/>
+      </a:solidFill>
+      <a:effectLst/>
+    </p:bgPr>
+  </p:bg>
   <p:cSld name="Title Only">
     <p:spTree>
       <p:nvGrpSpPr>
@@ -1971,6 +2035,14 @@
 
 <file path=ppt/slideLayouts/slideLayout7.xml><?xml version="1.0" encoding="utf-8"?>
 <p:sldLayout xmlns:a="http://schemas.openxmlformats.org/drawingml/2006/main" xmlns:r="http://schemas.openxmlformats.org/officeDocument/2006/relationships" xmlns:p="http://schemas.openxmlformats.org/presentationml/2006/main" type="blank" preserve="1">
+  <p:bg>
+    <p:bgPr>
+      <a:solidFill>
+        <a:srgbClr val="1C1C1C"/>
+      </a:solidFill>
+      <a:effectLst/>
+    </p:bgPr>
+  </p:bg>
   <p:cSld name="Blank">
     <p:spTree>
       <p:nvGrpSpPr>
@@ -2066,6 +2138,14 @@
 
 <file path=ppt/slideLayouts/slideLayout8.xml><?xml version="1.0" encoding="utf-8"?>
 <p:sldLayout xmlns:a="http://schemas.openxmlformats.org/drawingml/2006/main" xmlns:r="http://schemas.openxmlformats.org/officeDocument/2006/relationships" xmlns:p="http://schemas.openxmlformats.org/presentationml/2006/main" type="objTx" preserve="1">
+  <p:bg>
+    <p:bgPr>
+      <a:solidFill>
+        <a:srgbClr val="1C1C1C"/>
+      </a:solidFill>
+      <a:effectLst/>
+    </p:bgPr>
+  </p:bg>
   <p:cSld name="Content with Caption">
     <p:spTree>
       <p:nvGrpSpPr>
@@ -2343,6 +2423,14 @@
 
 <file path=ppt/slideLayouts/slideLayout9.xml><?xml version="1.0" encoding="utf-8"?>
 <p:sldLayout xmlns:a="http://schemas.openxmlformats.org/drawingml/2006/main" xmlns:r="http://schemas.openxmlformats.org/officeDocument/2006/relationships" xmlns:p="http://schemas.openxmlformats.org/presentationml/2006/main" type="picTx" preserve="1">
+  <p:bg>
+    <p:bgPr>
+      <a:solidFill>
+        <a:srgbClr val="1C1C1C"/>
+      </a:solidFill>
+      <a:effectLst/>
+    </p:bgPr>
+  </p:bg>
   <p:cSld name="Picture with Caption">
     <p:spTree>
       <p:nvGrpSpPr>
@@ -2598,9 +2686,12 @@
 <p:sldMaster xmlns:a="http://schemas.openxmlformats.org/drawingml/2006/main" xmlns:r="http://schemas.openxmlformats.org/officeDocument/2006/relationships" xmlns:p="http://schemas.openxmlformats.org/presentationml/2006/main">
   <p:cSld>
     <p:bg>
-      <p:bgRef idx="1001">
-        <a:schemeClr val="bg1"/>
-      </p:bgRef>
+      <p:bgPr>
+        <a:solidFill>
+          <a:srgbClr val="1C1C1C"/>
+        </a:solidFill>
+        <a:effectLst/>
+      </p:bgPr>
     </p:bg>
     <p:spTree>
       <p:nvGrpSpPr>
@@ -2837,7 +2928,7 @@
       </p:ext>
     </p:extLst>
   </p:cSld>
-  <p:clrMap bg1="lt1" tx1="dk1" bg2="lt2" tx2="dk2" accent1="accent1" accent2="accent2" accent3="accent3" accent4="accent4" accent5="accent5" accent6="accent6" hlink="hlink" folHlink="folHlink"/>
+  <p:clrMap bg1="dk1" tx1="dk1" bg2="lt2" tx2="dk2" accent1="accent1" accent2="accent2" accent3="accent3" accent4="accent4" accent5="accent5" accent6="accent6" hlink="hlink" folHlink="folHlink"/>
   <p:sldLayoutIdLst>
     <p:sldLayoutId id="2147483649" r:id="rId1"/>
     <p:sldLayoutId id="2147483650" r:id="rId2"/>
@@ -14324,13 +14415,13 @@
         <a:sysClr val="window" lastClr="FFFFFF"/>
       </a:lt1>
       <a:dk2>
-        <a:srgbClr val="1F497D"/>
+        <a:srgbClr val="252525"/>
       </a:dk2>
       <a:lt2>
         <a:srgbClr val="EEECE1"/>
       </a:lt2>
       <a:accent1>
-        <a:srgbClr val="4F81BD"/>
+        <a:srgbClr val="DA7756"/>
       </a:accent1>
       <a:accent2>
         <a:srgbClr val="C0504D"/>

</xml_diff>

<commit_message>
fix: inject fullscreen dark bg rectangle into every slide
Google Slides ignores <p:bgPr> solidFill. Workaround: insert
a full-slide Rectangle (id=9900 _BG_DARK_ fill=#1C1C1C,
noSelect/noMove/noResize) as first shape in every slide spTree.
Renders reliably in all PPTX viewers regardless of bg support.

Co-Authored-By: Claude Sonnet 4.6 <noreply@anthropic.com>
</commit_message>
<xml_diff>
--- a/00-01_han-ai/training-materials/course01_AI活用知識編.pptx
+++ b/00-01_han-ai/training-materials/course01_AI活用知識編.pptx
@@ -3213,6 +3213,35 @@
         <p:nvPr/>
       </p:nvGrpSpPr>
       <p:grpSpPr/>
+      <p:sp xmlns:a="http://schemas.openxmlformats.org/drawingml/2006/main" xmlns:p="http://schemas.openxmlformats.org/presentationml/2006/main">
+        <p:nvSpPr>
+          <p:cNvPr id="9900" name="_BG_DARK_"/>
+          <p:cNvSpPr>
+            <a:spLocks noSelect="1" noMove="1" noResize="1"/>
+          </p:cNvSpPr>
+          <p:nvPr/>
+        </p:nvSpPr>
+        <p:spPr>
+          <a:xfrm>
+            <a:off x="0" y="0"/>
+            <a:ext cx="9144000" cy="5143500"/>
+          </a:xfrm>
+          <a:prstGeom prst="rect">
+            <a:avLst/>
+          </a:prstGeom>
+          <a:solidFill>
+            <a:srgbClr val="1C1C1C"/>
+          </a:solidFill>
+          <a:ln>
+            <a:noFill/>
+          </a:ln>
+        </p:spPr>
+        <p:txBody>
+          <a:bodyPr/>
+          <a:lstStyle/>
+          <a:p/>
+        </p:txBody>
+      </p:sp>
       <p:sp>
         <p:nvSpPr>
           <p:cNvPr id="2" name="Rectangle 1"/>
@@ -3452,6 +3481,35 @@
         <p:nvPr/>
       </p:nvGrpSpPr>
       <p:grpSpPr/>
+      <p:sp xmlns:a="http://schemas.openxmlformats.org/drawingml/2006/main" xmlns:p="http://schemas.openxmlformats.org/presentationml/2006/main">
+        <p:nvSpPr>
+          <p:cNvPr id="9900" name="_BG_DARK_"/>
+          <p:cNvSpPr>
+            <a:spLocks noSelect="1" noMove="1" noResize="1"/>
+          </p:cNvSpPr>
+          <p:nvPr/>
+        </p:nvSpPr>
+        <p:spPr>
+          <a:xfrm>
+            <a:off x="0" y="0"/>
+            <a:ext cx="9144000" cy="5143500"/>
+          </a:xfrm>
+          <a:prstGeom prst="rect">
+            <a:avLst/>
+          </a:prstGeom>
+          <a:solidFill>
+            <a:srgbClr val="1C1C1C"/>
+          </a:solidFill>
+          <a:ln>
+            <a:noFill/>
+          </a:ln>
+        </p:spPr>
+        <p:txBody>
+          <a:bodyPr/>
+          <a:lstStyle/>
+          <a:p/>
+        </p:txBody>
+      </p:sp>
       <p:sp>
         <p:nvSpPr>
           <p:cNvPr id="2" name="Rectangle 1"/>
@@ -4144,6 +4202,35 @@
         <p:nvPr/>
       </p:nvGrpSpPr>
       <p:grpSpPr/>
+      <p:sp xmlns:a="http://schemas.openxmlformats.org/drawingml/2006/main" xmlns:p="http://schemas.openxmlformats.org/presentationml/2006/main">
+        <p:nvSpPr>
+          <p:cNvPr id="9900" name="_BG_DARK_"/>
+          <p:cNvSpPr>
+            <a:spLocks noSelect="1" noMove="1" noResize="1"/>
+          </p:cNvSpPr>
+          <p:nvPr/>
+        </p:nvSpPr>
+        <p:spPr>
+          <a:xfrm>
+            <a:off x="0" y="0"/>
+            <a:ext cx="9144000" cy="5143500"/>
+          </a:xfrm>
+          <a:prstGeom prst="rect">
+            <a:avLst/>
+          </a:prstGeom>
+          <a:solidFill>
+            <a:srgbClr val="1C1C1C"/>
+          </a:solidFill>
+          <a:ln>
+            <a:noFill/>
+          </a:ln>
+        </p:spPr>
+        <p:txBody>
+          <a:bodyPr/>
+          <a:lstStyle/>
+          <a:p/>
+        </p:txBody>
+      </p:sp>
       <p:sp>
         <p:nvSpPr>
           <p:cNvPr id="2" name="Rectangle 1"/>
@@ -4349,6 +4436,35 @@
         <p:nvPr/>
       </p:nvGrpSpPr>
       <p:grpSpPr/>
+      <p:sp xmlns:a="http://schemas.openxmlformats.org/drawingml/2006/main" xmlns:p="http://schemas.openxmlformats.org/presentationml/2006/main">
+        <p:nvSpPr>
+          <p:cNvPr id="9900" name="_BG_DARK_"/>
+          <p:cNvSpPr>
+            <a:spLocks noSelect="1" noMove="1" noResize="1"/>
+          </p:cNvSpPr>
+          <p:nvPr/>
+        </p:nvSpPr>
+        <p:spPr>
+          <a:xfrm>
+            <a:off x="0" y="0"/>
+            <a:ext cx="9144000" cy="5143500"/>
+          </a:xfrm>
+          <a:prstGeom prst="rect">
+            <a:avLst/>
+          </a:prstGeom>
+          <a:solidFill>
+            <a:srgbClr val="1C1C1C"/>
+          </a:solidFill>
+          <a:ln>
+            <a:noFill/>
+          </a:ln>
+        </p:spPr>
+        <p:txBody>
+          <a:bodyPr/>
+          <a:lstStyle/>
+          <a:p/>
+        </p:txBody>
+      </p:sp>
       <p:sp>
         <p:nvSpPr>
           <p:cNvPr id="2" name="Rectangle 1"/>
@@ -4857,6 +4973,35 @@
         <p:nvPr/>
       </p:nvGrpSpPr>
       <p:grpSpPr/>
+      <p:sp xmlns:a="http://schemas.openxmlformats.org/drawingml/2006/main" xmlns:p="http://schemas.openxmlformats.org/presentationml/2006/main">
+        <p:nvSpPr>
+          <p:cNvPr id="9900" name="_BG_DARK_"/>
+          <p:cNvSpPr>
+            <a:spLocks noSelect="1" noMove="1" noResize="1"/>
+          </p:cNvSpPr>
+          <p:nvPr/>
+        </p:nvSpPr>
+        <p:spPr>
+          <a:xfrm>
+            <a:off x="0" y="0"/>
+            <a:ext cx="9144000" cy="5143500"/>
+          </a:xfrm>
+          <a:prstGeom prst="rect">
+            <a:avLst/>
+          </a:prstGeom>
+          <a:solidFill>
+            <a:srgbClr val="1C1C1C"/>
+          </a:solidFill>
+          <a:ln>
+            <a:noFill/>
+          </a:ln>
+        </p:spPr>
+        <p:txBody>
+          <a:bodyPr/>
+          <a:lstStyle/>
+          <a:p/>
+        </p:txBody>
+      </p:sp>
       <p:sp>
         <p:nvSpPr>
           <p:cNvPr id="2" name="Rectangle 1"/>
@@ -5438,6 +5583,35 @@
         <p:nvPr/>
       </p:nvGrpSpPr>
       <p:grpSpPr/>
+      <p:sp xmlns:a="http://schemas.openxmlformats.org/drawingml/2006/main" xmlns:p="http://schemas.openxmlformats.org/presentationml/2006/main">
+        <p:nvSpPr>
+          <p:cNvPr id="9900" name="_BG_DARK_"/>
+          <p:cNvSpPr>
+            <a:spLocks noSelect="1" noMove="1" noResize="1"/>
+          </p:cNvSpPr>
+          <p:nvPr/>
+        </p:nvSpPr>
+        <p:spPr>
+          <a:xfrm>
+            <a:off x="0" y="0"/>
+            <a:ext cx="9144000" cy="5143500"/>
+          </a:xfrm>
+          <a:prstGeom prst="rect">
+            <a:avLst/>
+          </a:prstGeom>
+          <a:solidFill>
+            <a:srgbClr val="1C1C1C"/>
+          </a:solidFill>
+          <a:ln>
+            <a:noFill/>
+          </a:ln>
+        </p:spPr>
+        <p:txBody>
+          <a:bodyPr/>
+          <a:lstStyle/>
+          <a:p/>
+        </p:txBody>
+      </p:sp>
       <p:sp>
         <p:nvSpPr>
           <p:cNvPr id="2" name="Rectangle 1"/>
@@ -6141,6 +6315,35 @@
         <p:nvPr/>
       </p:nvGrpSpPr>
       <p:grpSpPr/>
+      <p:sp xmlns:a="http://schemas.openxmlformats.org/drawingml/2006/main" xmlns:p="http://schemas.openxmlformats.org/presentationml/2006/main">
+        <p:nvSpPr>
+          <p:cNvPr id="9900" name="_BG_DARK_"/>
+          <p:cNvSpPr>
+            <a:spLocks noSelect="1" noMove="1" noResize="1"/>
+          </p:cNvSpPr>
+          <p:nvPr/>
+        </p:nvSpPr>
+        <p:spPr>
+          <a:xfrm>
+            <a:off x="0" y="0"/>
+            <a:ext cx="9144000" cy="5143500"/>
+          </a:xfrm>
+          <a:prstGeom prst="rect">
+            <a:avLst/>
+          </a:prstGeom>
+          <a:solidFill>
+            <a:srgbClr val="1C1C1C"/>
+          </a:solidFill>
+          <a:ln>
+            <a:noFill/>
+          </a:ln>
+        </p:spPr>
+        <p:txBody>
+          <a:bodyPr/>
+          <a:lstStyle/>
+          <a:p/>
+        </p:txBody>
+      </p:sp>
       <p:sp>
         <p:nvSpPr>
           <p:cNvPr id="2" name="Rectangle 1"/>
@@ -6995,6 +7198,35 @@
         <p:nvPr/>
       </p:nvGrpSpPr>
       <p:grpSpPr/>
+      <p:sp xmlns:a="http://schemas.openxmlformats.org/drawingml/2006/main" xmlns:p="http://schemas.openxmlformats.org/presentationml/2006/main">
+        <p:nvSpPr>
+          <p:cNvPr id="9900" name="_BG_DARK_"/>
+          <p:cNvSpPr>
+            <a:spLocks noSelect="1" noMove="1" noResize="1"/>
+          </p:cNvSpPr>
+          <p:nvPr/>
+        </p:nvSpPr>
+        <p:spPr>
+          <a:xfrm>
+            <a:off x="0" y="0"/>
+            <a:ext cx="9144000" cy="5143500"/>
+          </a:xfrm>
+          <a:prstGeom prst="rect">
+            <a:avLst/>
+          </a:prstGeom>
+          <a:solidFill>
+            <a:srgbClr val="1C1C1C"/>
+          </a:solidFill>
+          <a:ln>
+            <a:noFill/>
+          </a:ln>
+        </p:spPr>
+        <p:txBody>
+          <a:bodyPr/>
+          <a:lstStyle/>
+          <a:p/>
+        </p:txBody>
+      </p:sp>
       <p:sp>
         <p:nvSpPr>
           <p:cNvPr id="2" name="Rectangle 1"/>
@@ -7200,6 +7432,35 @@
         <p:nvPr/>
       </p:nvGrpSpPr>
       <p:grpSpPr/>
+      <p:sp xmlns:a="http://schemas.openxmlformats.org/drawingml/2006/main" xmlns:p="http://schemas.openxmlformats.org/presentationml/2006/main">
+        <p:nvSpPr>
+          <p:cNvPr id="9900" name="_BG_DARK_"/>
+          <p:cNvSpPr>
+            <a:spLocks noSelect="1" noMove="1" noResize="1"/>
+          </p:cNvSpPr>
+          <p:nvPr/>
+        </p:nvSpPr>
+        <p:spPr>
+          <a:xfrm>
+            <a:off x="0" y="0"/>
+            <a:ext cx="9144000" cy="5143500"/>
+          </a:xfrm>
+          <a:prstGeom prst="rect">
+            <a:avLst/>
+          </a:prstGeom>
+          <a:solidFill>
+            <a:srgbClr val="1C1C1C"/>
+          </a:solidFill>
+          <a:ln>
+            <a:noFill/>
+          </a:ln>
+        </p:spPr>
+        <p:txBody>
+          <a:bodyPr/>
+          <a:lstStyle/>
+          <a:p/>
+        </p:txBody>
+      </p:sp>
       <p:sp>
         <p:nvSpPr>
           <p:cNvPr id="2" name="Rectangle 1"/>
@@ -7572,6 +7833,35 @@
         <p:nvPr/>
       </p:nvGrpSpPr>
       <p:grpSpPr/>
+      <p:sp xmlns:a="http://schemas.openxmlformats.org/drawingml/2006/main" xmlns:p="http://schemas.openxmlformats.org/presentationml/2006/main">
+        <p:nvSpPr>
+          <p:cNvPr id="9900" name="_BG_DARK_"/>
+          <p:cNvSpPr>
+            <a:spLocks noSelect="1" noMove="1" noResize="1"/>
+          </p:cNvSpPr>
+          <p:nvPr/>
+        </p:nvSpPr>
+        <p:spPr>
+          <a:xfrm>
+            <a:off x="0" y="0"/>
+            <a:ext cx="9144000" cy="5143500"/>
+          </a:xfrm>
+          <a:prstGeom prst="rect">
+            <a:avLst/>
+          </a:prstGeom>
+          <a:solidFill>
+            <a:srgbClr val="1C1C1C"/>
+          </a:solidFill>
+          <a:ln>
+            <a:noFill/>
+          </a:ln>
+        </p:spPr>
+        <p:txBody>
+          <a:bodyPr/>
+          <a:lstStyle/>
+          <a:p/>
+        </p:txBody>
+      </p:sp>
       <p:sp>
         <p:nvSpPr>
           <p:cNvPr id="2" name="Rectangle 1"/>
@@ -8149,6 +8439,35 @@
         <p:nvPr/>
       </p:nvGrpSpPr>
       <p:grpSpPr/>
+      <p:sp xmlns:a="http://schemas.openxmlformats.org/drawingml/2006/main" xmlns:p="http://schemas.openxmlformats.org/presentationml/2006/main">
+        <p:nvSpPr>
+          <p:cNvPr id="9900" name="_BG_DARK_"/>
+          <p:cNvSpPr>
+            <a:spLocks noSelect="1" noMove="1" noResize="1"/>
+          </p:cNvSpPr>
+          <p:nvPr/>
+        </p:nvSpPr>
+        <p:spPr>
+          <a:xfrm>
+            <a:off x="0" y="0"/>
+            <a:ext cx="9144000" cy="5143500"/>
+          </a:xfrm>
+          <a:prstGeom prst="rect">
+            <a:avLst/>
+          </a:prstGeom>
+          <a:solidFill>
+            <a:srgbClr val="1C1C1C"/>
+          </a:solidFill>
+          <a:ln>
+            <a:noFill/>
+          </a:ln>
+        </p:spPr>
+        <p:txBody>
+          <a:bodyPr/>
+          <a:lstStyle/>
+          <a:p/>
+        </p:txBody>
+      </p:sp>
       <p:sp>
         <p:nvSpPr>
           <p:cNvPr id="2" name="Rectangle 1"/>
@@ -8531,6 +8850,35 @@
         <p:nvPr/>
       </p:nvGrpSpPr>
       <p:grpSpPr/>
+      <p:sp xmlns:a="http://schemas.openxmlformats.org/drawingml/2006/main" xmlns:p="http://schemas.openxmlformats.org/presentationml/2006/main">
+        <p:nvSpPr>
+          <p:cNvPr id="9900" name="_BG_DARK_"/>
+          <p:cNvSpPr>
+            <a:spLocks noSelect="1" noMove="1" noResize="1"/>
+          </p:cNvSpPr>
+          <p:nvPr/>
+        </p:nvSpPr>
+        <p:spPr>
+          <a:xfrm>
+            <a:off x="0" y="0"/>
+            <a:ext cx="9144000" cy="5143500"/>
+          </a:xfrm>
+          <a:prstGeom prst="rect">
+            <a:avLst/>
+          </a:prstGeom>
+          <a:solidFill>
+            <a:srgbClr val="1C1C1C"/>
+          </a:solidFill>
+          <a:ln>
+            <a:noFill/>
+          </a:ln>
+        </p:spPr>
+        <p:txBody>
+          <a:bodyPr/>
+          <a:lstStyle/>
+          <a:p/>
+        </p:txBody>
+      </p:sp>
       <p:sp>
         <p:nvSpPr>
           <p:cNvPr id="2" name="Rectangle 1"/>
@@ -9223,6 +9571,35 @@
         <p:nvPr/>
       </p:nvGrpSpPr>
       <p:grpSpPr/>
+      <p:sp xmlns:a="http://schemas.openxmlformats.org/drawingml/2006/main" xmlns:p="http://schemas.openxmlformats.org/presentationml/2006/main">
+        <p:nvSpPr>
+          <p:cNvPr id="9900" name="_BG_DARK_"/>
+          <p:cNvSpPr>
+            <a:spLocks noSelect="1" noMove="1" noResize="1"/>
+          </p:cNvSpPr>
+          <p:nvPr/>
+        </p:nvSpPr>
+        <p:spPr>
+          <a:xfrm>
+            <a:off x="0" y="0"/>
+            <a:ext cx="9144000" cy="5143500"/>
+          </a:xfrm>
+          <a:prstGeom prst="rect">
+            <a:avLst/>
+          </a:prstGeom>
+          <a:solidFill>
+            <a:srgbClr val="1C1C1C"/>
+          </a:solidFill>
+          <a:ln>
+            <a:noFill/>
+          </a:ln>
+        </p:spPr>
+        <p:txBody>
+          <a:bodyPr/>
+          <a:lstStyle/>
+          <a:p/>
+        </p:txBody>
+      </p:sp>
       <p:sp>
         <p:nvSpPr>
           <p:cNvPr id="2" name="Rectangle 1"/>
@@ -9428,6 +9805,35 @@
         <p:nvPr/>
       </p:nvGrpSpPr>
       <p:grpSpPr/>
+      <p:sp xmlns:a="http://schemas.openxmlformats.org/drawingml/2006/main" xmlns:p="http://schemas.openxmlformats.org/presentationml/2006/main">
+        <p:nvSpPr>
+          <p:cNvPr id="9900" name="_BG_DARK_"/>
+          <p:cNvSpPr>
+            <a:spLocks noSelect="1" noMove="1" noResize="1"/>
+          </p:cNvSpPr>
+          <p:nvPr/>
+        </p:nvSpPr>
+        <p:spPr>
+          <a:xfrm>
+            <a:off x="0" y="0"/>
+            <a:ext cx="9144000" cy="5143500"/>
+          </a:xfrm>
+          <a:prstGeom prst="rect">
+            <a:avLst/>
+          </a:prstGeom>
+          <a:solidFill>
+            <a:srgbClr val="1C1C1C"/>
+          </a:solidFill>
+          <a:ln>
+            <a:noFill/>
+          </a:ln>
+        </p:spPr>
+        <p:txBody>
+          <a:bodyPr/>
+          <a:lstStyle/>
+          <a:p/>
+        </p:txBody>
+      </p:sp>
       <p:sp>
         <p:nvSpPr>
           <p:cNvPr id="2" name="Rectangle 1"/>
@@ -9949,6 +10355,35 @@
         <p:nvPr/>
       </p:nvGrpSpPr>
       <p:grpSpPr/>
+      <p:sp xmlns:a="http://schemas.openxmlformats.org/drawingml/2006/main" xmlns:p="http://schemas.openxmlformats.org/presentationml/2006/main">
+        <p:nvSpPr>
+          <p:cNvPr id="9900" name="_BG_DARK_"/>
+          <p:cNvSpPr>
+            <a:spLocks noSelect="1" noMove="1" noResize="1"/>
+          </p:cNvSpPr>
+          <p:nvPr/>
+        </p:nvSpPr>
+        <p:spPr>
+          <a:xfrm>
+            <a:off x="0" y="0"/>
+            <a:ext cx="9144000" cy="5143500"/>
+          </a:xfrm>
+          <a:prstGeom prst="rect">
+            <a:avLst/>
+          </a:prstGeom>
+          <a:solidFill>
+            <a:srgbClr val="1C1C1C"/>
+          </a:solidFill>
+          <a:ln>
+            <a:noFill/>
+          </a:ln>
+        </p:spPr>
+        <p:txBody>
+          <a:bodyPr/>
+          <a:lstStyle/>
+          <a:p/>
+        </p:txBody>
+      </p:sp>
       <p:sp>
         <p:nvSpPr>
           <p:cNvPr id="2" name="Rectangle 1"/>
@@ -10310,6 +10745,35 @@
         <p:nvPr/>
       </p:nvGrpSpPr>
       <p:grpSpPr/>
+      <p:sp xmlns:a="http://schemas.openxmlformats.org/drawingml/2006/main" xmlns:p="http://schemas.openxmlformats.org/presentationml/2006/main">
+        <p:nvSpPr>
+          <p:cNvPr id="9900" name="_BG_DARK_"/>
+          <p:cNvSpPr>
+            <a:spLocks noSelect="1" noMove="1" noResize="1"/>
+          </p:cNvSpPr>
+          <p:nvPr/>
+        </p:nvSpPr>
+        <p:spPr>
+          <a:xfrm>
+            <a:off x="0" y="0"/>
+            <a:ext cx="9144000" cy="5143500"/>
+          </a:xfrm>
+          <a:prstGeom prst="rect">
+            <a:avLst/>
+          </a:prstGeom>
+          <a:solidFill>
+            <a:srgbClr val="1C1C1C"/>
+          </a:solidFill>
+          <a:ln>
+            <a:noFill/>
+          </a:ln>
+        </p:spPr>
+        <p:txBody>
+          <a:bodyPr/>
+          <a:lstStyle/>
+          <a:p/>
+        </p:txBody>
+      </p:sp>
       <p:sp>
         <p:nvSpPr>
           <p:cNvPr id="2" name="Rectangle 1"/>
@@ -10728,6 +11192,35 @@
         <p:nvPr/>
       </p:nvGrpSpPr>
       <p:grpSpPr/>
+      <p:sp xmlns:a="http://schemas.openxmlformats.org/drawingml/2006/main" xmlns:p="http://schemas.openxmlformats.org/presentationml/2006/main">
+        <p:nvSpPr>
+          <p:cNvPr id="9900" name="_BG_DARK_"/>
+          <p:cNvSpPr>
+            <a:spLocks noSelect="1" noMove="1" noResize="1"/>
+          </p:cNvSpPr>
+          <p:nvPr/>
+        </p:nvSpPr>
+        <p:spPr>
+          <a:xfrm>
+            <a:off x="0" y="0"/>
+            <a:ext cx="9144000" cy="5143500"/>
+          </a:xfrm>
+          <a:prstGeom prst="rect">
+            <a:avLst/>
+          </a:prstGeom>
+          <a:solidFill>
+            <a:srgbClr val="1C1C1C"/>
+          </a:solidFill>
+          <a:ln>
+            <a:noFill/>
+          </a:ln>
+        </p:spPr>
+        <p:txBody>
+          <a:bodyPr/>
+          <a:lstStyle/>
+          <a:p/>
+        </p:txBody>
+      </p:sp>
       <p:sp>
         <p:nvSpPr>
           <p:cNvPr id="2" name="Rectangle 1"/>
@@ -10933,6 +11426,35 @@
         <p:nvPr/>
       </p:nvGrpSpPr>
       <p:grpSpPr/>
+      <p:sp xmlns:a="http://schemas.openxmlformats.org/drawingml/2006/main" xmlns:p="http://schemas.openxmlformats.org/presentationml/2006/main">
+        <p:nvSpPr>
+          <p:cNvPr id="9900" name="_BG_DARK_"/>
+          <p:cNvSpPr>
+            <a:spLocks noSelect="1" noMove="1" noResize="1"/>
+          </p:cNvSpPr>
+          <p:nvPr/>
+        </p:nvSpPr>
+        <p:spPr>
+          <a:xfrm>
+            <a:off x="0" y="0"/>
+            <a:ext cx="9144000" cy="5143500"/>
+          </a:xfrm>
+          <a:prstGeom prst="rect">
+            <a:avLst/>
+          </a:prstGeom>
+          <a:solidFill>
+            <a:srgbClr val="1C1C1C"/>
+          </a:solidFill>
+          <a:ln>
+            <a:noFill/>
+          </a:ln>
+        </p:spPr>
+        <p:txBody>
+          <a:bodyPr/>
+          <a:lstStyle/>
+          <a:p/>
+        </p:txBody>
+      </p:sp>
       <p:sp>
         <p:nvSpPr>
           <p:cNvPr id="2" name="Rectangle 1"/>
@@ -11557,6 +12079,35 @@
         <p:nvPr/>
       </p:nvGrpSpPr>
       <p:grpSpPr/>
+      <p:sp xmlns:a="http://schemas.openxmlformats.org/drawingml/2006/main" xmlns:p="http://schemas.openxmlformats.org/presentationml/2006/main">
+        <p:nvSpPr>
+          <p:cNvPr id="9900" name="_BG_DARK_"/>
+          <p:cNvSpPr>
+            <a:spLocks noSelect="1" noMove="1" noResize="1"/>
+          </p:cNvSpPr>
+          <p:nvPr/>
+        </p:nvSpPr>
+        <p:spPr>
+          <a:xfrm>
+            <a:off x="0" y="0"/>
+            <a:ext cx="9144000" cy="5143500"/>
+          </a:xfrm>
+          <a:prstGeom prst="rect">
+            <a:avLst/>
+          </a:prstGeom>
+          <a:solidFill>
+            <a:srgbClr val="1C1C1C"/>
+          </a:solidFill>
+          <a:ln>
+            <a:noFill/>
+          </a:ln>
+        </p:spPr>
+        <p:txBody>
+          <a:bodyPr/>
+          <a:lstStyle/>
+          <a:p/>
+        </p:txBody>
+      </p:sp>
       <p:sp>
         <p:nvSpPr>
           <p:cNvPr id="2" name="Rectangle 1"/>
@@ -11762,6 +12313,35 @@
         <p:nvPr/>
       </p:nvGrpSpPr>
       <p:grpSpPr/>
+      <p:sp xmlns:a="http://schemas.openxmlformats.org/drawingml/2006/main" xmlns:p="http://schemas.openxmlformats.org/presentationml/2006/main">
+        <p:nvSpPr>
+          <p:cNvPr id="9900" name="_BG_DARK_"/>
+          <p:cNvSpPr>
+            <a:spLocks noSelect="1" noMove="1" noResize="1"/>
+          </p:cNvSpPr>
+          <p:nvPr/>
+        </p:nvSpPr>
+        <p:spPr>
+          <a:xfrm>
+            <a:off x="0" y="0"/>
+            <a:ext cx="9144000" cy="5143500"/>
+          </a:xfrm>
+          <a:prstGeom prst="rect">
+            <a:avLst/>
+          </a:prstGeom>
+          <a:solidFill>
+            <a:srgbClr val="1C1C1C"/>
+          </a:solidFill>
+          <a:ln>
+            <a:noFill/>
+          </a:ln>
+        </p:spPr>
+        <p:txBody>
+          <a:bodyPr/>
+          <a:lstStyle/>
+          <a:p/>
+        </p:txBody>
+      </p:sp>
       <p:sp>
         <p:nvSpPr>
           <p:cNvPr id="2" name="Rectangle 1"/>
@@ -12169,6 +12749,35 @@
         <p:nvPr/>
       </p:nvGrpSpPr>
       <p:grpSpPr/>
+      <p:sp xmlns:a="http://schemas.openxmlformats.org/drawingml/2006/main" xmlns:p="http://schemas.openxmlformats.org/presentationml/2006/main">
+        <p:nvSpPr>
+          <p:cNvPr id="9900" name="_BG_DARK_"/>
+          <p:cNvSpPr>
+            <a:spLocks noSelect="1" noMove="1" noResize="1"/>
+          </p:cNvSpPr>
+          <p:nvPr/>
+        </p:nvSpPr>
+        <p:spPr>
+          <a:xfrm>
+            <a:off x="0" y="0"/>
+            <a:ext cx="9144000" cy="5143500"/>
+          </a:xfrm>
+          <a:prstGeom prst="rect">
+            <a:avLst/>
+          </a:prstGeom>
+          <a:solidFill>
+            <a:srgbClr val="1C1C1C"/>
+          </a:solidFill>
+          <a:ln>
+            <a:noFill/>
+          </a:ln>
+        </p:spPr>
+        <p:txBody>
+          <a:bodyPr/>
+          <a:lstStyle/>
+          <a:p/>
+        </p:txBody>
+      </p:sp>
       <p:sp>
         <p:nvSpPr>
           <p:cNvPr id="2" name="Rectangle 1"/>
@@ -12374,6 +12983,35 @@
         <p:nvPr/>
       </p:nvGrpSpPr>
       <p:grpSpPr/>
+      <p:sp xmlns:a="http://schemas.openxmlformats.org/drawingml/2006/main" xmlns:p="http://schemas.openxmlformats.org/presentationml/2006/main">
+        <p:nvSpPr>
+          <p:cNvPr id="9900" name="_BG_DARK_"/>
+          <p:cNvSpPr>
+            <a:spLocks noSelect="1" noMove="1" noResize="1"/>
+          </p:cNvSpPr>
+          <p:nvPr/>
+        </p:nvSpPr>
+        <p:spPr>
+          <a:xfrm>
+            <a:off x="0" y="0"/>
+            <a:ext cx="9144000" cy="5143500"/>
+          </a:xfrm>
+          <a:prstGeom prst="rect">
+            <a:avLst/>
+          </a:prstGeom>
+          <a:solidFill>
+            <a:srgbClr val="1C1C1C"/>
+          </a:solidFill>
+          <a:ln>
+            <a:noFill/>
+          </a:ln>
+        </p:spPr>
+        <p:txBody>
+          <a:bodyPr/>
+          <a:lstStyle/>
+          <a:p/>
+        </p:txBody>
+      </p:sp>
       <p:sp>
         <p:nvSpPr>
           <p:cNvPr id="2" name="Rectangle 1"/>
@@ -12818,6 +13456,35 @@
         <p:nvPr/>
       </p:nvGrpSpPr>
       <p:grpSpPr/>
+      <p:sp xmlns:a="http://schemas.openxmlformats.org/drawingml/2006/main" xmlns:p="http://schemas.openxmlformats.org/presentationml/2006/main">
+        <p:nvSpPr>
+          <p:cNvPr id="9900" name="_BG_DARK_"/>
+          <p:cNvSpPr>
+            <a:spLocks noSelect="1" noMove="1" noResize="1"/>
+          </p:cNvSpPr>
+          <p:nvPr/>
+        </p:nvSpPr>
+        <p:spPr>
+          <a:xfrm>
+            <a:off x="0" y="0"/>
+            <a:ext cx="9144000" cy="5143500"/>
+          </a:xfrm>
+          <a:prstGeom prst="rect">
+            <a:avLst/>
+          </a:prstGeom>
+          <a:solidFill>
+            <a:srgbClr val="1C1C1C"/>
+          </a:solidFill>
+          <a:ln>
+            <a:noFill/>
+          </a:ln>
+        </p:spPr>
+        <p:txBody>
+          <a:bodyPr/>
+          <a:lstStyle/>
+          <a:p/>
+        </p:txBody>
+      </p:sp>
       <p:sp>
         <p:nvSpPr>
           <p:cNvPr id="2" name="Rectangle 1"/>
@@ -13215,6 +13882,35 @@
         <p:nvPr/>
       </p:nvGrpSpPr>
       <p:grpSpPr/>
+      <p:sp xmlns:a="http://schemas.openxmlformats.org/drawingml/2006/main" xmlns:p="http://schemas.openxmlformats.org/presentationml/2006/main">
+        <p:nvSpPr>
+          <p:cNvPr id="9900" name="_BG_DARK_"/>
+          <p:cNvSpPr>
+            <a:spLocks noSelect="1" noMove="1" noResize="1"/>
+          </p:cNvSpPr>
+          <p:nvPr/>
+        </p:nvSpPr>
+        <p:spPr>
+          <a:xfrm>
+            <a:off x="0" y="0"/>
+            <a:ext cx="9144000" cy="5143500"/>
+          </a:xfrm>
+          <a:prstGeom prst="rect">
+            <a:avLst/>
+          </a:prstGeom>
+          <a:solidFill>
+            <a:srgbClr val="1C1C1C"/>
+          </a:solidFill>
+          <a:ln>
+            <a:noFill/>
+          </a:ln>
+        </p:spPr>
+        <p:txBody>
+          <a:bodyPr/>
+          <a:lstStyle/>
+          <a:p/>
+        </p:txBody>
+      </p:sp>
       <p:sp>
         <p:nvSpPr>
           <p:cNvPr id="2" name="Rectangle 1"/>
@@ -13420,6 +14116,35 @@
         <p:nvPr/>
       </p:nvGrpSpPr>
       <p:grpSpPr/>
+      <p:sp xmlns:a="http://schemas.openxmlformats.org/drawingml/2006/main" xmlns:p="http://schemas.openxmlformats.org/presentationml/2006/main">
+        <p:nvSpPr>
+          <p:cNvPr id="9900" name="_BG_DARK_"/>
+          <p:cNvSpPr>
+            <a:spLocks noSelect="1" noMove="1" noResize="1"/>
+          </p:cNvSpPr>
+          <p:nvPr/>
+        </p:nvSpPr>
+        <p:spPr>
+          <a:xfrm>
+            <a:off x="0" y="0"/>
+            <a:ext cx="9144000" cy="5143500"/>
+          </a:xfrm>
+          <a:prstGeom prst="rect">
+            <a:avLst/>
+          </a:prstGeom>
+          <a:solidFill>
+            <a:srgbClr val="1C1C1C"/>
+          </a:solidFill>
+          <a:ln>
+            <a:noFill/>
+          </a:ln>
+        </p:spPr>
+        <p:txBody>
+          <a:bodyPr/>
+          <a:lstStyle/>
+          <a:p/>
+        </p:txBody>
+      </p:sp>
       <p:sp>
         <p:nvSpPr>
           <p:cNvPr id="2" name="Rectangle 1"/>
@@ -13845,6 +14570,35 @@
         <p:nvPr/>
       </p:nvGrpSpPr>
       <p:grpSpPr/>
+      <p:sp xmlns:a="http://schemas.openxmlformats.org/drawingml/2006/main" xmlns:p="http://schemas.openxmlformats.org/presentationml/2006/main">
+        <p:nvSpPr>
+          <p:cNvPr id="9900" name="_BG_DARK_"/>
+          <p:cNvSpPr>
+            <a:spLocks noSelect="1" noMove="1" noResize="1"/>
+          </p:cNvSpPr>
+          <p:nvPr/>
+        </p:nvSpPr>
+        <p:spPr>
+          <a:xfrm>
+            <a:off x="0" y="0"/>
+            <a:ext cx="9144000" cy="5143500"/>
+          </a:xfrm>
+          <a:prstGeom prst="rect">
+            <a:avLst/>
+          </a:prstGeom>
+          <a:solidFill>
+            <a:srgbClr val="1C1C1C"/>
+          </a:solidFill>
+          <a:ln>
+            <a:noFill/>
+          </a:ln>
+        </p:spPr>
+        <p:txBody>
+          <a:bodyPr/>
+          <a:lstStyle/>
+          <a:p/>
+        </p:txBody>
+      </p:sp>
       <p:sp>
         <p:nvSpPr>
           <p:cNvPr id="2" name="Rectangle 1"/>
@@ -14217,6 +14971,35 @@
         <p:nvPr/>
       </p:nvGrpSpPr>
       <p:grpSpPr/>
+      <p:sp xmlns:a="http://schemas.openxmlformats.org/drawingml/2006/main" xmlns:p="http://schemas.openxmlformats.org/presentationml/2006/main">
+        <p:nvSpPr>
+          <p:cNvPr id="9900" name="_BG_DARK_"/>
+          <p:cNvSpPr>
+            <a:spLocks noSelect="1" noMove="1" noResize="1"/>
+          </p:cNvSpPr>
+          <p:nvPr/>
+        </p:nvSpPr>
+        <p:spPr>
+          <a:xfrm>
+            <a:off x="0" y="0"/>
+            <a:ext cx="9144000" cy="5143500"/>
+          </a:xfrm>
+          <a:prstGeom prst="rect">
+            <a:avLst/>
+          </a:prstGeom>
+          <a:solidFill>
+            <a:srgbClr val="1C1C1C"/>
+          </a:solidFill>
+          <a:ln>
+            <a:noFill/>
+          </a:ln>
+        </p:spPr>
+        <p:txBody>
+          <a:bodyPr/>
+          <a:lstStyle/>
+          <a:p/>
+        </p:txBody>
+      </p:sp>
       <p:sp>
         <p:nvSpPr>
           <p:cNvPr id="2" name="Rectangle 1"/>

</xml_diff>

<commit_message>
fix: rebuild pptx with clean bg rect (remove duplicate, fix xmlns, add p:style)
</commit_message>
<xml_diff>
--- a/00-01_han-ai/training-materials/course01_AI活用知識編.pptx
+++ b/00-01_han-ai/training-materials/course01_AI活用知識編.pptx
@@ -3213,12 +3213,10 @@
         <p:nvPr/>
       </p:nvGrpSpPr>
       <p:grpSpPr/>
-      <p:sp xmlns:a="http://schemas.openxmlformats.org/drawingml/2006/main" xmlns:p="http://schemas.openxmlformats.org/presentationml/2006/main">
+      <p:sp>
         <p:nvSpPr>
           <p:cNvPr id="9900" name="_BG_DARK_"/>
-          <p:cNvSpPr>
-            <a:spLocks noSelect="1" noMove="1" noResize="1"/>
-          </p:cNvSpPr>
+          <p:cNvSpPr/>
           <p:nvPr/>
         </p:nvSpPr>
         <p:spPr>
@@ -3236,6 +3234,20 @@
             <a:noFill/>
           </a:ln>
         </p:spPr>
+        <p:style>
+          <a:lnRef idx="1">
+            <a:srgbClr val="1C1C1C"/>
+          </a:lnRef>
+          <a:fillRef idx="1">
+            <a:srgbClr val="1C1C1C"/>
+          </a:fillRef>
+          <a:effectRef idx="0">
+            <a:srgbClr val="1C1C1C"/>
+          </a:effectRef>
+          <a:fontRef idx="minor">
+            <a:srgbClr val="EEEEEE"/>
+          </a:fontRef>
+        </p:style>
         <p:txBody>
           <a:bodyPr/>
           <a:lstStyle/>
@@ -3481,12 +3493,10 @@
         <p:nvPr/>
       </p:nvGrpSpPr>
       <p:grpSpPr/>
-      <p:sp xmlns:a="http://schemas.openxmlformats.org/drawingml/2006/main" xmlns:p="http://schemas.openxmlformats.org/presentationml/2006/main">
+      <p:sp>
         <p:nvSpPr>
           <p:cNvPr id="9900" name="_BG_DARK_"/>
-          <p:cNvSpPr>
-            <a:spLocks noSelect="1" noMove="1" noResize="1"/>
-          </p:cNvSpPr>
+          <p:cNvSpPr/>
           <p:nvPr/>
         </p:nvSpPr>
         <p:spPr>
@@ -3504,6 +3514,20 @@
             <a:noFill/>
           </a:ln>
         </p:spPr>
+        <p:style>
+          <a:lnRef idx="1">
+            <a:srgbClr val="1C1C1C"/>
+          </a:lnRef>
+          <a:fillRef idx="1">
+            <a:srgbClr val="1C1C1C"/>
+          </a:fillRef>
+          <a:effectRef idx="0">
+            <a:srgbClr val="1C1C1C"/>
+          </a:effectRef>
+          <a:fontRef idx="minor">
+            <a:srgbClr val="EEEEEE"/>
+          </a:fontRef>
+        </p:style>
         <p:txBody>
           <a:bodyPr/>
           <a:lstStyle/>
@@ -4202,12 +4226,10 @@
         <p:nvPr/>
       </p:nvGrpSpPr>
       <p:grpSpPr/>
-      <p:sp xmlns:a="http://schemas.openxmlformats.org/drawingml/2006/main" xmlns:p="http://schemas.openxmlformats.org/presentationml/2006/main">
+      <p:sp>
         <p:nvSpPr>
           <p:cNvPr id="9900" name="_BG_DARK_"/>
-          <p:cNvSpPr>
-            <a:spLocks noSelect="1" noMove="1" noResize="1"/>
-          </p:cNvSpPr>
+          <p:cNvSpPr/>
           <p:nvPr/>
         </p:nvSpPr>
         <p:spPr>
@@ -4225,6 +4247,20 @@
             <a:noFill/>
           </a:ln>
         </p:spPr>
+        <p:style>
+          <a:lnRef idx="1">
+            <a:srgbClr val="1C1C1C"/>
+          </a:lnRef>
+          <a:fillRef idx="1">
+            <a:srgbClr val="1C1C1C"/>
+          </a:fillRef>
+          <a:effectRef idx="0">
+            <a:srgbClr val="1C1C1C"/>
+          </a:effectRef>
+          <a:fontRef idx="minor">
+            <a:srgbClr val="EEEEEE"/>
+          </a:fontRef>
+        </p:style>
         <p:txBody>
           <a:bodyPr/>
           <a:lstStyle/>
@@ -4436,12 +4472,10 @@
         <p:nvPr/>
       </p:nvGrpSpPr>
       <p:grpSpPr/>
-      <p:sp xmlns:a="http://schemas.openxmlformats.org/drawingml/2006/main" xmlns:p="http://schemas.openxmlformats.org/presentationml/2006/main">
+      <p:sp>
         <p:nvSpPr>
           <p:cNvPr id="9900" name="_BG_DARK_"/>
-          <p:cNvSpPr>
-            <a:spLocks noSelect="1" noMove="1" noResize="1"/>
-          </p:cNvSpPr>
+          <p:cNvSpPr/>
           <p:nvPr/>
         </p:nvSpPr>
         <p:spPr>
@@ -4459,6 +4493,20 @@
             <a:noFill/>
           </a:ln>
         </p:spPr>
+        <p:style>
+          <a:lnRef idx="1">
+            <a:srgbClr val="1C1C1C"/>
+          </a:lnRef>
+          <a:fillRef idx="1">
+            <a:srgbClr val="1C1C1C"/>
+          </a:fillRef>
+          <a:effectRef idx="0">
+            <a:srgbClr val="1C1C1C"/>
+          </a:effectRef>
+          <a:fontRef idx="minor">
+            <a:srgbClr val="EEEEEE"/>
+          </a:fontRef>
+        </p:style>
         <p:txBody>
           <a:bodyPr/>
           <a:lstStyle/>
@@ -4973,12 +5021,10 @@
         <p:nvPr/>
       </p:nvGrpSpPr>
       <p:grpSpPr/>
-      <p:sp xmlns:a="http://schemas.openxmlformats.org/drawingml/2006/main" xmlns:p="http://schemas.openxmlformats.org/presentationml/2006/main">
+      <p:sp>
         <p:nvSpPr>
           <p:cNvPr id="9900" name="_BG_DARK_"/>
-          <p:cNvSpPr>
-            <a:spLocks noSelect="1" noMove="1" noResize="1"/>
-          </p:cNvSpPr>
+          <p:cNvSpPr/>
           <p:nvPr/>
         </p:nvSpPr>
         <p:spPr>
@@ -4996,6 +5042,20 @@
             <a:noFill/>
           </a:ln>
         </p:spPr>
+        <p:style>
+          <a:lnRef idx="1">
+            <a:srgbClr val="1C1C1C"/>
+          </a:lnRef>
+          <a:fillRef idx="1">
+            <a:srgbClr val="1C1C1C"/>
+          </a:fillRef>
+          <a:effectRef idx="0">
+            <a:srgbClr val="1C1C1C"/>
+          </a:effectRef>
+          <a:fontRef idx="minor">
+            <a:srgbClr val="EEEEEE"/>
+          </a:fontRef>
+        </p:style>
         <p:txBody>
           <a:bodyPr/>
           <a:lstStyle/>
@@ -5583,12 +5643,10 @@
         <p:nvPr/>
       </p:nvGrpSpPr>
       <p:grpSpPr/>
-      <p:sp xmlns:a="http://schemas.openxmlformats.org/drawingml/2006/main" xmlns:p="http://schemas.openxmlformats.org/presentationml/2006/main">
+      <p:sp>
         <p:nvSpPr>
           <p:cNvPr id="9900" name="_BG_DARK_"/>
-          <p:cNvSpPr>
-            <a:spLocks noSelect="1" noMove="1" noResize="1"/>
-          </p:cNvSpPr>
+          <p:cNvSpPr/>
           <p:nvPr/>
         </p:nvSpPr>
         <p:spPr>
@@ -5606,6 +5664,20 @@
             <a:noFill/>
           </a:ln>
         </p:spPr>
+        <p:style>
+          <a:lnRef idx="1">
+            <a:srgbClr val="1C1C1C"/>
+          </a:lnRef>
+          <a:fillRef idx="1">
+            <a:srgbClr val="1C1C1C"/>
+          </a:fillRef>
+          <a:effectRef idx="0">
+            <a:srgbClr val="1C1C1C"/>
+          </a:effectRef>
+          <a:fontRef idx="minor">
+            <a:srgbClr val="EEEEEE"/>
+          </a:fontRef>
+        </p:style>
         <p:txBody>
           <a:bodyPr/>
           <a:lstStyle/>
@@ -6315,12 +6387,10 @@
         <p:nvPr/>
       </p:nvGrpSpPr>
       <p:grpSpPr/>
-      <p:sp xmlns:a="http://schemas.openxmlformats.org/drawingml/2006/main" xmlns:p="http://schemas.openxmlformats.org/presentationml/2006/main">
+      <p:sp>
         <p:nvSpPr>
           <p:cNvPr id="9900" name="_BG_DARK_"/>
-          <p:cNvSpPr>
-            <a:spLocks noSelect="1" noMove="1" noResize="1"/>
-          </p:cNvSpPr>
+          <p:cNvSpPr/>
           <p:nvPr/>
         </p:nvSpPr>
         <p:spPr>
@@ -6338,6 +6408,20 @@
             <a:noFill/>
           </a:ln>
         </p:spPr>
+        <p:style>
+          <a:lnRef idx="1">
+            <a:srgbClr val="1C1C1C"/>
+          </a:lnRef>
+          <a:fillRef idx="1">
+            <a:srgbClr val="1C1C1C"/>
+          </a:fillRef>
+          <a:effectRef idx="0">
+            <a:srgbClr val="1C1C1C"/>
+          </a:effectRef>
+          <a:fontRef idx="minor">
+            <a:srgbClr val="EEEEEE"/>
+          </a:fontRef>
+        </p:style>
         <p:txBody>
           <a:bodyPr/>
           <a:lstStyle/>
@@ -7198,12 +7282,10 @@
         <p:nvPr/>
       </p:nvGrpSpPr>
       <p:grpSpPr/>
-      <p:sp xmlns:a="http://schemas.openxmlformats.org/drawingml/2006/main" xmlns:p="http://schemas.openxmlformats.org/presentationml/2006/main">
+      <p:sp>
         <p:nvSpPr>
           <p:cNvPr id="9900" name="_BG_DARK_"/>
-          <p:cNvSpPr>
-            <a:spLocks noSelect="1" noMove="1" noResize="1"/>
-          </p:cNvSpPr>
+          <p:cNvSpPr/>
           <p:nvPr/>
         </p:nvSpPr>
         <p:spPr>
@@ -7221,6 +7303,20 @@
             <a:noFill/>
           </a:ln>
         </p:spPr>
+        <p:style>
+          <a:lnRef idx="1">
+            <a:srgbClr val="1C1C1C"/>
+          </a:lnRef>
+          <a:fillRef idx="1">
+            <a:srgbClr val="1C1C1C"/>
+          </a:fillRef>
+          <a:effectRef idx="0">
+            <a:srgbClr val="1C1C1C"/>
+          </a:effectRef>
+          <a:fontRef idx="minor">
+            <a:srgbClr val="EEEEEE"/>
+          </a:fontRef>
+        </p:style>
         <p:txBody>
           <a:bodyPr/>
           <a:lstStyle/>
@@ -7432,12 +7528,10 @@
         <p:nvPr/>
       </p:nvGrpSpPr>
       <p:grpSpPr/>
-      <p:sp xmlns:a="http://schemas.openxmlformats.org/drawingml/2006/main" xmlns:p="http://schemas.openxmlformats.org/presentationml/2006/main">
+      <p:sp>
         <p:nvSpPr>
           <p:cNvPr id="9900" name="_BG_DARK_"/>
-          <p:cNvSpPr>
-            <a:spLocks noSelect="1" noMove="1" noResize="1"/>
-          </p:cNvSpPr>
+          <p:cNvSpPr/>
           <p:nvPr/>
         </p:nvSpPr>
         <p:spPr>
@@ -7455,6 +7549,20 @@
             <a:noFill/>
           </a:ln>
         </p:spPr>
+        <p:style>
+          <a:lnRef idx="1">
+            <a:srgbClr val="1C1C1C"/>
+          </a:lnRef>
+          <a:fillRef idx="1">
+            <a:srgbClr val="1C1C1C"/>
+          </a:fillRef>
+          <a:effectRef idx="0">
+            <a:srgbClr val="1C1C1C"/>
+          </a:effectRef>
+          <a:fontRef idx="minor">
+            <a:srgbClr val="EEEEEE"/>
+          </a:fontRef>
+        </p:style>
         <p:txBody>
           <a:bodyPr/>
           <a:lstStyle/>
@@ -7833,12 +7941,10 @@
         <p:nvPr/>
       </p:nvGrpSpPr>
       <p:grpSpPr/>
-      <p:sp xmlns:a="http://schemas.openxmlformats.org/drawingml/2006/main" xmlns:p="http://schemas.openxmlformats.org/presentationml/2006/main">
+      <p:sp>
         <p:nvSpPr>
           <p:cNvPr id="9900" name="_BG_DARK_"/>
-          <p:cNvSpPr>
-            <a:spLocks noSelect="1" noMove="1" noResize="1"/>
-          </p:cNvSpPr>
+          <p:cNvSpPr/>
           <p:nvPr/>
         </p:nvSpPr>
         <p:spPr>
@@ -7856,6 +7962,20 @@
             <a:noFill/>
           </a:ln>
         </p:spPr>
+        <p:style>
+          <a:lnRef idx="1">
+            <a:srgbClr val="1C1C1C"/>
+          </a:lnRef>
+          <a:fillRef idx="1">
+            <a:srgbClr val="1C1C1C"/>
+          </a:fillRef>
+          <a:effectRef idx="0">
+            <a:srgbClr val="1C1C1C"/>
+          </a:effectRef>
+          <a:fontRef idx="minor">
+            <a:srgbClr val="EEEEEE"/>
+          </a:fontRef>
+        </p:style>
         <p:txBody>
           <a:bodyPr/>
           <a:lstStyle/>
@@ -8439,12 +8559,10 @@
         <p:nvPr/>
       </p:nvGrpSpPr>
       <p:grpSpPr/>
-      <p:sp xmlns:a="http://schemas.openxmlformats.org/drawingml/2006/main" xmlns:p="http://schemas.openxmlformats.org/presentationml/2006/main">
+      <p:sp>
         <p:nvSpPr>
           <p:cNvPr id="9900" name="_BG_DARK_"/>
-          <p:cNvSpPr>
-            <a:spLocks noSelect="1" noMove="1" noResize="1"/>
-          </p:cNvSpPr>
+          <p:cNvSpPr/>
           <p:nvPr/>
         </p:nvSpPr>
         <p:spPr>
@@ -8462,6 +8580,20 @@
             <a:noFill/>
           </a:ln>
         </p:spPr>
+        <p:style>
+          <a:lnRef idx="1">
+            <a:srgbClr val="1C1C1C"/>
+          </a:lnRef>
+          <a:fillRef idx="1">
+            <a:srgbClr val="1C1C1C"/>
+          </a:fillRef>
+          <a:effectRef idx="0">
+            <a:srgbClr val="1C1C1C"/>
+          </a:effectRef>
+          <a:fontRef idx="minor">
+            <a:srgbClr val="EEEEEE"/>
+          </a:fontRef>
+        </p:style>
         <p:txBody>
           <a:bodyPr/>
           <a:lstStyle/>
@@ -8850,12 +8982,10 @@
         <p:nvPr/>
       </p:nvGrpSpPr>
       <p:grpSpPr/>
-      <p:sp xmlns:a="http://schemas.openxmlformats.org/drawingml/2006/main" xmlns:p="http://schemas.openxmlformats.org/presentationml/2006/main">
+      <p:sp>
         <p:nvSpPr>
           <p:cNvPr id="9900" name="_BG_DARK_"/>
-          <p:cNvSpPr>
-            <a:spLocks noSelect="1" noMove="1" noResize="1"/>
-          </p:cNvSpPr>
+          <p:cNvSpPr/>
           <p:nvPr/>
         </p:nvSpPr>
         <p:spPr>
@@ -8873,6 +9003,20 @@
             <a:noFill/>
           </a:ln>
         </p:spPr>
+        <p:style>
+          <a:lnRef idx="1">
+            <a:srgbClr val="1C1C1C"/>
+          </a:lnRef>
+          <a:fillRef idx="1">
+            <a:srgbClr val="1C1C1C"/>
+          </a:fillRef>
+          <a:effectRef idx="0">
+            <a:srgbClr val="1C1C1C"/>
+          </a:effectRef>
+          <a:fontRef idx="minor">
+            <a:srgbClr val="EEEEEE"/>
+          </a:fontRef>
+        </p:style>
         <p:txBody>
           <a:bodyPr/>
           <a:lstStyle/>
@@ -9571,12 +9715,10 @@
         <p:nvPr/>
       </p:nvGrpSpPr>
       <p:grpSpPr/>
-      <p:sp xmlns:a="http://schemas.openxmlformats.org/drawingml/2006/main" xmlns:p="http://schemas.openxmlformats.org/presentationml/2006/main">
+      <p:sp>
         <p:nvSpPr>
           <p:cNvPr id="9900" name="_BG_DARK_"/>
-          <p:cNvSpPr>
-            <a:spLocks noSelect="1" noMove="1" noResize="1"/>
-          </p:cNvSpPr>
+          <p:cNvSpPr/>
           <p:nvPr/>
         </p:nvSpPr>
         <p:spPr>
@@ -9594,6 +9736,20 @@
             <a:noFill/>
           </a:ln>
         </p:spPr>
+        <p:style>
+          <a:lnRef idx="1">
+            <a:srgbClr val="1C1C1C"/>
+          </a:lnRef>
+          <a:fillRef idx="1">
+            <a:srgbClr val="1C1C1C"/>
+          </a:fillRef>
+          <a:effectRef idx="0">
+            <a:srgbClr val="1C1C1C"/>
+          </a:effectRef>
+          <a:fontRef idx="minor">
+            <a:srgbClr val="EEEEEE"/>
+          </a:fontRef>
+        </p:style>
         <p:txBody>
           <a:bodyPr/>
           <a:lstStyle/>
@@ -9805,12 +9961,10 @@
         <p:nvPr/>
       </p:nvGrpSpPr>
       <p:grpSpPr/>
-      <p:sp xmlns:a="http://schemas.openxmlformats.org/drawingml/2006/main" xmlns:p="http://schemas.openxmlformats.org/presentationml/2006/main">
+      <p:sp>
         <p:nvSpPr>
           <p:cNvPr id="9900" name="_BG_DARK_"/>
-          <p:cNvSpPr>
-            <a:spLocks noSelect="1" noMove="1" noResize="1"/>
-          </p:cNvSpPr>
+          <p:cNvSpPr/>
           <p:nvPr/>
         </p:nvSpPr>
         <p:spPr>
@@ -9828,6 +9982,20 @@
             <a:noFill/>
           </a:ln>
         </p:spPr>
+        <p:style>
+          <a:lnRef idx="1">
+            <a:srgbClr val="1C1C1C"/>
+          </a:lnRef>
+          <a:fillRef idx="1">
+            <a:srgbClr val="1C1C1C"/>
+          </a:fillRef>
+          <a:effectRef idx="0">
+            <a:srgbClr val="1C1C1C"/>
+          </a:effectRef>
+          <a:fontRef idx="minor">
+            <a:srgbClr val="EEEEEE"/>
+          </a:fontRef>
+        </p:style>
         <p:txBody>
           <a:bodyPr/>
           <a:lstStyle/>
@@ -10355,12 +10523,10 @@
         <p:nvPr/>
       </p:nvGrpSpPr>
       <p:grpSpPr/>
-      <p:sp xmlns:a="http://schemas.openxmlformats.org/drawingml/2006/main" xmlns:p="http://schemas.openxmlformats.org/presentationml/2006/main">
+      <p:sp>
         <p:nvSpPr>
           <p:cNvPr id="9900" name="_BG_DARK_"/>
-          <p:cNvSpPr>
-            <a:spLocks noSelect="1" noMove="1" noResize="1"/>
-          </p:cNvSpPr>
+          <p:cNvSpPr/>
           <p:nvPr/>
         </p:nvSpPr>
         <p:spPr>
@@ -10378,6 +10544,20 @@
             <a:noFill/>
           </a:ln>
         </p:spPr>
+        <p:style>
+          <a:lnRef idx="1">
+            <a:srgbClr val="1C1C1C"/>
+          </a:lnRef>
+          <a:fillRef idx="1">
+            <a:srgbClr val="1C1C1C"/>
+          </a:fillRef>
+          <a:effectRef idx="0">
+            <a:srgbClr val="1C1C1C"/>
+          </a:effectRef>
+          <a:fontRef idx="minor">
+            <a:srgbClr val="EEEEEE"/>
+          </a:fontRef>
+        </p:style>
         <p:txBody>
           <a:bodyPr/>
           <a:lstStyle/>
@@ -10745,12 +10925,10 @@
         <p:nvPr/>
       </p:nvGrpSpPr>
       <p:grpSpPr/>
-      <p:sp xmlns:a="http://schemas.openxmlformats.org/drawingml/2006/main" xmlns:p="http://schemas.openxmlformats.org/presentationml/2006/main">
+      <p:sp>
         <p:nvSpPr>
           <p:cNvPr id="9900" name="_BG_DARK_"/>
-          <p:cNvSpPr>
-            <a:spLocks noSelect="1" noMove="1" noResize="1"/>
-          </p:cNvSpPr>
+          <p:cNvSpPr/>
           <p:nvPr/>
         </p:nvSpPr>
         <p:spPr>
@@ -10768,6 +10946,20 @@
             <a:noFill/>
           </a:ln>
         </p:spPr>
+        <p:style>
+          <a:lnRef idx="1">
+            <a:srgbClr val="1C1C1C"/>
+          </a:lnRef>
+          <a:fillRef idx="1">
+            <a:srgbClr val="1C1C1C"/>
+          </a:fillRef>
+          <a:effectRef idx="0">
+            <a:srgbClr val="1C1C1C"/>
+          </a:effectRef>
+          <a:fontRef idx="minor">
+            <a:srgbClr val="EEEEEE"/>
+          </a:fontRef>
+        </p:style>
         <p:txBody>
           <a:bodyPr/>
           <a:lstStyle/>
@@ -11192,12 +11384,10 @@
         <p:nvPr/>
       </p:nvGrpSpPr>
       <p:grpSpPr/>
-      <p:sp xmlns:a="http://schemas.openxmlformats.org/drawingml/2006/main" xmlns:p="http://schemas.openxmlformats.org/presentationml/2006/main">
+      <p:sp>
         <p:nvSpPr>
           <p:cNvPr id="9900" name="_BG_DARK_"/>
-          <p:cNvSpPr>
-            <a:spLocks noSelect="1" noMove="1" noResize="1"/>
-          </p:cNvSpPr>
+          <p:cNvSpPr/>
           <p:nvPr/>
         </p:nvSpPr>
         <p:spPr>
@@ -11215,6 +11405,20 @@
             <a:noFill/>
           </a:ln>
         </p:spPr>
+        <p:style>
+          <a:lnRef idx="1">
+            <a:srgbClr val="1C1C1C"/>
+          </a:lnRef>
+          <a:fillRef idx="1">
+            <a:srgbClr val="1C1C1C"/>
+          </a:fillRef>
+          <a:effectRef idx="0">
+            <a:srgbClr val="1C1C1C"/>
+          </a:effectRef>
+          <a:fontRef idx="minor">
+            <a:srgbClr val="EEEEEE"/>
+          </a:fontRef>
+        </p:style>
         <p:txBody>
           <a:bodyPr/>
           <a:lstStyle/>
@@ -11426,12 +11630,10 @@
         <p:nvPr/>
       </p:nvGrpSpPr>
       <p:grpSpPr/>
-      <p:sp xmlns:a="http://schemas.openxmlformats.org/drawingml/2006/main" xmlns:p="http://schemas.openxmlformats.org/presentationml/2006/main">
+      <p:sp>
         <p:nvSpPr>
           <p:cNvPr id="9900" name="_BG_DARK_"/>
-          <p:cNvSpPr>
-            <a:spLocks noSelect="1" noMove="1" noResize="1"/>
-          </p:cNvSpPr>
+          <p:cNvSpPr/>
           <p:nvPr/>
         </p:nvSpPr>
         <p:spPr>
@@ -11449,6 +11651,20 @@
             <a:noFill/>
           </a:ln>
         </p:spPr>
+        <p:style>
+          <a:lnRef idx="1">
+            <a:srgbClr val="1C1C1C"/>
+          </a:lnRef>
+          <a:fillRef idx="1">
+            <a:srgbClr val="1C1C1C"/>
+          </a:fillRef>
+          <a:effectRef idx="0">
+            <a:srgbClr val="1C1C1C"/>
+          </a:effectRef>
+          <a:fontRef idx="minor">
+            <a:srgbClr val="EEEEEE"/>
+          </a:fontRef>
+        </p:style>
         <p:txBody>
           <a:bodyPr/>
           <a:lstStyle/>
@@ -12079,12 +12295,10 @@
         <p:nvPr/>
       </p:nvGrpSpPr>
       <p:grpSpPr/>
-      <p:sp xmlns:a="http://schemas.openxmlformats.org/drawingml/2006/main" xmlns:p="http://schemas.openxmlformats.org/presentationml/2006/main">
+      <p:sp>
         <p:nvSpPr>
           <p:cNvPr id="9900" name="_BG_DARK_"/>
-          <p:cNvSpPr>
-            <a:spLocks noSelect="1" noMove="1" noResize="1"/>
-          </p:cNvSpPr>
+          <p:cNvSpPr/>
           <p:nvPr/>
         </p:nvSpPr>
         <p:spPr>
@@ -12102,6 +12316,20 @@
             <a:noFill/>
           </a:ln>
         </p:spPr>
+        <p:style>
+          <a:lnRef idx="1">
+            <a:srgbClr val="1C1C1C"/>
+          </a:lnRef>
+          <a:fillRef idx="1">
+            <a:srgbClr val="1C1C1C"/>
+          </a:fillRef>
+          <a:effectRef idx="0">
+            <a:srgbClr val="1C1C1C"/>
+          </a:effectRef>
+          <a:fontRef idx="minor">
+            <a:srgbClr val="EEEEEE"/>
+          </a:fontRef>
+        </p:style>
         <p:txBody>
           <a:bodyPr/>
           <a:lstStyle/>
@@ -12313,12 +12541,10 @@
         <p:nvPr/>
       </p:nvGrpSpPr>
       <p:grpSpPr/>
-      <p:sp xmlns:a="http://schemas.openxmlformats.org/drawingml/2006/main" xmlns:p="http://schemas.openxmlformats.org/presentationml/2006/main">
+      <p:sp>
         <p:nvSpPr>
           <p:cNvPr id="9900" name="_BG_DARK_"/>
-          <p:cNvSpPr>
-            <a:spLocks noSelect="1" noMove="1" noResize="1"/>
-          </p:cNvSpPr>
+          <p:cNvSpPr/>
           <p:nvPr/>
         </p:nvSpPr>
         <p:spPr>
@@ -12336,6 +12562,20 @@
             <a:noFill/>
           </a:ln>
         </p:spPr>
+        <p:style>
+          <a:lnRef idx="1">
+            <a:srgbClr val="1C1C1C"/>
+          </a:lnRef>
+          <a:fillRef idx="1">
+            <a:srgbClr val="1C1C1C"/>
+          </a:fillRef>
+          <a:effectRef idx="0">
+            <a:srgbClr val="1C1C1C"/>
+          </a:effectRef>
+          <a:fontRef idx="minor">
+            <a:srgbClr val="EEEEEE"/>
+          </a:fontRef>
+        </p:style>
         <p:txBody>
           <a:bodyPr/>
           <a:lstStyle/>
@@ -12749,12 +12989,10 @@
         <p:nvPr/>
       </p:nvGrpSpPr>
       <p:grpSpPr/>
-      <p:sp xmlns:a="http://schemas.openxmlformats.org/drawingml/2006/main" xmlns:p="http://schemas.openxmlformats.org/presentationml/2006/main">
+      <p:sp>
         <p:nvSpPr>
           <p:cNvPr id="9900" name="_BG_DARK_"/>
-          <p:cNvSpPr>
-            <a:spLocks noSelect="1" noMove="1" noResize="1"/>
-          </p:cNvSpPr>
+          <p:cNvSpPr/>
           <p:nvPr/>
         </p:nvSpPr>
         <p:spPr>
@@ -12772,6 +13010,20 @@
             <a:noFill/>
           </a:ln>
         </p:spPr>
+        <p:style>
+          <a:lnRef idx="1">
+            <a:srgbClr val="1C1C1C"/>
+          </a:lnRef>
+          <a:fillRef idx="1">
+            <a:srgbClr val="1C1C1C"/>
+          </a:fillRef>
+          <a:effectRef idx="0">
+            <a:srgbClr val="1C1C1C"/>
+          </a:effectRef>
+          <a:fontRef idx="minor">
+            <a:srgbClr val="EEEEEE"/>
+          </a:fontRef>
+        </p:style>
         <p:txBody>
           <a:bodyPr/>
           <a:lstStyle/>
@@ -12983,12 +13235,10 @@
         <p:nvPr/>
       </p:nvGrpSpPr>
       <p:grpSpPr/>
-      <p:sp xmlns:a="http://schemas.openxmlformats.org/drawingml/2006/main" xmlns:p="http://schemas.openxmlformats.org/presentationml/2006/main">
+      <p:sp>
         <p:nvSpPr>
           <p:cNvPr id="9900" name="_BG_DARK_"/>
-          <p:cNvSpPr>
-            <a:spLocks noSelect="1" noMove="1" noResize="1"/>
-          </p:cNvSpPr>
+          <p:cNvSpPr/>
           <p:nvPr/>
         </p:nvSpPr>
         <p:spPr>
@@ -13006,6 +13256,20 @@
             <a:noFill/>
           </a:ln>
         </p:spPr>
+        <p:style>
+          <a:lnRef idx="1">
+            <a:srgbClr val="1C1C1C"/>
+          </a:lnRef>
+          <a:fillRef idx="1">
+            <a:srgbClr val="1C1C1C"/>
+          </a:fillRef>
+          <a:effectRef idx="0">
+            <a:srgbClr val="1C1C1C"/>
+          </a:effectRef>
+          <a:fontRef idx="minor">
+            <a:srgbClr val="EEEEEE"/>
+          </a:fontRef>
+        </p:style>
         <p:txBody>
           <a:bodyPr/>
           <a:lstStyle/>
@@ -13456,12 +13720,10 @@
         <p:nvPr/>
       </p:nvGrpSpPr>
       <p:grpSpPr/>
-      <p:sp xmlns:a="http://schemas.openxmlformats.org/drawingml/2006/main" xmlns:p="http://schemas.openxmlformats.org/presentationml/2006/main">
+      <p:sp>
         <p:nvSpPr>
           <p:cNvPr id="9900" name="_BG_DARK_"/>
-          <p:cNvSpPr>
-            <a:spLocks noSelect="1" noMove="1" noResize="1"/>
-          </p:cNvSpPr>
+          <p:cNvSpPr/>
           <p:nvPr/>
         </p:nvSpPr>
         <p:spPr>
@@ -13479,6 +13741,20 @@
             <a:noFill/>
           </a:ln>
         </p:spPr>
+        <p:style>
+          <a:lnRef idx="1">
+            <a:srgbClr val="1C1C1C"/>
+          </a:lnRef>
+          <a:fillRef idx="1">
+            <a:srgbClr val="1C1C1C"/>
+          </a:fillRef>
+          <a:effectRef idx="0">
+            <a:srgbClr val="1C1C1C"/>
+          </a:effectRef>
+          <a:fontRef idx="minor">
+            <a:srgbClr val="EEEEEE"/>
+          </a:fontRef>
+        </p:style>
         <p:txBody>
           <a:bodyPr/>
           <a:lstStyle/>
@@ -13882,12 +14158,10 @@
         <p:nvPr/>
       </p:nvGrpSpPr>
       <p:grpSpPr/>
-      <p:sp xmlns:a="http://schemas.openxmlformats.org/drawingml/2006/main" xmlns:p="http://schemas.openxmlformats.org/presentationml/2006/main">
+      <p:sp>
         <p:nvSpPr>
           <p:cNvPr id="9900" name="_BG_DARK_"/>
-          <p:cNvSpPr>
-            <a:spLocks noSelect="1" noMove="1" noResize="1"/>
-          </p:cNvSpPr>
+          <p:cNvSpPr/>
           <p:nvPr/>
         </p:nvSpPr>
         <p:spPr>
@@ -13905,6 +14179,20 @@
             <a:noFill/>
           </a:ln>
         </p:spPr>
+        <p:style>
+          <a:lnRef idx="1">
+            <a:srgbClr val="1C1C1C"/>
+          </a:lnRef>
+          <a:fillRef idx="1">
+            <a:srgbClr val="1C1C1C"/>
+          </a:fillRef>
+          <a:effectRef idx="0">
+            <a:srgbClr val="1C1C1C"/>
+          </a:effectRef>
+          <a:fontRef idx="minor">
+            <a:srgbClr val="EEEEEE"/>
+          </a:fontRef>
+        </p:style>
         <p:txBody>
           <a:bodyPr/>
           <a:lstStyle/>
@@ -14116,12 +14404,10 @@
         <p:nvPr/>
       </p:nvGrpSpPr>
       <p:grpSpPr/>
-      <p:sp xmlns:a="http://schemas.openxmlformats.org/drawingml/2006/main" xmlns:p="http://schemas.openxmlformats.org/presentationml/2006/main">
+      <p:sp>
         <p:nvSpPr>
           <p:cNvPr id="9900" name="_BG_DARK_"/>
-          <p:cNvSpPr>
-            <a:spLocks noSelect="1" noMove="1" noResize="1"/>
-          </p:cNvSpPr>
+          <p:cNvSpPr/>
           <p:nvPr/>
         </p:nvSpPr>
         <p:spPr>
@@ -14139,6 +14425,20 @@
             <a:noFill/>
           </a:ln>
         </p:spPr>
+        <p:style>
+          <a:lnRef idx="1">
+            <a:srgbClr val="1C1C1C"/>
+          </a:lnRef>
+          <a:fillRef idx="1">
+            <a:srgbClr val="1C1C1C"/>
+          </a:fillRef>
+          <a:effectRef idx="0">
+            <a:srgbClr val="1C1C1C"/>
+          </a:effectRef>
+          <a:fontRef idx="minor">
+            <a:srgbClr val="EEEEEE"/>
+          </a:fontRef>
+        </p:style>
         <p:txBody>
           <a:bodyPr/>
           <a:lstStyle/>
@@ -14570,12 +14870,10 @@
         <p:nvPr/>
       </p:nvGrpSpPr>
       <p:grpSpPr/>
-      <p:sp xmlns:a="http://schemas.openxmlformats.org/drawingml/2006/main" xmlns:p="http://schemas.openxmlformats.org/presentationml/2006/main">
+      <p:sp>
         <p:nvSpPr>
           <p:cNvPr id="9900" name="_BG_DARK_"/>
-          <p:cNvSpPr>
-            <a:spLocks noSelect="1" noMove="1" noResize="1"/>
-          </p:cNvSpPr>
+          <p:cNvSpPr/>
           <p:nvPr/>
         </p:nvSpPr>
         <p:spPr>
@@ -14593,6 +14891,20 @@
             <a:noFill/>
           </a:ln>
         </p:spPr>
+        <p:style>
+          <a:lnRef idx="1">
+            <a:srgbClr val="1C1C1C"/>
+          </a:lnRef>
+          <a:fillRef idx="1">
+            <a:srgbClr val="1C1C1C"/>
+          </a:fillRef>
+          <a:effectRef idx="0">
+            <a:srgbClr val="1C1C1C"/>
+          </a:effectRef>
+          <a:fontRef idx="minor">
+            <a:srgbClr val="EEEEEE"/>
+          </a:fontRef>
+        </p:style>
         <p:txBody>
           <a:bodyPr/>
           <a:lstStyle/>
@@ -14971,12 +15283,10 @@
         <p:nvPr/>
       </p:nvGrpSpPr>
       <p:grpSpPr/>
-      <p:sp xmlns:a="http://schemas.openxmlformats.org/drawingml/2006/main" xmlns:p="http://schemas.openxmlformats.org/presentationml/2006/main">
+      <p:sp>
         <p:nvSpPr>
           <p:cNvPr id="9900" name="_BG_DARK_"/>
-          <p:cNvSpPr>
-            <a:spLocks noSelect="1" noMove="1" noResize="1"/>
-          </p:cNvSpPr>
+          <p:cNvSpPr/>
           <p:nvPr/>
         </p:nvSpPr>
         <p:spPr>
@@ -14994,6 +15304,20 @@
             <a:noFill/>
           </a:ln>
         </p:spPr>
+        <p:style>
+          <a:lnRef idx="1">
+            <a:srgbClr val="1C1C1C"/>
+          </a:lnRef>
+          <a:fillRef idx="1">
+            <a:srgbClr val="1C1C1C"/>
+          </a:fillRef>
+          <a:effectRef idx="0">
+            <a:srgbClr val="1C1C1C"/>
+          </a:effectRef>
+          <a:fontRef idx="minor">
+            <a:srgbClr val="EEEEEE"/>
+          </a:fontRef>
+        </p:style>
         <p:txBody>
           <a:bodyPr/>
           <a:lstStyle/>

</xml_diff>